<commit_message>
Abschluss: konkrete Abschlussaufgabe statt "Heute habe ich gelernt" (8D Generalstände, CLAUDE.md)
Co-Authored-By: Claude Sonnet 5.5 <noreply@anthropic.com>
Claude-Session: https://claude.ai/code/session_01GXwmzpsaCraifErTDddPwN
</commit_message>
<xml_diff>
--- a/Geschichte_8D/Generalstaende/Praesentation_Generalstaende_8D.pptx
+++ b/Geschichte_8D/Generalstaende/Praesentation_Generalstaende_8D.pptx
@@ -1046,7 +1046,7 @@
           <a:p>
             <a:r>
               <a:rPr lang="en-US" dirty="0"/>
-              <a:t>Die Klasse prüft still die Lernziele (Folie 2). Dann schreibt jede und jeder in einem Satz: „Heute habe ich gelernt, …“. Beispiel: „… dass bei den Generalständen jeder Stand nur eine Stimme hatte und Klerus und Adel den Dritten Stand überstimmen konnten, obwohl er fast alle Menschen vertrat.“ Keine Antworten ins Plenum (außer ein bis zwei freiwillige).</a:t>
+              <a:t>Ansage: „Stifte liegen. Ihr hört nur zu. Schaut auf die Ziele. Jetzt arbeitet ihr allein. Die Aufgabe steht rechts.“ Die Klasse prüft zuerst still die Lernziele (Folie 2) und löst dann die Abschlussaufgabe im Heft. Erwartung 1: z. B. 1614 letzte Generalstände, 1788 Missernte oder 1787 Steuerplan scheitert, August 1788 König kündigt an, 5. Mai 1789 Eröffnung. Erwartung 2: Beim Abstimmen nach Ständen hat jeder Stand nur eine Stimme. Klerus und Adel haben zwei von drei Stimmen und stimmen sich ab, deshalb überstimmen sie den Dritten Stand (Bauern und Bürger), obwohl er fast alle Menschen vertritt. Stichprobe: Beim Durchgehen bei 4 bis 6 Heften unterschiedlichen Niveaus mitlesen, nicht kommentieren (unbenotet).</a:t>
             </a:r>
             <a:endParaRPr lang="en-US" dirty="0"/>
           </a:p>
@@ -8816,7 +8816,7 @@
                 <a:ea typeface="Cambria" pitchFamily="34" charset="-122"/>
                 <a:cs typeface="Cambria" pitchFamily="34" charset="-120"/>
               </a:rPr>
-              <a:t>Heute habe ich gelernt, …</a:t>
+              <a:t>Abschlussaufgabe: Das Wichtigste der Stunde</a:t>
             </a:r>
             <a:endParaRPr lang="en-US" sz="3400" dirty="0"/>
           </a:p>
@@ -8908,12 +8908,12 @@
         </p:nvSpPr>
         <p:spPr>
           <a:xfrm>
-            <a:off x="548640" y="1463040"/>
-            <a:ext cx="11109960" cy="960120"/>
+            <a:off x="548640" y="1417320"/>
+            <a:ext cx="11109960" cy="685800"/>
           </a:xfrm>
           <a:prstGeom prst="roundRect">
             <a:avLst>
-              <a:gd name="adj" fmla="val 7619"/>
+              <a:gd name="adj" fmla="val 10667"/>
             </a:avLst>
           </a:prstGeom>
           <a:solidFill>
@@ -8930,8 +8930,8 @@
         </p:nvSpPr>
         <p:spPr>
           <a:xfrm>
-            <a:off x="777240" y="1691640"/>
-            <a:ext cx="502920" cy="502920"/>
+            <a:off x="777240" y="1581912"/>
+            <a:ext cx="365760" cy="365760"/>
           </a:xfrm>
           <a:prstGeom prst="ellipse">
             <a:avLst/>
@@ -8955,8 +8955,8 @@
         </p:nvSpPr>
         <p:spPr>
           <a:xfrm>
-            <a:off x="1554480" y="1463040"/>
-            <a:ext cx="9875520" cy="960120"/>
+            <a:off x="1417320" y="1417320"/>
+            <a:ext cx="10058400" cy="685800"/>
           </a:xfrm>
           <a:prstGeom prst="rect">
             <a:avLst/>
@@ -8994,12 +8994,12 @@
         </p:nvSpPr>
         <p:spPr>
           <a:xfrm>
-            <a:off x="548640" y="2542032"/>
-            <a:ext cx="11109960" cy="960120"/>
+            <a:off x="548640" y="2194560"/>
+            <a:ext cx="11109960" cy="685800"/>
           </a:xfrm>
           <a:prstGeom prst="roundRect">
             <a:avLst>
-              <a:gd name="adj" fmla="val 7619"/>
+              <a:gd name="adj" fmla="val 10667"/>
             </a:avLst>
           </a:prstGeom>
           <a:solidFill>
@@ -9016,8 +9016,8 @@
         </p:nvSpPr>
         <p:spPr>
           <a:xfrm>
-            <a:off x="777240" y="2770632"/>
-            <a:ext cx="502920" cy="502920"/>
+            <a:off x="777240" y="2359152"/>
+            <a:ext cx="365760" cy="365760"/>
           </a:xfrm>
           <a:prstGeom prst="ellipse">
             <a:avLst/>
@@ -9041,8 +9041,8 @@
         </p:nvSpPr>
         <p:spPr>
           <a:xfrm>
-            <a:off x="1554480" y="2542032"/>
-            <a:ext cx="9875520" cy="960120"/>
+            <a:off x="1417320" y="2194560"/>
+            <a:ext cx="10058400" cy="685800"/>
           </a:xfrm>
           <a:prstGeom prst="rect">
             <a:avLst/>
@@ -9080,12 +9080,12 @@
         </p:nvSpPr>
         <p:spPr>
           <a:xfrm>
-            <a:off x="548640" y="3621024"/>
-            <a:ext cx="11109960" cy="960120"/>
+            <a:off x="548640" y="2971800"/>
+            <a:ext cx="11109960" cy="685800"/>
           </a:xfrm>
           <a:prstGeom prst="roundRect">
             <a:avLst>
-              <a:gd name="adj" fmla="val 7619"/>
+              <a:gd name="adj" fmla="val 10667"/>
             </a:avLst>
           </a:prstGeom>
           <a:solidFill>
@@ -9102,8 +9102,8 @@
         </p:nvSpPr>
         <p:spPr>
           <a:xfrm>
-            <a:off x="777240" y="3849624"/>
-            <a:ext cx="502920" cy="502920"/>
+            <a:off x="777240" y="3136392"/>
+            <a:ext cx="365760" cy="365760"/>
           </a:xfrm>
           <a:prstGeom prst="ellipse">
             <a:avLst/>
@@ -9127,8 +9127,8 @@
         </p:nvSpPr>
         <p:spPr>
           <a:xfrm>
-            <a:off x="1554480" y="3621024"/>
-            <a:ext cx="9875520" cy="960120"/>
+            <a:off x="1417320" y="2971800"/>
+            <a:ext cx="10058400" cy="685800"/>
           </a:xfrm>
           <a:prstGeom prst="rect">
             <a:avLst/>
@@ -9166,12 +9166,12 @@
         </p:nvSpPr>
         <p:spPr>
           <a:xfrm>
-            <a:off x="548640" y="4754880"/>
-            <a:ext cx="11109960" cy="822960"/>
+            <a:off x="548640" y="3840480"/>
+            <a:ext cx="11109960" cy="1737360"/>
           </a:xfrm>
           <a:prstGeom prst="roundRect">
             <a:avLst>
-              <a:gd name="adj" fmla="val 8889"/>
+              <a:gd name="adj" fmla="val 4211"/>
             </a:avLst>
           </a:prstGeom>
           <a:solidFill>
@@ -9188,8 +9188,8 @@
         </p:nvSpPr>
         <p:spPr>
           <a:xfrm>
-            <a:off x="822960" y="4754880"/>
-            <a:ext cx="10607040" cy="822960"/>
+            <a:off x="822960" y="3886200"/>
+            <a:ext cx="10607040" cy="365760"/>
           </a:xfrm>
           <a:prstGeom prst="rect">
             <a:avLst/>
@@ -9207,13 +9207,13 @@
             <a:r>
               <a:rPr lang="en-US" sz="2400" b="1" dirty="0">
                 <a:solidFill>
-                  <a:srgbClr val="FFFFFF"/>
+                  <a:srgbClr val="CADCFC"/>
                 </a:solidFill>
                 <a:latin typeface="Cambria" pitchFamily="34" charset="0"/>
                 <a:ea typeface="Cambria" pitchFamily="34" charset="-122"/>
                 <a:cs typeface="Cambria" pitchFamily="34" charset="-120"/>
               </a:rPr>
-              <a:t>Schreibe in einem Satz: „Heute habe ich gelernt, …“</a:t>
+              <a:t>Abschlussaufgabe</a:t>
             </a:r>
             <a:endParaRPr lang="en-US" sz="2400" dirty="0"/>
           </a:p>
@@ -9222,6 +9222,202 @@
       <p:sp>
         <p:nvSpPr>
           <p:cNvPr id="28" name="Shape 25"/>
+          <p:cNvSpPr/>
+          <p:nvPr/>
+        </p:nvSpPr>
+        <p:spPr>
+          <a:xfrm>
+            <a:off x="868680" y="4379976"/>
+            <a:ext cx="384048" cy="384048"/>
+          </a:xfrm>
+          <a:prstGeom prst="ellipse">
+            <a:avLst/>
+          </a:prstGeom>
+          <a:solidFill>
+            <a:srgbClr val="D9534F"/>
+          </a:solidFill>
+          <a:ln/>
+        </p:spPr>
+      </p:sp>
+      <p:sp>
+        <p:nvSpPr>
+          <p:cNvPr id="29" name="Text 26"/>
+          <p:cNvSpPr txBox="1"/>
+          <p:nvPr/>
+        </p:nvSpPr>
+        <p:spPr>
+          <a:xfrm>
+            <a:off x="868680" y="4379976"/>
+            <a:ext cx="384048" cy="384048"/>
+          </a:xfrm>
+          <a:prstGeom prst="rect">
+            <a:avLst/>
+          </a:prstGeom>
+          <a:noFill/>
+          <a:ln/>
+        </p:spPr>
+        <p:txBody>
+          <a:bodyPr wrap="square" lIns="0" tIns="0" rIns="0" bIns="0" rtlCol="0" anchor="ctr"/>
+          <a:lstStyle/>
+          <a:p>
+            <a:pPr algn="ctr" indent="0" marL="0">
+              <a:buNone/>
+            </a:pPr>
+            <a:r>
+              <a:rPr lang="en-US" sz="1800" b="1" dirty="0">
+                <a:solidFill>
+                  <a:srgbClr val="FFFFFF"/>
+                </a:solidFill>
+                <a:latin typeface="Calibri" pitchFamily="34" charset="0"/>
+                <a:ea typeface="Calibri" pitchFamily="34" charset="-122"/>
+                <a:cs typeface="Calibri" pitchFamily="34" charset="-120"/>
+              </a:rPr>
+              <a:t>1</a:t>
+            </a:r>
+            <a:endParaRPr lang="en-US" sz="1800" dirty="0"/>
+          </a:p>
+        </p:txBody>
+      </p:sp>
+      <p:sp>
+        <p:nvSpPr>
+          <p:cNvPr id="30" name="Text 27"/>
+          <p:cNvSpPr txBox="1"/>
+          <p:nvPr/>
+        </p:nvSpPr>
+        <p:spPr>
+          <a:xfrm>
+            <a:off x="1463040" y="4343400"/>
+            <a:ext cx="9966960" cy="457200"/>
+          </a:xfrm>
+          <a:prstGeom prst="rect">
+            <a:avLst/>
+          </a:prstGeom>
+          <a:noFill/>
+          <a:ln/>
+        </p:spPr>
+        <p:txBody>
+          <a:bodyPr wrap="square" lIns="0" tIns="0" rIns="0" bIns="0" rtlCol="0" anchor="ctr"/>
+          <a:lstStyle/>
+          <a:p>
+            <a:pPr indent="0" marL="0">
+              <a:buNone/>
+            </a:pPr>
+            <a:r>
+              <a:rPr lang="en-US" sz="2400" b="1" dirty="0">
+                <a:solidFill>
+                  <a:srgbClr val="FFFFFF"/>
+                </a:solidFill>
+                <a:latin typeface="Calibri" pitchFamily="34" charset="0"/>
+                <a:ea typeface="Calibri" pitchFamily="34" charset="-122"/>
+                <a:cs typeface="Calibri" pitchFamily="34" charset="-120"/>
+              </a:rPr>
+              <a:t>Nenne zwei Ereignisse bis zu den Generalständen, mit Jahr.</a:t>
+            </a:r>
+            <a:endParaRPr lang="en-US" sz="2400" dirty="0"/>
+          </a:p>
+        </p:txBody>
+      </p:sp>
+      <p:sp>
+        <p:nvSpPr>
+          <p:cNvPr id="31" name="Shape 28"/>
+          <p:cNvSpPr/>
+          <p:nvPr/>
+        </p:nvSpPr>
+        <p:spPr>
+          <a:xfrm>
+            <a:off x="868680" y="5020056"/>
+            <a:ext cx="384048" cy="384048"/>
+          </a:xfrm>
+          <a:prstGeom prst="ellipse">
+            <a:avLst/>
+          </a:prstGeom>
+          <a:solidFill>
+            <a:srgbClr val="D9534F"/>
+          </a:solidFill>
+          <a:ln/>
+        </p:spPr>
+      </p:sp>
+      <p:sp>
+        <p:nvSpPr>
+          <p:cNvPr id="32" name="Text 29"/>
+          <p:cNvSpPr txBox="1"/>
+          <p:nvPr/>
+        </p:nvSpPr>
+        <p:spPr>
+          <a:xfrm>
+            <a:off x="868680" y="5020056"/>
+            <a:ext cx="384048" cy="384048"/>
+          </a:xfrm>
+          <a:prstGeom prst="rect">
+            <a:avLst/>
+          </a:prstGeom>
+          <a:noFill/>
+          <a:ln/>
+        </p:spPr>
+        <p:txBody>
+          <a:bodyPr wrap="square" lIns="0" tIns="0" rIns="0" bIns="0" rtlCol="0" anchor="ctr"/>
+          <a:lstStyle/>
+          <a:p>
+            <a:pPr algn="ctr" indent="0" marL="0">
+              <a:buNone/>
+            </a:pPr>
+            <a:r>
+              <a:rPr lang="en-US" sz="1800" b="1" dirty="0">
+                <a:solidFill>
+                  <a:srgbClr val="FFFFFF"/>
+                </a:solidFill>
+                <a:latin typeface="Calibri" pitchFamily="34" charset="0"/>
+                <a:ea typeface="Calibri" pitchFamily="34" charset="-122"/>
+                <a:cs typeface="Calibri" pitchFamily="34" charset="-120"/>
+              </a:rPr>
+              <a:t>2</a:t>
+            </a:r>
+            <a:endParaRPr lang="en-US" sz="1800" dirty="0"/>
+          </a:p>
+        </p:txBody>
+      </p:sp>
+      <p:sp>
+        <p:nvSpPr>
+          <p:cNvPr id="33" name="Text 30"/>
+          <p:cNvSpPr txBox="1"/>
+          <p:nvPr/>
+        </p:nvSpPr>
+        <p:spPr>
+          <a:xfrm>
+            <a:off x="1463040" y="4892040"/>
+            <a:ext cx="9966960" cy="640080"/>
+          </a:xfrm>
+          <a:prstGeom prst="rect">
+            <a:avLst/>
+          </a:prstGeom>
+          <a:noFill/>
+          <a:ln/>
+        </p:spPr>
+        <p:txBody>
+          <a:bodyPr wrap="square" lIns="0" tIns="0" rIns="0" bIns="0" rtlCol="0" anchor="ctr"/>
+          <a:lstStyle/>
+          <a:p>
+            <a:pPr indent="0" marL="0">
+              <a:buNone/>
+            </a:pPr>
+            <a:r>
+              <a:rPr lang="en-US" sz="2400" b="1" dirty="0">
+                <a:solidFill>
+                  <a:srgbClr val="FFFFFF"/>
+                </a:solidFill>
+                <a:latin typeface="Calibri" pitchFamily="34" charset="0"/>
+                <a:ea typeface="Calibri" pitchFamily="34" charset="-122"/>
+                <a:cs typeface="Calibri" pitchFamily="34" charset="-120"/>
+              </a:rPr>
+              <a:t>Erkläre in einem Satz, warum der Dritte Stand (Bauern und Bürger) überstimmt wurde, obwohl er fast alle Menschen vertrat.</a:t>
+            </a:r>
+            <a:endParaRPr lang="en-US" sz="2400" dirty="0"/>
+          </a:p>
+        </p:txBody>
+      </p:sp>
+      <p:sp>
+        <p:nvSpPr>
+          <p:cNvPr id="34" name="Shape 31"/>
           <p:cNvSpPr/>
           <p:nvPr/>
         </p:nvSpPr>
@@ -9243,7 +9439,7 @@
       </p:sp>
       <p:sp>
         <p:nvSpPr>
-          <p:cNvPr id="29" name="Text 26"/>
+          <p:cNvPr id="35" name="Text 32"/>
           <p:cNvSpPr txBox="1"/>
           <p:nvPr/>
         </p:nvSpPr>

</xml_diff>

<commit_message>
Generalstände 8D: offene Abschlussfrage im Berater-Format, Form variabel; Orientierung in Sequenz und CLAUDE.md
Co-Authored-By: Claude Sonnet 5.5 <noreply@anthropic.com>
Claude-Session: https://claude.ai/code/session_01GXwmzpsaCraifErTDddPwN
</commit_message>
<xml_diff>
--- a/Geschichte_8D/Generalstaende/Praesentation_Generalstaende_8D.pptx
+++ b/Geschichte_8D/Generalstaende/Praesentation_Generalstaende_8D.pptx
@@ -1046,7 +1046,7 @@
           <a:p>
             <a:r>
               <a:rPr lang="en-US" dirty="0"/>
-              <a:t>Ansage: „Stifte liegen. Ihr hört nur zu. Schaut auf die Ziele. Jetzt arbeitet ihr allein. Die Aufgabe steht rechts.“ Die Klasse prüft zuerst still die Lernziele (Folie 2) und löst dann die Abschlussaufgabe im Heft. Erwartung 1: z. B. 1614 letzte Generalstände, 1788 Missernte oder 1787 Steuerplan scheitert, August 1788 König kündigt an, 5. Mai 1789 Eröffnung. Erwartung 2: Beim Abstimmen nach Ständen hat jeder Stand nur eine Stimme. Klerus und Adel haben zwei von drei Stimmen und stimmen sich ab, deshalb überstimmen sie den Dritten Stand (Bauern und Bürger), obwohl er fast alle Menschen vertritt. Stichprobe: Beim Durchgehen bei 4 bis 6 Heften unterschiedlichen Niveaus mitlesen, nicht kommentieren (unbenotet).</a:t>
+              <a:t>Ansage: „Stifte liegen. Ihr hört nur zu. Schaut kurz auf die Ziele. Jetzt arbeitet ihr allein. Die Aufgabe steht rechts.“ Die Klasse prüft still die Lernziele (Folie 2), dann zehn Sekunden denken, dann schreiben. Es gibt mehrere gute Antworten, geprüft wird die Begründung: eine Position, ein Sachargument aus der Stunde, ein „weil“. Erwartung (Auswahl, keine Musterlösung): FÜR Erlauben: Der Staat braucht Geld, Steuern gehen nur mit dem Dritten Stand (Bauern und Bürger); er stellt fast alle Menschen, sonst droht Unruhe; Hunger und Staatsbankrott sind nah. GEGEN Erlauben: Adel und Klerus sind wütend (der Steuerplan scheiterte 1787), der König verliert Rückhalt und Macht; der Dritte Stand wäre zu mächtig; seit 1614 wurde nach Ständen abgestimmt. Auch eine Zwischenlösung ist gut begründbar. Form nach Verlauf: Blitzlicht (je eine Stimme „erlauben“, eine „nicht erlauben“, gezielt aufgerufen), schriftlich mit Vorlesen oder Berater-Duell zu zweit. Stichprobe: bei 4 bis 6 Heften unterschiedlichen Niveaus mitlesen, nicht kommentieren (unbenotet).</a:t>
             </a:r>
             <a:endParaRPr lang="en-US" dirty="0"/>
           </a:p>
@@ -8816,7 +8816,7 @@
                 <a:ea typeface="Cambria" pitchFamily="34" charset="-122"/>
                 <a:cs typeface="Cambria" pitchFamily="34" charset="-120"/>
               </a:rPr>
-              <a:t>Abschlussaufgabe: Das Wichtigste der Stunde</a:t>
+              <a:t>Abschlussfrage: Du bist Berater</a:t>
             </a:r>
             <a:endParaRPr lang="en-US" sz="3400" dirty="0"/>
           </a:p>
@@ -8908,12 +8908,12 @@
         </p:nvSpPr>
         <p:spPr>
           <a:xfrm>
-            <a:off x="548640" y="1417320"/>
-            <a:ext cx="11109960" cy="685800"/>
+            <a:off x="548640" y="1371600"/>
+            <a:ext cx="11109960" cy="530352"/>
           </a:xfrm>
           <a:prstGeom prst="roundRect">
             <a:avLst>
-              <a:gd name="adj" fmla="val 10667"/>
+              <a:gd name="adj" fmla="val 13793"/>
             </a:avLst>
           </a:prstGeom>
           <a:solidFill>
@@ -8930,8 +8930,8 @@
         </p:nvSpPr>
         <p:spPr>
           <a:xfrm>
-            <a:off x="777240" y="1581912"/>
-            <a:ext cx="365760" cy="365760"/>
+            <a:off x="777240" y="1481328"/>
+            <a:ext cx="310896" cy="310896"/>
           </a:xfrm>
           <a:prstGeom prst="ellipse">
             <a:avLst/>
@@ -8955,8 +8955,8 @@
         </p:nvSpPr>
         <p:spPr>
           <a:xfrm>
-            <a:off x="1417320" y="1417320"/>
-            <a:ext cx="10058400" cy="685800"/>
+            <a:off x="1325880" y="1371600"/>
+            <a:ext cx="10149840" cy="530352"/>
           </a:xfrm>
           <a:prstGeom prst="rect">
             <a:avLst/>
@@ -8994,12 +8994,12 @@
         </p:nvSpPr>
         <p:spPr>
           <a:xfrm>
-            <a:off x="548640" y="2194560"/>
-            <a:ext cx="11109960" cy="685800"/>
+            <a:off x="548640" y="1993392"/>
+            <a:ext cx="11109960" cy="530352"/>
           </a:xfrm>
           <a:prstGeom prst="roundRect">
             <a:avLst>
-              <a:gd name="adj" fmla="val 10667"/>
+              <a:gd name="adj" fmla="val 13793"/>
             </a:avLst>
           </a:prstGeom>
           <a:solidFill>
@@ -9016,8 +9016,8 @@
         </p:nvSpPr>
         <p:spPr>
           <a:xfrm>
-            <a:off x="777240" y="2359152"/>
-            <a:ext cx="365760" cy="365760"/>
+            <a:off x="777240" y="2103120"/>
+            <a:ext cx="310896" cy="310896"/>
           </a:xfrm>
           <a:prstGeom prst="ellipse">
             <a:avLst/>
@@ -9041,8 +9041,8 @@
         </p:nvSpPr>
         <p:spPr>
           <a:xfrm>
-            <a:off x="1417320" y="2194560"/>
-            <a:ext cx="10058400" cy="685800"/>
+            <a:off x="1325880" y="1993392"/>
+            <a:ext cx="10149840" cy="530352"/>
           </a:xfrm>
           <a:prstGeom prst="rect">
             <a:avLst/>
@@ -9080,12 +9080,12 @@
         </p:nvSpPr>
         <p:spPr>
           <a:xfrm>
-            <a:off x="548640" y="2971800"/>
-            <a:ext cx="11109960" cy="685800"/>
+            <a:off x="548640" y="2615184"/>
+            <a:ext cx="11109960" cy="530352"/>
           </a:xfrm>
           <a:prstGeom prst="roundRect">
             <a:avLst>
-              <a:gd name="adj" fmla="val 10667"/>
+              <a:gd name="adj" fmla="val 13793"/>
             </a:avLst>
           </a:prstGeom>
           <a:solidFill>
@@ -9102,8 +9102,8 @@
         </p:nvSpPr>
         <p:spPr>
           <a:xfrm>
-            <a:off x="777240" y="3136392"/>
-            <a:ext cx="365760" cy="365760"/>
+            <a:off x="777240" y="2724912"/>
+            <a:ext cx="310896" cy="310896"/>
           </a:xfrm>
           <a:prstGeom prst="ellipse">
             <a:avLst/>
@@ -9127,8 +9127,8 @@
         </p:nvSpPr>
         <p:spPr>
           <a:xfrm>
-            <a:off x="1417320" y="2971800"/>
-            <a:ext cx="10058400" cy="685800"/>
+            <a:off x="1325880" y="2615184"/>
+            <a:ext cx="10149840" cy="530352"/>
           </a:xfrm>
           <a:prstGeom prst="rect">
             <a:avLst/>
@@ -9166,12 +9166,12 @@
         </p:nvSpPr>
         <p:spPr>
           <a:xfrm>
-            <a:off x="548640" y="3840480"/>
-            <a:ext cx="11109960" cy="1737360"/>
+            <a:off x="548640" y="3337560"/>
+            <a:ext cx="11109960" cy="2240280"/>
           </a:xfrm>
           <a:prstGeom prst="roundRect">
             <a:avLst>
-              <a:gd name="adj" fmla="val 4211"/>
+              <a:gd name="adj" fmla="val 3265"/>
             </a:avLst>
           </a:prstGeom>
           <a:solidFill>
@@ -9188,8 +9188,8 @@
         </p:nvSpPr>
         <p:spPr>
           <a:xfrm>
-            <a:off x="822960" y="3886200"/>
-            <a:ext cx="10607040" cy="365760"/>
+            <a:off x="822960" y="3383280"/>
+            <a:ext cx="10607040" cy="411480"/>
           </a:xfrm>
           <a:prstGeom prst="rect">
             <a:avLst/>
@@ -9213,7 +9213,7 @@
                 <a:ea typeface="Cambria" pitchFamily="34" charset="-122"/>
                 <a:cs typeface="Cambria" pitchFamily="34" charset="-120"/>
               </a:rPr>
-              <a:t>Abschlussaufgabe</a:t>
+              <a:t>Du bist Berater von König Ludwig XVI. Er fragt dich:</a:t>
             </a:r>
             <a:endParaRPr lang="en-US" sz="2400" dirty="0"/>
           </a:p>
@@ -9221,23 +9221,42 @@
       </p:sp>
       <p:sp>
         <p:nvSpPr>
-          <p:cNvPr id="28" name="Shape 25"/>
-          <p:cNvSpPr/>
-          <p:nvPr/>
-        </p:nvSpPr>
-        <p:spPr>
-          <a:xfrm>
-            <a:off x="868680" y="4379976"/>
-            <a:ext cx="384048" cy="384048"/>
-          </a:xfrm>
-          <a:prstGeom prst="ellipse">
-            <a:avLst/>
-          </a:prstGeom>
-          <a:solidFill>
-            <a:srgbClr val="D9534F"/>
-          </a:solidFill>
-          <a:ln/>
-        </p:spPr>
+          <p:cNvPr id="28" name="Text 25"/>
+          <p:cNvSpPr txBox="1"/>
+          <p:nvPr/>
+        </p:nvSpPr>
+        <p:spPr>
+          <a:xfrm>
+            <a:off x="822960" y="3794760"/>
+            <a:ext cx="10607040" cy="868680"/>
+          </a:xfrm>
+          <a:prstGeom prst="rect">
+            <a:avLst/>
+          </a:prstGeom>
+          <a:noFill/>
+          <a:ln/>
+        </p:spPr>
+        <p:txBody>
+          <a:bodyPr wrap="square" lIns="0" tIns="0" rIns="0" bIns="0" rtlCol="0" anchor="ctr"/>
+          <a:lstStyle/>
+          <a:p>
+            <a:pPr indent="0" marL="0">
+              <a:buNone/>
+            </a:pPr>
+            <a:r>
+              <a:rPr lang="en-US" sz="2400" b="1" dirty="0">
+                <a:solidFill>
+                  <a:srgbClr val="FFFFFF"/>
+                </a:solidFill>
+                <a:latin typeface="Calibri" pitchFamily="34" charset="0"/>
+                <a:ea typeface="Calibri" pitchFamily="34" charset="-122"/>
+                <a:cs typeface="Calibri" pitchFamily="34" charset="-120"/>
+              </a:rPr>
+              <a:t>„Soll ich erlauben, dass der Dritte Stand (Bauern und Bürger) nach Köpfen abstimmt?“</a:t>
+            </a:r>
+            <a:endParaRPr lang="en-US" sz="2400" dirty="0"/>
+          </a:p>
+        </p:txBody>
       </p:sp>
       <p:sp>
         <p:nvSpPr>
@@ -9247,8 +9266,8 @@
         </p:nvSpPr>
         <p:spPr>
           <a:xfrm>
-            <a:off x="868680" y="4379976"/>
-            <a:ext cx="384048" cy="384048"/>
+            <a:off x="822960" y="4663440"/>
+            <a:ext cx="10607040" cy="411480"/>
           </a:xfrm>
           <a:prstGeom prst="rect">
             <a:avLst/>
@@ -9260,21 +9279,21 @@
           <a:bodyPr wrap="square" lIns="0" tIns="0" rIns="0" bIns="0" rtlCol="0" anchor="ctr"/>
           <a:lstStyle/>
           <a:p>
-            <a:pPr algn="ctr" indent="0" marL="0">
-              <a:buNone/>
-            </a:pPr>
-            <a:r>
-              <a:rPr lang="en-US" sz="1800" b="1" dirty="0">
+            <a:pPr indent="0" marL="0">
+              <a:buNone/>
+            </a:pPr>
+            <a:r>
+              <a:rPr lang="en-US" sz="2400" b="1" dirty="0">
                 <a:solidFill>
                   <a:srgbClr val="FFFFFF"/>
                 </a:solidFill>
-                <a:latin typeface="Calibri" pitchFamily="34" charset="0"/>
-                <a:ea typeface="Calibri" pitchFamily="34" charset="-122"/>
-                <a:cs typeface="Calibri" pitchFamily="34" charset="-120"/>
-              </a:rPr>
-              <a:t>1</a:t>
-            </a:r>
-            <a:endParaRPr lang="en-US" sz="1800" dirty="0"/>
+                <a:latin typeface="Cambria" pitchFamily="34" charset="0"/>
+                <a:ea typeface="Cambria" pitchFamily="34" charset="-122"/>
+                <a:cs typeface="Cambria" pitchFamily="34" charset="-120"/>
+              </a:rPr>
+              <a:t>Dein Rat:  „Ich rate dir, … , weil …“</a:t>
+            </a:r>
+            <a:endParaRPr lang="en-US" sz="2400" dirty="0"/>
           </a:p>
         </p:txBody>
       </p:sp>
@@ -9286,8 +9305,8 @@
         </p:nvSpPr>
         <p:spPr>
           <a:xfrm>
-            <a:off x="1463040" y="4343400"/>
-            <a:ext cx="9966960" cy="457200"/>
+            <a:off x="822960" y="5074920"/>
+            <a:ext cx="10607040" cy="411480"/>
           </a:xfrm>
           <a:prstGeom prst="rect">
             <a:avLst/>
@@ -9303,15 +9322,15 @@
               <a:buNone/>
             </a:pPr>
             <a:r>
-              <a:rPr lang="en-US" sz="2400" b="1" dirty="0">
-                <a:solidFill>
-                  <a:srgbClr val="FFFFFF"/>
-                </a:solidFill>
-                <a:latin typeface="Calibri" pitchFamily="34" charset="0"/>
-                <a:ea typeface="Calibri" pitchFamily="34" charset="-122"/>
-                <a:cs typeface="Calibri" pitchFamily="34" charset="-120"/>
-              </a:rPr>
-              <a:t>Nenne zwei Ereignisse bis zu den Generalständen, mit Jahr.</a:t>
+              <a:rPr lang="en-US" sz="2400" dirty="0">
+                <a:solidFill>
+                  <a:srgbClr val="CADCFC"/>
+                </a:solidFill>
+                <a:latin typeface="Calibri" pitchFamily="34" charset="0"/>
+                <a:ea typeface="Calibri" pitchFamily="34" charset="-122"/>
+                <a:cs typeface="Calibri" pitchFamily="34" charset="-120"/>
+              </a:rPr>
+              <a:t>Das gehört hinein: eine Position · ein Sachargument aus der Stunde · ein „weil“</a:t>
             </a:r>
             <a:endParaRPr lang="en-US" sz="2400" dirty="0"/>
           </a:p>
@@ -9320,104 +9339,6 @@
       <p:sp>
         <p:nvSpPr>
           <p:cNvPr id="31" name="Shape 28"/>
-          <p:cNvSpPr/>
-          <p:nvPr/>
-        </p:nvSpPr>
-        <p:spPr>
-          <a:xfrm>
-            <a:off x="868680" y="5020056"/>
-            <a:ext cx="384048" cy="384048"/>
-          </a:xfrm>
-          <a:prstGeom prst="ellipse">
-            <a:avLst/>
-          </a:prstGeom>
-          <a:solidFill>
-            <a:srgbClr val="D9534F"/>
-          </a:solidFill>
-          <a:ln/>
-        </p:spPr>
-      </p:sp>
-      <p:sp>
-        <p:nvSpPr>
-          <p:cNvPr id="32" name="Text 29"/>
-          <p:cNvSpPr txBox="1"/>
-          <p:nvPr/>
-        </p:nvSpPr>
-        <p:spPr>
-          <a:xfrm>
-            <a:off x="868680" y="5020056"/>
-            <a:ext cx="384048" cy="384048"/>
-          </a:xfrm>
-          <a:prstGeom prst="rect">
-            <a:avLst/>
-          </a:prstGeom>
-          <a:noFill/>
-          <a:ln/>
-        </p:spPr>
-        <p:txBody>
-          <a:bodyPr wrap="square" lIns="0" tIns="0" rIns="0" bIns="0" rtlCol="0" anchor="ctr"/>
-          <a:lstStyle/>
-          <a:p>
-            <a:pPr algn="ctr" indent="0" marL="0">
-              <a:buNone/>
-            </a:pPr>
-            <a:r>
-              <a:rPr lang="en-US" sz="1800" b="1" dirty="0">
-                <a:solidFill>
-                  <a:srgbClr val="FFFFFF"/>
-                </a:solidFill>
-                <a:latin typeface="Calibri" pitchFamily="34" charset="0"/>
-                <a:ea typeface="Calibri" pitchFamily="34" charset="-122"/>
-                <a:cs typeface="Calibri" pitchFamily="34" charset="-120"/>
-              </a:rPr>
-              <a:t>2</a:t>
-            </a:r>
-            <a:endParaRPr lang="en-US" sz="1800" dirty="0"/>
-          </a:p>
-        </p:txBody>
-      </p:sp>
-      <p:sp>
-        <p:nvSpPr>
-          <p:cNvPr id="33" name="Text 30"/>
-          <p:cNvSpPr txBox="1"/>
-          <p:nvPr/>
-        </p:nvSpPr>
-        <p:spPr>
-          <a:xfrm>
-            <a:off x="1463040" y="4892040"/>
-            <a:ext cx="9966960" cy="640080"/>
-          </a:xfrm>
-          <a:prstGeom prst="rect">
-            <a:avLst/>
-          </a:prstGeom>
-          <a:noFill/>
-          <a:ln/>
-        </p:spPr>
-        <p:txBody>
-          <a:bodyPr wrap="square" lIns="0" tIns="0" rIns="0" bIns="0" rtlCol="0" anchor="ctr"/>
-          <a:lstStyle/>
-          <a:p>
-            <a:pPr indent="0" marL="0">
-              <a:buNone/>
-            </a:pPr>
-            <a:r>
-              <a:rPr lang="en-US" sz="2400" b="1" dirty="0">
-                <a:solidFill>
-                  <a:srgbClr val="FFFFFF"/>
-                </a:solidFill>
-                <a:latin typeface="Calibri" pitchFamily="34" charset="0"/>
-                <a:ea typeface="Calibri" pitchFamily="34" charset="-122"/>
-                <a:cs typeface="Calibri" pitchFamily="34" charset="-120"/>
-              </a:rPr>
-              <a:t>Erkläre in einem Satz, warum der Dritte Stand (Bauern und Bürger) überstimmt wurde, obwohl er fast alle Menschen vertrat.</a:t>
-            </a:r>
-            <a:endParaRPr lang="en-US" sz="2400" dirty="0"/>
-          </a:p>
-        </p:txBody>
-      </p:sp>
-      <p:sp>
-        <p:nvSpPr>
-          <p:cNvPr id="34" name="Shape 31"/>
           <p:cNvSpPr/>
           <p:nvPr/>
         </p:nvSpPr>
@@ -9439,7 +9360,7 @@
       </p:sp>
       <p:sp>
         <p:nvSpPr>
-          <p:cNvPr id="35" name="Text 32"/>
+          <p:cNvPr id="32" name="Text 29"/>
           <p:cNvSpPr txBox="1"/>
           <p:nvPr/>
         </p:nvSpPr>
@@ -9484,7 +9405,7 @@
                 <a:ea typeface="Calibri" pitchFamily="34" charset="-122"/>
                 <a:cs typeface="Calibri" pitchFamily="34" charset="-120"/>
               </a:rPr>
-              <a:t>2 Minuten · allein · leise      </a:t>
+              <a:t>3 Minuten · allein · leise      </a:t>
             </a:r>
             <a:pPr indent="0" marL="0">
               <a:buNone/>
@@ -12332,7 +12253,7 @@
                 <a:ea typeface="Calibri" pitchFamily="34" charset="-122"/>
                 <a:cs typeface="Calibri" pitchFamily="34" charset="-120"/>
               </a:rPr>
-              <a:t>17 Min.</a:t>
+              <a:t>18 Min.</a:t>
             </a:r>
             <a:endParaRPr lang="en-US" sz="2400" dirty="0"/>
           </a:p>
@@ -12491,7 +12412,7 @@
                 <a:ea typeface="Calibri" pitchFamily="34" charset="-122"/>
                 <a:cs typeface="Calibri" pitchFamily="34" charset="-120"/>
               </a:rPr>
-              <a:t>Merksatz, Ich kann …*</a:t>
+              <a:t>Merksatz, Abschlussfrage</a:t>
             </a:r>
             <a:endParaRPr lang="en-US" sz="2400" dirty="0"/>
           </a:p>
@@ -12530,7 +12451,7 @@
                 <a:ea typeface="Calibri" pitchFamily="34" charset="-122"/>
                 <a:cs typeface="Calibri" pitchFamily="34" charset="-120"/>
               </a:rPr>
-              <a:t>5 Min.</a:t>
+              <a:t>6 Min.</a:t>
             </a:r>
             <a:endParaRPr lang="en-US" sz="2400" dirty="0"/>
           </a:p>

</xml_diff>

<commit_message>
Generalstände 8D: Berater-Folie mit Zeichnungen und Sprechblasen, Ziele-Folie danach (18 Folien)
Co-Authored-By: Claude Sonnet 5.5 <noreply@anthropic.com>
Claude-Session: https://claude.ai/code/session_01GXwmzpsaCraifErTDddPwN
</commit_message>
<xml_diff>
--- a/Geschichte_8D/Generalstaende/Praesentation_Generalstaende_8D.pptx
+++ b/Geschichte_8D/Generalstaende/Praesentation_Generalstaende_8D.pptx
@@ -22,9 +22,10 @@
     <p:sldId id="270" r:id="rId16"/>
     <p:sldId id="271" r:id="rId17"/>
     <p:sldId id="272" r:id="rId18"/>
+    <p:sldId id="273" r:id="rId19"/>
   </p:sldIdLst>
   <p:notesMasterIdLst>
-    <p:notesMasterId r:id="rId19"/>
+    <p:notesMasterId r:id="rId20"/>
   </p:notesMasterIdLst>
   <p:sldSz cx="12192000" cy="6858000"/>
   <p:notesSz cx="6858000" cy="12192000"/>
@@ -1046,7 +1047,7 @@
           <a:p>
             <a:r>
               <a:rPr lang="en-US" dirty="0"/>
-              <a:t>Ansage: „Stifte liegen. Ihr hört nur zu. Schaut kurz auf die Ziele. Jetzt arbeitet ihr allein. Die Aufgabe steht rechts.“ Die Klasse prüft still die Lernziele (Folie 2), dann zehn Sekunden denken, dann schreiben. Es gibt mehrere gute Antworten, geprüft wird die Begründung: eine Position, ein Sachargument aus der Stunde, ein „weil“. Erwartung (Auswahl, keine Musterlösung): FÜR Erlauben: Der Staat braucht Geld, Steuern gehen nur mit dem Dritten Stand (Bauern und Bürger); er stellt fast alle Menschen, sonst droht Unruhe; Hunger und Staatsbankrott sind nah. GEGEN Erlauben: Adel und Klerus sind wütend (der Steuerplan scheiterte 1787), der König verliert Rückhalt und Macht; der Dritte Stand wäre zu mächtig; seit 1614 wurde nach Ständen abgestimmt. Auch eine Zwischenlösung ist gut begründbar. Form nach Verlauf: Blitzlicht (je eine Stimme „erlauben“, eine „nicht erlauben“, gezielt aufgerufen), schriftlich mit Vorlesen oder Berater-Duell zu zweit. Stichprobe: bei 4 bis 6 Heften unterschiedlichen Niveaus mitlesen, nicht kommentieren (unbenotet).</a:t>
+              <a:t>Ansage: „Stifte liegen. Ihr hört nur zu. Das ist die letzte Aufgabe. Jetzt arbeitet ihr allein. Die Aufgabe steht rechts.“ Zehn Sekunden denken, dann schreiben. Es gibt mehrere gute Antworten, geprüft wird die Begründung: eine Position, ein Sachargument aus der Stunde, ein „weil“. Erwartung (Auswahl, keine Musterlösung): FÜR Erlauben: Der Staat braucht Geld, Steuern gehen nur mit dem Dritten Stand (Bauern und Bürger); er stellt fast alle Menschen, sonst droht Unruhe; Hunger und Staatsbankrott sind nah. GEGEN Erlauben: Adel und Klerus sind wütend (der Steuerplan scheiterte 1787), der König verliert Rückhalt und Macht; der Dritte Stand wäre zu mächtig; seit 1614 wurde nach Ständen abgestimmt. Auch eine Zwischenlösung ist gut begründbar. Form nach Verlauf: Blitzlicht (je eine Stimme „erlauben“, eine „nicht erlauben“, gezielt aufgerufen), schriftlich mit Vorlesen oder Berater-Duell zu zweit. Stichprobe: bei 4 bis 6 Heften unterschiedlichen Niveaus mitlesen, nicht kommentieren (unbenotet). Die Figuren sind Zeichnungen, keine historischen Porträts.</a:t>
             </a:r>
             <a:endParaRPr lang="en-US" dirty="0"/>
           </a:p>
@@ -1134,7 +1135,7 @@
           <a:p>
             <a:r>
               <a:rPr lang="en-US" dirty="0"/>
-              <a:t>Folie nur lesen (1 Minute). Ausblick: Was passiert, wenn der Dritte Stand verlangt, dass nach Köpfen abgestimmt wird, und der König ablehnt? Hausaufgabe nur, wenn der Test zurückgegeben wurde: Falsche Aufgaben mit Grün berichtigen.</a:t>
+              <a:t>Die Klasse prüft still: Kann ich das? Danach Folie 17. Ziel 3 hat einen Stern (*): Es kann sein, dass es nicht mehr geschafft wurde, dann kommt es nächste Stunde als Wiederholung. Keine Antworten ins Plenum, keine Abfrage von Selbsteinschätzungen.</a:t>
             </a:r>
             <a:endParaRPr lang="en-US" dirty="0"/>
           </a:p>
@@ -1222,7 +1223,7 @@
           <a:p>
             <a:r>
               <a:rPr lang="en-US" dirty="0"/>
-              <a:t>Nur bei Zeit (Puffer). Einzelarbeit im Heft, 2 Minuten. Erwartung: Die Abteilung Fußball (200 Mitglieder) hat nur eine von drei Stimmen, Tischtennis (20) und Schach (10) können sie überstimmen. Das entspricht der Abstimmung nach Ständen. Fairer: nach Köpfen.</a:t>
+              <a:t>Folie nur lesen (1 Minute). Ausblick: Was passiert, wenn der Dritte Stand verlangt, dass nach Köpfen abgestimmt wird, und der König ablehnt? Hausaufgabe nur, wenn der Test zurückgegeben wurde: Falsche Aufgaben mit Grün berichtigen.</a:t>
             </a:r>
             <a:endParaRPr lang="en-US" dirty="0"/>
           </a:p>
@@ -1246,6 +1247,94 @@
             <a:fld id="{F7021451-1387-4CA6-816F-3879F97B5CBC}" type="slidenum">
               <a:rPr lang="en-US"/>
               <a:t>17</a:t>
+            </a:fld>
+            <a:endParaRPr lang="en-US"/>
+          </a:p>
+        </p:txBody>
+      </p:sp>
+    </p:spTree>
+    <p:extLst>
+      <p:ext uri="{BB962C8B-B14F-4D97-AF65-F5344CB8AC3E}">
+        <p14:creationId xmlns:p14="http://schemas.microsoft.com/office/powerpoint/2010/main" val="1024086991"/>
+      </p:ext>
+    </p:extLst>
+  </p:cSld>
+  <p:clrMapOvr>
+    <a:masterClrMapping/>
+  </p:clrMapOvr>
+</p:notes>
+</file>
+
+<file path=ppt/notesSlides/notesSlide18.xml><?xml version="1.0" encoding="utf-8"?>
+<p:notes xmlns:a="http://schemas.openxmlformats.org/drawingml/2006/main" xmlns:r="http://schemas.openxmlformats.org/officeDocument/2006/relationships" xmlns:p="http://schemas.openxmlformats.org/presentationml/2006/main">
+  <p:cSld>
+    <p:spTree>
+      <p:nvGrpSpPr>
+        <p:cNvPr id="1" name=""/>
+        <p:cNvGrpSpPr/>
+        <p:nvPr/>
+      </p:nvGrpSpPr>
+      <p:grpSpPr>
+        <a:xfrm>
+          <a:off x="0" y="0"/>
+          <a:ext cx="0" cy="0"/>
+          <a:chOff x="0" y="0"/>
+          <a:chExt cx="0" cy="0"/>
+        </a:xfrm>
+      </p:grpSpPr>
+      <p:sp>
+        <p:nvSpPr>
+          <p:cNvPr id="2" name="Slide Image Placeholder 1"/>
+          <p:cNvSpPr>
+            <a:spLocks noGrp="1" noRot="1" noChangeAspect="1"/>
+          </p:cNvSpPr>
+          <p:nvPr>
+            <p:ph type="sldImg"/>
+          </p:nvPr>
+        </p:nvSpPr>
+        <p:spPr/>
+      </p:sp>
+      <p:sp>
+        <p:nvSpPr>
+          <p:cNvPr id="3" name="Notes Placeholder 2"/>
+          <p:cNvSpPr>
+            <a:spLocks noGrp="1"/>
+          </p:cNvSpPr>
+          <p:nvPr>
+            <p:ph type="body" idx="1"/>
+          </p:nvPr>
+        </p:nvSpPr>
+        <p:spPr/>
+        <p:txBody>
+          <a:bodyPr/>
+          <a:lstStyle/>
+          <a:p>
+            <a:r>
+              <a:rPr lang="en-US" dirty="0"/>
+              <a:t>Nur bei Zeit (Puffer). Einzelarbeit im Heft, 2 Minuten. Erwartung: Die Abteilung Fußball (200 Mitglieder) hat nur eine von drei Stimmen, Tischtennis (20) und Schach (10) können sie überstimmen. Das entspricht der Abstimmung nach Ständen. Fairer: nach Köpfen.</a:t>
+            </a:r>
+            <a:endParaRPr lang="en-US" dirty="0"/>
+          </a:p>
+        </p:txBody>
+      </p:sp>
+      <p:sp>
+        <p:nvSpPr>
+          <p:cNvPr id="4" name="Slide Number Placeholder 3"/>
+          <p:cNvSpPr>
+            <a:spLocks noGrp="1"/>
+          </p:cNvSpPr>
+          <p:nvPr>
+            <p:ph type="sldNum" sz="quarter" idx="10"/>
+          </p:nvPr>
+        </p:nvSpPr>
+        <p:spPr/>
+        <p:txBody>
+          <a:bodyPr/>
+          <a:lstStyle/>
+          <a:p>
+            <a:fld id="{F7021451-1387-4CA6-816F-3879F97B5CBC}" type="slidenum">
+              <a:rPr lang="en-US"/>
+              <a:t>18</a:t>
             </a:fld>
             <a:endParaRPr lang="en-US"/>
           </a:p>
@@ -1310,7 +1399,7 @@
           <a:p>
             <a:r>
               <a:rPr lang="en-US" dirty="0"/>
-              <a:t>Lernziele vorlesen (1 Minute, Klasse hört nur zu). Am Ende der Stunde (Folie 15) prüft die Klasse still, ob sie erreicht sind. Was nicht geschafft wird, hat einen Stern.</a:t>
+              <a:t>Lernziele vorlesen (1 Minute, Klasse hört nur zu). Am Ende der Stunde (Folie 16) prüft die Klasse still, ob sie erreicht sind. Was nicht geschafft wird, hat einen Stern.</a:t>
             </a:r>
             <a:endParaRPr lang="en-US" dirty="0"/>
           </a:p>
@@ -8900,46 +8989,89 @@
           </a:p>
         </p:txBody>
       </p:sp>
-      <p:sp>
-        <p:nvSpPr>
-          <p:cNvPr id="17" name="Shape 14"/>
-          <p:cNvSpPr/>
-          <p:nvPr/>
-        </p:nvSpPr>
-        <p:spPr>
-          <a:xfrm>
-            <a:off x="548640" y="1371600"/>
-            <a:ext cx="11109960" cy="530352"/>
+      <p:pic>
+        <p:nvPicPr>
+          <p:cNvPr id="17" name="Image 0" descr="../material/koenig.png">    </p:cNvPr>
+          <p:cNvPicPr>
+            <a:picLocks noChangeAspect="1"/>
+          </p:cNvPicPr>
+          <p:nvPr/>
+        </p:nvPicPr>
+        <p:blipFill>
+          <a:blip r:embed="rId1"/>
+          <a:stretch>
+            <a:fillRect/>
+          </a:stretch>
+        </p:blipFill>
+        <p:spPr>
+          <a:xfrm>
+            <a:off x="502920" y="1325880"/>
+            <a:ext cx="2834640" cy="3657600"/>
+          </a:xfrm>
+          <a:prstGeom prst="rect">
+            <a:avLst/>
+          </a:prstGeom>
+        </p:spPr>
+      </p:pic>
+      <p:sp>
+        <p:nvSpPr>
+          <p:cNvPr id="18" name="Text 14"/>
+          <p:cNvSpPr txBox="1"/>
+          <p:nvPr/>
+        </p:nvSpPr>
+        <p:spPr>
+          <a:xfrm>
+            <a:off x="502920" y="5029200"/>
+            <a:ext cx="2834640" cy="365760"/>
+          </a:xfrm>
+          <a:prstGeom prst="rect">
+            <a:avLst/>
+          </a:prstGeom>
+          <a:noFill/>
+          <a:ln/>
+        </p:spPr>
+        <p:txBody>
+          <a:bodyPr wrap="square" lIns="0" tIns="0" rIns="0" bIns="0" rtlCol="0" anchor="t"/>
+          <a:lstStyle/>
+          <a:p>
+            <a:pPr algn="ctr" indent="0" marL="0">
+              <a:buNone/>
+            </a:pPr>
+            <a:r>
+              <a:rPr lang="en-US" sz="2400" b="1" dirty="0">
+                <a:solidFill>
+                  <a:srgbClr val="1E2761"/>
+                </a:solidFill>
+                <a:latin typeface="Cambria" pitchFamily="34" charset="0"/>
+                <a:ea typeface="Cambria" pitchFamily="34" charset="-122"/>
+                <a:cs typeface="Cambria" pitchFamily="34" charset="-120"/>
+              </a:rPr>
+              <a:t>König Ludwig XVI.</a:t>
+            </a:r>
+            <a:endParaRPr lang="en-US" sz="2400" dirty="0"/>
+          </a:p>
+        </p:txBody>
+      </p:sp>
+      <p:sp>
+        <p:nvSpPr>
+          <p:cNvPr id="19" name="Shape 15"/>
+          <p:cNvSpPr/>
+          <p:nvPr/>
+        </p:nvSpPr>
+        <p:spPr>
+          <a:xfrm>
+            <a:off x="3840480" y="1371600"/>
+            <a:ext cx="7818120" cy="1783080"/>
           </a:xfrm>
           <a:prstGeom prst="roundRect">
             <a:avLst>
-              <a:gd name="adj" fmla="val 13793"/>
+              <a:gd name="adj" fmla="val 9231"/>
             </a:avLst>
           </a:prstGeom>
           <a:solidFill>
-            <a:srgbClr val="EAF0FA"/>
-          </a:solidFill>
-          <a:ln/>
-        </p:spPr>
-      </p:sp>
-      <p:sp>
-        <p:nvSpPr>
-          <p:cNvPr id="18" name="Shape 15"/>
-          <p:cNvSpPr/>
-          <p:nvPr/>
-        </p:nvSpPr>
-        <p:spPr>
-          <a:xfrm>
-            <a:off x="777240" y="1481328"/>
-            <a:ext cx="310896" cy="310896"/>
-          </a:xfrm>
-          <a:prstGeom prst="ellipse">
-            <a:avLst/>
-          </a:prstGeom>
-          <a:solidFill>
             <a:srgbClr val="FFFFFF"/>
           </a:solidFill>
-          <a:ln w="25400">
+          <a:ln w="38100">
             <a:solidFill>
               <a:srgbClr val="1E2761"/>
             </a:solidFill>
@@ -8949,83 +9081,22 @@
       </p:sp>
       <p:sp>
         <p:nvSpPr>
-          <p:cNvPr id="19" name="Text 16"/>
-          <p:cNvSpPr txBox="1"/>
-          <p:nvPr/>
-        </p:nvSpPr>
-        <p:spPr>
-          <a:xfrm>
-            <a:off x="1325880" y="1371600"/>
-            <a:ext cx="10149840" cy="530352"/>
-          </a:xfrm>
-          <a:prstGeom prst="rect">
-            <a:avLst/>
-          </a:prstGeom>
-          <a:noFill/>
-          <a:ln/>
-        </p:spPr>
-        <p:txBody>
-          <a:bodyPr wrap="square" lIns="0" tIns="0" rIns="0" bIns="0" rtlCol="0" anchor="ctr"/>
-          <a:lstStyle/>
-          <a:p>
-            <a:pPr indent="0" marL="0">
-              <a:buNone/>
-            </a:pPr>
-            <a:r>
-              <a:rPr lang="en-US" sz="2400" dirty="0">
-                <a:solidFill>
-                  <a:srgbClr val="1E2761"/>
-                </a:solidFill>
-                <a:latin typeface="Cambria" pitchFamily="34" charset="0"/>
-                <a:ea typeface="Cambria" pitchFamily="34" charset="-122"/>
-                <a:cs typeface="Cambria" pitchFamily="34" charset="-120"/>
-              </a:rPr>
-              <a:t>Ich kann den Weg bis zu den Generalständen am Zeitstrahl erklären.</a:t>
-            </a:r>
-            <a:endParaRPr lang="en-US" sz="2400" dirty="0"/>
-          </a:p>
-        </p:txBody>
-      </p:sp>
-      <p:sp>
-        <p:nvSpPr>
-          <p:cNvPr id="20" name="Shape 17"/>
-          <p:cNvSpPr/>
-          <p:nvPr/>
-        </p:nvSpPr>
-        <p:spPr>
-          <a:xfrm>
-            <a:off x="548640" y="1993392"/>
-            <a:ext cx="11109960" cy="530352"/>
-          </a:xfrm>
-          <a:prstGeom prst="roundRect">
-            <a:avLst>
-              <a:gd name="adj" fmla="val 13793"/>
-            </a:avLst>
-          </a:prstGeom>
-          <a:solidFill>
-            <a:srgbClr val="F4F7FD"/>
-          </a:solidFill>
-          <a:ln/>
-        </p:spPr>
-      </p:sp>
-      <p:sp>
-        <p:nvSpPr>
-          <p:cNvPr id="21" name="Shape 18"/>
-          <p:cNvSpPr/>
-          <p:nvPr/>
-        </p:nvSpPr>
-        <p:spPr>
-          <a:xfrm>
-            <a:off x="777240" y="2103120"/>
-            <a:ext cx="310896" cy="310896"/>
-          </a:xfrm>
-          <a:prstGeom prst="ellipse">
+          <p:cNvPr id="20" name="Shape 16"/>
+          <p:cNvSpPr/>
+          <p:nvPr/>
+        </p:nvSpPr>
+        <p:spPr>
+          <a:xfrm rot="16200000">
+            <a:off x="3474720" y="2093976"/>
+            <a:ext cx="457200" cy="384048"/>
+          </a:xfrm>
+          <a:prstGeom prst="triangle">
             <a:avLst/>
           </a:prstGeom>
           <a:solidFill>
             <a:srgbClr val="FFFFFF"/>
           </a:solidFill>
-          <a:ln w="25400">
+          <a:ln w="38100">
             <a:solidFill>
               <a:srgbClr val="1E2761"/>
             </a:solidFill>
@@ -9035,14 +9106,34 @@
       </p:sp>
       <p:sp>
         <p:nvSpPr>
-          <p:cNvPr id="22" name="Text 19"/>
-          <p:cNvSpPr txBox="1"/>
-          <p:nvPr/>
-        </p:nvSpPr>
-        <p:spPr>
-          <a:xfrm>
-            <a:off x="1325880" y="1993392"/>
-            <a:ext cx="10149840" cy="530352"/>
+          <p:cNvPr id="21" name="Shape 17"/>
+          <p:cNvSpPr/>
+          <p:nvPr/>
+        </p:nvSpPr>
+        <p:spPr>
+          <a:xfrm>
+            <a:off x="3822192" y="2103120"/>
+            <a:ext cx="91440" cy="365760"/>
+          </a:xfrm>
+          <a:prstGeom prst="rect">
+            <a:avLst/>
+          </a:prstGeom>
+          <a:solidFill>
+            <a:srgbClr val="FFFFFF"/>
+          </a:solidFill>
+          <a:ln/>
+        </p:spPr>
+      </p:sp>
+      <p:sp>
+        <p:nvSpPr>
+          <p:cNvPr id="22" name="Text 18"/>
+          <p:cNvSpPr txBox="1"/>
+          <p:nvPr/>
+        </p:nvSpPr>
+        <p:spPr>
+          <a:xfrm>
+            <a:off x="4114800" y="1371600"/>
+            <a:ext cx="7315200" cy="1783080"/>
           </a:xfrm>
           <a:prstGeom prst="rect">
             <a:avLst/>
@@ -9058,7 +9149,7 @@
               <a:buNone/>
             </a:pPr>
             <a:r>
-              <a:rPr lang="en-US" sz="2400" dirty="0">
+              <a:rPr lang="en-US" sz="2600" b="1" dirty="0">
                 <a:solidFill>
                   <a:srgbClr val="1E2761"/>
                 </a:solidFill>
@@ -9066,54 +9157,34 @@
                 <a:ea typeface="Cambria" pitchFamily="34" charset="-122"/>
                 <a:cs typeface="Cambria" pitchFamily="34" charset="-120"/>
               </a:rPr>
-              <a:t>Ich kann erklären, wie die Stände den Dritten Stand überstimmen konnten.</a:t>
-            </a:r>
-            <a:endParaRPr lang="en-US" sz="2400" dirty="0"/>
-          </a:p>
-        </p:txBody>
-      </p:sp>
-      <p:sp>
-        <p:nvSpPr>
-          <p:cNvPr id="23" name="Shape 20"/>
-          <p:cNvSpPr/>
-          <p:nvPr/>
-        </p:nvSpPr>
-        <p:spPr>
-          <a:xfrm>
-            <a:off x="548640" y="2615184"/>
-            <a:ext cx="11109960" cy="530352"/>
+              <a:t>„Soll ich erlauben, dass der Dritte Stand (Bauern und Bürger) nach Köpfen abstimmt?“</a:t>
+            </a:r>
+            <a:endParaRPr lang="en-US" sz="2600" dirty="0"/>
+          </a:p>
+        </p:txBody>
+      </p:sp>
+      <p:sp>
+        <p:nvSpPr>
+          <p:cNvPr id="23" name="Shape 19"/>
+          <p:cNvSpPr/>
+          <p:nvPr/>
+        </p:nvSpPr>
+        <p:spPr>
+          <a:xfrm>
+            <a:off x="3840480" y="3429000"/>
+            <a:ext cx="6309360" cy="1463040"/>
           </a:xfrm>
           <a:prstGeom prst="roundRect">
             <a:avLst>
-              <a:gd name="adj" fmla="val 13793"/>
+              <a:gd name="adj" fmla="val 11250"/>
             </a:avLst>
           </a:prstGeom>
           <a:solidFill>
-            <a:srgbClr val="EAF0FA"/>
-          </a:solidFill>
-          <a:ln/>
-        </p:spPr>
-      </p:sp>
-      <p:sp>
-        <p:nvSpPr>
-          <p:cNvPr id="24" name="Shape 21"/>
-          <p:cNvSpPr/>
-          <p:nvPr/>
-        </p:nvSpPr>
-        <p:spPr>
-          <a:xfrm>
-            <a:off x="777240" y="2724912"/>
-            <a:ext cx="310896" cy="310896"/>
-          </a:xfrm>
-          <a:prstGeom prst="ellipse">
-            <a:avLst/>
-          </a:prstGeom>
-          <a:solidFill>
-            <a:srgbClr val="FFFFFF"/>
-          </a:solidFill>
-          <a:ln w="25400">
+            <a:srgbClr val="FDF1D8"/>
+          </a:solidFill>
+          <a:ln w="38100">
             <a:solidFill>
-              <a:srgbClr val="1E2761"/>
+              <a:srgbClr val="C98A1E"/>
             </a:solidFill>
             <a:prstDash val="solid"/>
           </a:ln>
@@ -9121,14 +9192,59 @@
       </p:sp>
       <p:sp>
         <p:nvSpPr>
-          <p:cNvPr id="25" name="Text 22"/>
-          <p:cNvSpPr txBox="1"/>
-          <p:nvPr/>
-        </p:nvSpPr>
-        <p:spPr>
-          <a:xfrm>
-            <a:off x="1325880" y="2615184"/>
-            <a:ext cx="10149840" cy="530352"/>
+          <p:cNvPr id="24" name="Shape 20"/>
+          <p:cNvSpPr/>
+          <p:nvPr/>
+        </p:nvSpPr>
+        <p:spPr>
+          <a:xfrm rot="5400000">
+            <a:off x="10058400" y="3968496"/>
+            <a:ext cx="457200" cy="384048"/>
+          </a:xfrm>
+          <a:prstGeom prst="triangle">
+            <a:avLst/>
+          </a:prstGeom>
+          <a:solidFill>
+            <a:srgbClr val="FDF1D8"/>
+          </a:solidFill>
+          <a:ln w="38100">
+            <a:solidFill>
+              <a:srgbClr val="C98A1E"/>
+            </a:solidFill>
+            <a:prstDash val="solid"/>
+          </a:ln>
+        </p:spPr>
+      </p:sp>
+      <p:sp>
+        <p:nvSpPr>
+          <p:cNvPr id="25" name="Shape 21"/>
+          <p:cNvSpPr/>
+          <p:nvPr/>
+        </p:nvSpPr>
+        <p:spPr>
+          <a:xfrm>
+            <a:off x="10076688" y="3977640"/>
+            <a:ext cx="91440" cy="365760"/>
+          </a:xfrm>
+          <a:prstGeom prst="rect">
+            <a:avLst/>
+          </a:prstGeom>
+          <a:solidFill>
+            <a:srgbClr val="FDF1D8"/>
+          </a:solidFill>
+          <a:ln/>
+        </p:spPr>
+      </p:sp>
+      <p:sp>
+        <p:nvSpPr>
+          <p:cNvPr id="26" name="Text 22"/>
+          <p:cNvSpPr txBox="1"/>
+          <p:nvPr/>
+        </p:nvSpPr>
+        <p:spPr>
+          <a:xfrm>
+            <a:off x="4114800" y="3429000"/>
+            <a:ext cx="5852160" cy="1463040"/>
           </a:xfrm>
           <a:prstGeom prst="rect">
             <a:avLst/>
@@ -9144,7 +9260,7 @@
               <a:buNone/>
             </a:pPr>
             <a:r>
-              <a:rPr lang="en-US" sz="2400" dirty="0">
+              <a:rPr lang="en-US" sz="2600" b="1" dirty="0">
                 <a:solidFill>
                   <a:srgbClr val="1E2761"/>
                 </a:solidFill>
@@ -9152,68 +9268,70 @@
                 <a:ea typeface="Cambria" pitchFamily="34" charset="-122"/>
                 <a:cs typeface="Cambria" pitchFamily="34" charset="-120"/>
               </a:rPr>
-              <a:t>Ich kann begründen, warum die Abstimmung nach Ständen unfair war.*</a:t>
-            </a:r>
-            <a:endParaRPr lang="en-US" sz="2400" dirty="0"/>
-          </a:p>
-        </p:txBody>
-      </p:sp>
-      <p:sp>
-        <p:nvSpPr>
-          <p:cNvPr id="26" name="Shape 23"/>
-          <p:cNvSpPr/>
-          <p:nvPr/>
-        </p:nvSpPr>
-        <p:spPr>
-          <a:xfrm>
-            <a:off x="548640" y="3337560"/>
-            <a:ext cx="11109960" cy="2240280"/>
-          </a:xfrm>
-          <a:prstGeom prst="roundRect">
-            <a:avLst>
-              <a:gd name="adj" fmla="val 3265"/>
-            </a:avLst>
-          </a:prstGeom>
-          <a:solidFill>
-            <a:srgbClr val="1E2761"/>
-          </a:solidFill>
-          <a:ln/>
-        </p:spPr>
-      </p:sp>
-      <p:sp>
-        <p:nvSpPr>
-          <p:cNvPr id="27" name="Text 24"/>
-          <p:cNvSpPr txBox="1"/>
-          <p:nvPr/>
-        </p:nvSpPr>
-        <p:spPr>
-          <a:xfrm>
-            <a:off x="822960" y="3383280"/>
-            <a:ext cx="10607040" cy="411480"/>
-          </a:xfrm>
-          <a:prstGeom prst="rect">
-            <a:avLst/>
-          </a:prstGeom>
-          <a:noFill/>
-          <a:ln/>
-        </p:spPr>
-        <p:txBody>
-          <a:bodyPr wrap="square" lIns="0" tIns="0" rIns="0" bIns="0" rtlCol="0" anchor="ctr"/>
-          <a:lstStyle/>
-          <a:p>
-            <a:pPr indent="0" marL="0">
+              <a:t>Dein Rat:  „Ich rate dir, … , weil …“</a:t>
+            </a:r>
+            <a:endParaRPr lang="en-US" sz="2600" dirty="0"/>
+          </a:p>
+        </p:txBody>
+      </p:sp>
+      <p:pic>
+        <p:nvPicPr>
+          <p:cNvPr id="27" name="Image 1" descr="../material/berater.png">    </p:cNvPr>
+          <p:cNvPicPr>
+            <a:picLocks noChangeAspect="1"/>
+          </p:cNvPicPr>
+          <p:nvPr/>
+        </p:nvPicPr>
+        <p:blipFill>
+          <a:blip r:embed="rId2"/>
+          <a:stretch>
+            <a:fillRect/>
+          </a:stretch>
+        </p:blipFill>
+        <p:spPr>
+          <a:xfrm>
+            <a:off x="10744200" y="3108960"/>
+            <a:ext cx="1188720" cy="1645920"/>
+          </a:xfrm>
+          <a:prstGeom prst="rect">
+            <a:avLst/>
+          </a:prstGeom>
+        </p:spPr>
+      </p:pic>
+      <p:sp>
+        <p:nvSpPr>
+          <p:cNvPr id="28" name="Text 23"/>
+          <p:cNvSpPr txBox="1"/>
+          <p:nvPr/>
+        </p:nvSpPr>
+        <p:spPr>
+          <a:xfrm>
+            <a:off x="10744200" y="4754880"/>
+            <a:ext cx="1188720" cy="365760"/>
+          </a:xfrm>
+          <a:prstGeom prst="rect">
+            <a:avLst/>
+          </a:prstGeom>
+          <a:noFill/>
+          <a:ln/>
+        </p:spPr>
+        <p:txBody>
+          <a:bodyPr wrap="square" lIns="0" tIns="0" rIns="0" bIns="0" rtlCol="0" anchor="t"/>
+          <a:lstStyle/>
+          <a:p>
+            <a:pPr algn="ctr" indent="0" marL="0">
               <a:buNone/>
             </a:pPr>
             <a:r>
               <a:rPr lang="en-US" sz="2400" b="1" dirty="0">
                 <a:solidFill>
-                  <a:srgbClr val="CADCFC"/>
+                  <a:srgbClr val="1E2761"/>
                 </a:solidFill>
                 <a:latin typeface="Cambria" pitchFamily="34" charset="0"/>
                 <a:ea typeface="Cambria" pitchFamily="34" charset="-122"/>
                 <a:cs typeface="Cambria" pitchFamily="34" charset="-120"/>
               </a:rPr>
-              <a:t>Du bist Berater von König Ludwig XVI. Er fragt dich:</a:t>
+              <a:t>Du</a:t>
             </a:r>
             <a:endParaRPr lang="en-US" sz="2400" dirty="0"/>
           </a:p>
@@ -9221,14 +9339,36 @@
       </p:sp>
       <p:sp>
         <p:nvSpPr>
-          <p:cNvPr id="28" name="Text 25"/>
-          <p:cNvSpPr txBox="1"/>
-          <p:nvPr/>
-        </p:nvSpPr>
-        <p:spPr>
-          <a:xfrm>
-            <a:off x="822960" y="3794760"/>
-            <a:ext cx="10607040" cy="868680"/>
+          <p:cNvPr id="29" name="Shape 24"/>
+          <p:cNvSpPr/>
+          <p:nvPr/>
+        </p:nvSpPr>
+        <p:spPr>
+          <a:xfrm>
+            <a:off x="3840480" y="5074920"/>
+            <a:ext cx="2103120" cy="566928"/>
+          </a:xfrm>
+          <a:prstGeom prst="roundRect">
+            <a:avLst>
+              <a:gd name="adj" fmla="val 12903"/>
+            </a:avLst>
+          </a:prstGeom>
+          <a:solidFill>
+            <a:srgbClr val="EAF0FA"/>
+          </a:solidFill>
+          <a:ln/>
+        </p:spPr>
+      </p:sp>
+      <p:sp>
+        <p:nvSpPr>
+          <p:cNvPr id="30" name="Text 25"/>
+          <p:cNvSpPr txBox="1"/>
+          <p:nvPr/>
+        </p:nvSpPr>
+        <p:spPr>
+          <a:xfrm>
+            <a:off x="3931920" y="5074920"/>
+            <a:ext cx="1920240" cy="566928"/>
           </a:xfrm>
           <a:prstGeom prst="rect">
             <a:avLst/>
@@ -9240,58 +9380,19 @@
           <a:bodyPr wrap="square" lIns="0" tIns="0" rIns="0" bIns="0" rtlCol="0" anchor="ctr"/>
           <a:lstStyle/>
           <a:p>
-            <a:pPr indent="0" marL="0">
+            <a:pPr algn="ctr" indent="0" marL="0">
               <a:buNone/>
             </a:pPr>
             <a:r>
               <a:rPr lang="en-US" sz="2400" b="1" dirty="0">
                 <a:solidFill>
-                  <a:srgbClr val="FFFFFF"/>
-                </a:solidFill>
-                <a:latin typeface="Calibri" pitchFamily="34" charset="0"/>
-                <a:ea typeface="Calibri" pitchFamily="34" charset="-122"/>
-                <a:cs typeface="Calibri" pitchFamily="34" charset="-120"/>
-              </a:rPr>
-              <a:t>„Soll ich erlauben, dass der Dritte Stand (Bauern und Bürger) nach Köpfen abstimmt?“</a:t>
-            </a:r>
-            <a:endParaRPr lang="en-US" sz="2400" dirty="0"/>
-          </a:p>
-        </p:txBody>
-      </p:sp>
-      <p:sp>
-        <p:nvSpPr>
-          <p:cNvPr id="29" name="Text 26"/>
-          <p:cNvSpPr txBox="1"/>
-          <p:nvPr/>
-        </p:nvSpPr>
-        <p:spPr>
-          <a:xfrm>
-            <a:off x="822960" y="4663440"/>
-            <a:ext cx="10607040" cy="411480"/>
-          </a:xfrm>
-          <a:prstGeom prst="rect">
-            <a:avLst/>
-          </a:prstGeom>
-          <a:noFill/>
-          <a:ln/>
-        </p:spPr>
-        <p:txBody>
-          <a:bodyPr wrap="square" lIns="0" tIns="0" rIns="0" bIns="0" rtlCol="0" anchor="ctr"/>
-          <a:lstStyle/>
-          <a:p>
-            <a:pPr indent="0" marL="0">
-              <a:buNone/>
-            </a:pPr>
-            <a:r>
-              <a:rPr lang="en-US" sz="2400" b="1" dirty="0">
-                <a:solidFill>
-                  <a:srgbClr val="FFFFFF"/>
+                  <a:srgbClr val="1E2761"/>
                 </a:solidFill>
                 <a:latin typeface="Cambria" pitchFamily="34" charset="0"/>
                 <a:ea typeface="Cambria" pitchFamily="34" charset="-122"/>
                 <a:cs typeface="Cambria" pitchFamily="34" charset="-120"/>
               </a:rPr>
-              <a:t>Dein Rat:  „Ich rate dir, … , weil …“</a:t>
+              <a:t>Position</a:t>
             </a:r>
             <a:endParaRPr lang="en-US" sz="2400" dirty="0"/>
           </a:p>
@@ -9299,14 +9400,36 @@
       </p:sp>
       <p:sp>
         <p:nvSpPr>
-          <p:cNvPr id="30" name="Text 27"/>
-          <p:cNvSpPr txBox="1"/>
-          <p:nvPr/>
-        </p:nvSpPr>
-        <p:spPr>
-          <a:xfrm>
-            <a:off x="822960" y="5074920"/>
-            <a:ext cx="10607040" cy="411480"/>
+          <p:cNvPr id="31" name="Shape 26"/>
+          <p:cNvSpPr/>
+          <p:nvPr/>
+        </p:nvSpPr>
+        <p:spPr>
+          <a:xfrm>
+            <a:off x="6126480" y="5074920"/>
+            <a:ext cx="3017520" cy="566928"/>
+          </a:xfrm>
+          <a:prstGeom prst="roundRect">
+            <a:avLst>
+              <a:gd name="adj" fmla="val 12903"/>
+            </a:avLst>
+          </a:prstGeom>
+          <a:solidFill>
+            <a:srgbClr val="F4F7FD"/>
+          </a:solidFill>
+          <a:ln/>
+        </p:spPr>
+      </p:sp>
+      <p:sp>
+        <p:nvSpPr>
+          <p:cNvPr id="32" name="Text 27"/>
+          <p:cNvSpPr txBox="1"/>
+          <p:nvPr/>
+        </p:nvSpPr>
+        <p:spPr>
+          <a:xfrm>
+            <a:off x="6217920" y="5074920"/>
+            <a:ext cx="2834640" cy="566928"/>
           </a:xfrm>
           <a:prstGeom prst="rect">
             <a:avLst/>
@@ -9318,19 +9441,19 @@
           <a:bodyPr wrap="square" lIns="0" tIns="0" rIns="0" bIns="0" rtlCol="0" anchor="ctr"/>
           <a:lstStyle/>
           <a:p>
-            <a:pPr indent="0" marL="0">
-              <a:buNone/>
-            </a:pPr>
-            <a:r>
-              <a:rPr lang="en-US" sz="2400" dirty="0">
-                <a:solidFill>
-                  <a:srgbClr val="CADCFC"/>
-                </a:solidFill>
-                <a:latin typeface="Calibri" pitchFamily="34" charset="0"/>
-                <a:ea typeface="Calibri" pitchFamily="34" charset="-122"/>
-                <a:cs typeface="Calibri" pitchFamily="34" charset="-120"/>
-              </a:rPr>
-              <a:t>Das gehört hinein: eine Position · ein Sachargument aus der Stunde · ein „weil“</a:t>
+            <a:pPr algn="ctr" indent="0" marL="0">
+              <a:buNone/>
+            </a:pPr>
+            <a:r>
+              <a:rPr lang="en-US" sz="2400" b="1" dirty="0">
+                <a:solidFill>
+                  <a:srgbClr val="1E2761"/>
+                </a:solidFill>
+                <a:latin typeface="Cambria" pitchFamily="34" charset="0"/>
+                <a:ea typeface="Cambria" pitchFamily="34" charset="-122"/>
+                <a:cs typeface="Cambria" pitchFamily="34" charset="-120"/>
+              </a:rPr>
+              <a:t>Sachargument</a:t>
             </a:r>
             <a:endParaRPr lang="en-US" sz="2400" dirty="0"/>
           </a:p>
@@ -9338,7 +9461,68 @@
       </p:sp>
       <p:sp>
         <p:nvSpPr>
-          <p:cNvPr id="31" name="Shape 28"/>
+          <p:cNvPr id="33" name="Shape 28"/>
+          <p:cNvSpPr/>
+          <p:nvPr/>
+        </p:nvSpPr>
+        <p:spPr>
+          <a:xfrm>
+            <a:off x="9326880" y="5074920"/>
+            <a:ext cx="1920240" cy="566928"/>
+          </a:xfrm>
+          <a:prstGeom prst="roundRect">
+            <a:avLst>
+              <a:gd name="adj" fmla="val 12903"/>
+            </a:avLst>
+          </a:prstGeom>
+          <a:solidFill>
+            <a:srgbClr val="EAF0FA"/>
+          </a:solidFill>
+          <a:ln/>
+        </p:spPr>
+      </p:sp>
+      <p:sp>
+        <p:nvSpPr>
+          <p:cNvPr id="34" name="Text 29"/>
+          <p:cNvSpPr txBox="1"/>
+          <p:nvPr/>
+        </p:nvSpPr>
+        <p:spPr>
+          <a:xfrm>
+            <a:off x="9418320" y="5074920"/>
+            <a:ext cx="1737360" cy="566928"/>
+          </a:xfrm>
+          <a:prstGeom prst="rect">
+            <a:avLst/>
+          </a:prstGeom>
+          <a:noFill/>
+          <a:ln/>
+        </p:spPr>
+        <p:txBody>
+          <a:bodyPr wrap="square" lIns="0" tIns="0" rIns="0" bIns="0" rtlCol="0" anchor="ctr"/>
+          <a:lstStyle/>
+          <a:p>
+            <a:pPr algn="ctr" indent="0" marL="0">
+              <a:buNone/>
+            </a:pPr>
+            <a:r>
+              <a:rPr lang="en-US" sz="2400" b="1" dirty="0">
+                <a:solidFill>
+                  <a:srgbClr val="1E2761"/>
+                </a:solidFill>
+                <a:latin typeface="Cambria" pitchFamily="34" charset="0"/>
+                <a:ea typeface="Cambria" pitchFamily="34" charset="-122"/>
+                <a:cs typeface="Cambria" pitchFamily="34" charset="-120"/>
+              </a:rPr>
+              <a:t>„weil“</a:t>
+            </a:r>
+            <a:endParaRPr lang="en-US" sz="2400" dirty="0"/>
+          </a:p>
+        </p:txBody>
+      </p:sp>
+      <p:sp>
+        <p:nvSpPr>
+          <p:cNvPr id="35" name="Shape 30"/>
           <p:cNvSpPr/>
           <p:nvPr/>
         </p:nvSpPr>
@@ -9360,7 +9544,7 @@
       </p:sp>
       <p:sp>
         <p:nvSpPr>
-          <p:cNvPr id="32" name="Text 29"/>
+          <p:cNvPr id="36" name="Text 31"/>
           <p:cNvSpPr txBox="1"/>
           <p:nvPr/>
         </p:nvSpPr>
@@ -9490,7 +9674,7 @@
                 <a:ea typeface="Calibri" pitchFamily="34" charset="-122"/>
                 <a:cs typeface="Calibri" pitchFamily="34" charset="-120"/>
               </a:rPr>
-              <a:t>A · AUSWERTEN · AUSBLICK</a:t>
+              <a:t>A · AUSWERTEN</a:t>
             </a:r>
             <a:endParaRPr lang="en-US" sz="1300" dirty="0"/>
           </a:p>
@@ -9824,7 +10008,7 @@
                 <a:ea typeface="Cambria" pitchFamily="34" charset="-122"/>
                 <a:cs typeface="Cambria" pitchFamily="34" charset="-120"/>
               </a:rPr>
-              <a:t>Wie geht es weiter?</a:t>
+              <a:t>Haben wir die Ziele erreicht?</a:t>
             </a:r>
             <a:endParaRPr lang="en-US" sz="3400" dirty="0"/>
           </a:p>
@@ -9916,30 +10100,55 @@
         </p:nvSpPr>
         <p:spPr>
           <a:xfrm>
-            <a:off x="548640" y="1645920"/>
-            <a:ext cx="11109960" cy="1828800"/>
+            <a:off x="548640" y="1554480"/>
+            <a:ext cx="11109960" cy="1051560"/>
           </a:xfrm>
           <a:prstGeom prst="roundRect">
             <a:avLst>
-              <a:gd name="adj" fmla="val 4000"/>
+              <a:gd name="adj" fmla="val 6957"/>
             </a:avLst>
           </a:prstGeom>
           <a:solidFill>
-            <a:srgbClr val="1E2761"/>
-          </a:solidFill>
-          <a:ln/>
-        </p:spPr>
-      </p:sp>
-      <p:sp>
-        <p:nvSpPr>
-          <p:cNvPr id="18" name="Text 15"/>
-          <p:cNvSpPr txBox="1"/>
-          <p:nvPr/>
-        </p:nvSpPr>
-        <p:spPr>
-          <a:xfrm>
-            <a:off x="868680" y="1645920"/>
-            <a:ext cx="10469880" cy="1828800"/>
+            <a:srgbClr val="EAF0FA"/>
+          </a:solidFill>
+          <a:ln/>
+        </p:spPr>
+      </p:sp>
+      <p:sp>
+        <p:nvSpPr>
+          <p:cNvPr id="18" name="Shape 15"/>
+          <p:cNvSpPr/>
+          <p:nvPr/>
+        </p:nvSpPr>
+        <p:spPr>
+          <a:xfrm>
+            <a:off x="822960" y="1828800"/>
+            <a:ext cx="502920" cy="502920"/>
+          </a:xfrm>
+          <a:prstGeom prst="ellipse">
+            <a:avLst/>
+          </a:prstGeom>
+          <a:solidFill>
+            <a:srgbClr val="FFFFFF"/>
+          </a:solidFill>
+          <a:ln w="25400">
+            <a:solidFill>
+              <a:srgbClr val="1E2761"/>
+            </a:solidFill>
+            <a:prstDash val="solid"/>
+          </a:ln>
+        </p:spPr>
+      </p:sp>
+      <p:sp>
+        <p:nvSpPr>
+          <p:cNvPr id="19" name="Text 16"/>
+          <p:cNvSpPr txBox="1"/>
+          <p:nvPr/>
+        </p:nvSpPr>
+        <p:spPr>
+          <a:xfrm>
+            <a:off x="1600200" y="1554480"/>
+            <a:ext cx="9875520" cy="1051560"/>
           </a:xfrm>
           <a:prstGeom prst="rect">
             <a:avLst/>
@@ -9955,51 +10164,120 @@
               <a:buNone/>
             </a:pPr>
             <a:r>
-              <a:rPr lang="en-US" sz="3200" b="1" dirty="0">
-                <a:solidFill>
-                  <a:srgbClr val="FFFFFF"/>
+              <a:rPr lang="en-US" sz="2600" dirty="0">
+                <a:solidFill>
+                  <a:srgbClr val="1E2761"/>
                 </a:solidFill>
                 <a:latin typeface="Cambria" pitchFamily="34" charset="0"/>
                 <a:ea typeface="Cambria" pitchFamily="34" charset="-122"/>
                 <a:cs typeface="Cambria" pitchFamily="34" charset="-120"/>
               </a:rPr>
-              <a:t>Der Dritte Stand fordert:</a:t>
-            </a:r>
-            <a:endParaRPr lang="en-US" sz="3200" dirty="0"/>
-          </a:p>
+              <a:t>Ich kann den Weg bis zu den Generalständen am Zeitstrahl erklären.</a:t>
+            </a:r>
+            <a:endParaRPr lang="en-US" sz="2600" dirty="0"/>
+          </a:p>
+        </p:txBody>
+      </p:sp>
+      <p:sp>
+        <p:nvSpPr>
+          <p:cNvPr id="20" name="Shape 17"/>
+          <p:cNvSpPr/>
+          <p:nvPr/>
+        </p:nvSpPr>
+        <p:spPr>
+          <a:xfrm>
+            <a:off x="548640" y="2834640"/>
+            <a:ext cx="11109960" cy="1051560"/>
+          </a:xfrm>
+          <a:prstGeom prst="roundRect">
+            <a:avLst>
+              <a:gd name="adj" fmla="val 6957"/>
+            </a:avLst>
+          </a:prstGeom>
+          <a:solidFill>
+            <a:srgbClr val="F4F7FD"/>
+          </a:solidFill>
+          <a:ln/>
+        </p:spPr>
+      </p:sp>
+      <p:sp>
+        <p:nvSpPr>
+          <p:cNvPr id="21" name="Shape 18"/>
+          <p:cNvSpPr/>
+          <p:nvPr/>
+        </p:nvSpPr>
+        <p:spPr>
+          <a:xfrm>
+            <a:off x="822960" y="3108960"/>
+            <a:ext cx="502920" cy="502920"/>
+          </a:xfrm>
+          <a:prstGeom prst="ellipse">
+            <a:avLst/>
+          </a:prstGeom>
+          <a:solidFill>
+            <a:srgbClr val="FFFFFF"/>
+          </a:solidFill>
+          <a:ln w="25400">
+            <a:solidFill>
+              <a:srgbClr val="1E2761"/>
+            </a:solidFill>
+            <a:prstDash val="solid"/>
+          </a:ln>
+        </p:spPr>
+      </p:sp>
+      <p:sp>
+        <p:nvSpPr>
+          <p:cNvPr id="22" name="Text 19"/>
+          <p:cNvSpPr txBox="1"/>
+          <p:nvPr/>
+        </p:nvSpPr>
+        <p:spPr>
+          <a:xfrm>
+            <a:off x="1600200" y="2834640"/>
+            <a:ext cx="9875520" cy="1051560"/>
+          </a:xfrm>
+          <a:prstGeom prst="rect">
+            <a:avLst/>
+          </a:prstGeom>
+          <a:noFill/>
+          <a:ln/>
+        </p:spPr>
+        <p:txBody>
+          <a:bodyPr wrap="square" lIns="0" tIns="0" rIns="0" bIns="0" rtlCol="0" anchor="ctr"/>
+          <a:lstStyle/>
           <a:p>
             <a:pPr indent="0" marL="0">
               <a:buNone/>
             </a:pPr>
             <a:r>
-              <a:rPr lang="en-US" sz="3200" b="1" dirty="0">
-                <a:solidFill>
-                  <a:srgbClr val="FFFFFF"/>
+              <a:rPr lang="en-US" sz="2600" dirty="0">
+                <a:solidFill>
+                  <a:srgbClr val="1E2761"/>
                 </a:solidFill>
                 <a:latin typeface="Cambria" pitchFamily="34" charset="0"/>
                 <a:ea typeface="Cambria" pitchFamily="34" charset="-122"/>
                 <a:cs typeface="Cambria" pitchFamily="34" charset="-120"/>
               </a:rPr>
-              <a:t>„Wir stimmen nach Köpfen ab!“</a:t>
-            </a:r>
-            <a:endParaRPr lang="en-US" sz="3200" dirty="0"/>
-          </a:p>
-        </p:txBody>
-      </p:sp>
-      <p:sp>
-        <p:nvSpPr>
-          <p:cNvPr id="19" name="Shape 16"/>
-          <p:cNvSpPr/>
-          <p:nvPr/>
-        </p:nvSpPr>
-        <p:spPr>
-          <a:xfrm>
-            <a:off x="548640" y="3749040"/>
-            <a:ext cx="11109960" cy="1463040"/>
+              <a:t>Ich kann erklären, wie die Stände den Dritten Stand überstimmen konnten.</a:t>
+            </a:r>
+            <a:endParaRPr lang="en-US" sz="2600" dirty="0"/>
+          </a:p>
+        </p:txBody>
+      </p:sp>
+      <p:sp>
+        <p:nvSpPr>
+          <p:cNvPr id="23" name="Shape 20"/>
+          <p:cNvSpPr/>
+          <p:nvPr/>
+        </p:nvSpPr>
+        <p:spPr>
+          <a:xfrm>
+            <a:off x="548640" y="4114800"/>
+            <a:ext cx="11109960" cy="1051560"/>
           </a:xfrm>
           <a:prstGeom prst="roundRect">
             <a:avLst>
-              <a:gd name="adj" fmla="val 5000"/>
+              <a:gd name="adj" fmla="val 6957"/>
             </a:avLst>
           </a:prstGeom>
           <a:solidFill>
@@ -10010,14 +10288,39 @@
       </p:sp>
       <p:sp>
         <p:nvSpPr>
-          <p:cNvPr id="20" name="Text 17"/>
-          <p:cNvSpPr txBox="1"/>
-          <p:nvPr/>
-        </p:nvSpPr>
-        <p:spPr>
-          <a:xfrm>
-            <a:off x="868680" y="3749040"/>
-            <a:ext cx="10469880" cy="1463040"/>
+          <p:cNvPr id="24" name="Shape 21"/>
+          <p:cNvSpPr/>
+          <p:nvPr/>
+        </p:nvSpPr>
+        <p:spPr>
+          <a:xfrm>
+            <a:off x="822960" y="4389120"/>
+            <a:ext cx="502920" cy="502920"/>
+          </a:xfrm>
+          <a:prstGeom prst="ellipse">
+            <a:avLst/>
+          </a:prstGeom>
+          <a:solidFill>
+            <a:srgbClr val="FFFFFF"/>
+          </a:solidFill>
+          <a:ln w="25400">
+            <a:solidFill>
+              <a:srgbClr val="1E2761"/>
+            </a:solidFill>
+            <a:prstDash val="solid"/>
+          </a:ln>
+        </p:spPr>
+      </p:sp>
+      <p:sp>
+        <p:nvSpPr>
+          <p:cNvPr id="25" name="Text 22"/>
+          <p:cNvSpPr txBox="1"/>
+          <p:nvPr/>
+        </p:nvSpPr>
+        <p:spPr>
+          <a:xfrm>
+            <a:off x="1600200" y="4114800"/>
+            <a:ext cx="9875520" cy="1051560"/>
           </a:xfrm>
           <a:prstGeom prst="rect">
             <a:avLst/>
@@ -10033,7 +10336,7 @@
               <a:buNone/>
             </a:pPr>
             <a:r>
-              <a:rPr lang="en-US" sz="2800" dirty="0">
+              <a:rPr lang="en-US" sz="2600" dirty="0">
                 <a:solidFill>
                   <a:srgbClr val="1E2761"/>
                 </a:solidFill>
@@ -10041,15 +10344,15 @@
                 <a:ea typeface="Cambria" pitchFamily="34" charset="-122"/>
                 <a:cs typeface="Cambria" pitchFamily="34" charset="-120"/>
               </a:rPr>
-              <a:t>Wie reagieren Klerus, Adel und der König? Das sehen wir in der nächsten Stunde.</a:t>
-            </a:r>
-            <a:endParaRPr lang="en-US" sz="2800" dirty="0"/>
-          </a:p>
-        </p:txBody>
-      </p:sp>
-      <p:sp>
-        <p:nvSpPr>
-          <p:cNvPr id="21" name="Shape 18"/>
+              <a:t>Ich kann begründen, warum die Abstimmung nach Ständen unfair war.*</a:t>
+            </a:r>
+            <a:endParaRPr lang="en-US" sz="2600" dirty="0"/>
+          </a:p>
+        </p:txBody>
+      </p:sp>
+      <p:sp>
+        <p:nvSpPr>
+          <p:cNvPr id="26" name="Shape 23"/>
           <p:cNvSpPr/>
           <p:nvPr/>
         </p:nvSpPr>
@@ -10071,7 +10374,7 @@
       </p:sp>
       <p:sp>
         <p:nvSpPr>
-          <p:cNvPr id="22" name="Text 19"/>
+          <p:cNvPr id="27" name="Text 24"/>
           <p:cNvSpPr txBox="1"/>
           <p:nvPr/>
         </p:nvSpPr>
@@ -10102,7 +10405,7 @@
                 <a:ea typeface="Calibri" pitchFamily="34" charset="-122"/>
                 <a:cs typeface="Calibri" pitchFamily="34" charset="-120"/>
               </a:rPr>
-              <a:t>Hausaufgabe: </a:t>
+              <a:t>Jetzt: </a:t>
             </a:r>
             <a:pPr indent="0" marL="0">
               <a:buNone/>
@@ -10116,7 +10419,7 @@
                 <a:ea typeface="Calibri" pitchFamily="34" charset="-122"/>
                 <a:cs typeface="Calibri" pitchFamily="34" charset="-120"/>
               </a:rPr>
-              <a:t>Testaufgaben mit Grün berichtigen.</a:t>
+              <a:t>Schau auf die Ziele. Haben wir sie erreicht?</a:t>
             </a:r>
             <a:endParaRPr lang="en-US" sz="2400" dirty="0"/>
           </a:p>
@@ -10187,7 +10490,7 @@
                 <a:ea typeface="Calibri" pitchFamily="34" charset="-122"/>
                 <a:cs typeface="Calibri" pitchFamily="34" charset="-120"/>
               </a:rPr>
-              <a:t>ZUSATZ · NUR BEI ZEIT*</a:t>
+              <a:t>A · AUSWERTEN · AUSBLICK</a:t>
             </a:r>
             <a:endParaRPr lang="en-US" sz="1300" dirty="0"/>
           </a:p>
@@ -10195,7 +10498,302 @@
       </p:sp>
       <p:sp>
         <p:nvSpPr>
-          <p:cNvPr id="3" name="Text 1"/>
+          <p:cNvPr id="3" name="Shape 1"/>
+          <p:cNvSpPr/>
+          <p:nvPr/>
+        </p:nvSpPr>
+        <p:spPr>
+          <a:xfrm>
+            <a:off x="9144000" y="274320"/>
+            <a:ext cx="402336" cy="402336"/>
+          </a:xfrm>
+          <a:prstGeom prst="ellipse">
+            <a:avLst/>
+          </a:prstGeom>
+          <a:solidFill>
+            <a:srgbClr val="EAF0FA"/>
+          </a:solidFill>
+          <a:ln/>
+        </p:spPr>
+      </p:sp>
+      <p:sp>
+        <p:nvSpPr>
+          <p:cNvPr id="4" name="Text 2"/>
+          <p:cNvSpPr txBox="1"/>
+          <p:nvPr/>
+        </p:nvSpPr>
+        <p:spPr>
+          <a:xfrm>
+            <a:off x="9144000" y="274320"/>
+            <a:ext cx="402336" cy="402336"/>
+          </a:xfrm>
+          <a:prstGeom prst="rect">
+            <a:avLst/>
+          </a:prstGeom>
+          <a:noFill/>
+          <a:ln/>
+        </p:spPr>
+        <p:txBody>
+          <a:bodyPr wrap="square" lIns="0" tIns="0" rIns="0" bIns="0" rtlCol="0" anchor="ctr"/>
+          <a:lstStyle/>
+          <a:p>
+            <a:pPr algn="ctr" indent="0" marL="0">
+              <a:buNone/>
+            </a:pPr>
+            <a:r>
+              <a:rPr lang="en-US" sz="1400" b="1" dirty="0">
+                <a:solidFill>
+                  <a:srgbClr val="5B6B8C"/>
+                </a:solidFill>
+                <a:latin typeface="Calibri" pitchFamily="34" charset="0"/>
+                <a:ea typeface="Calibri" pitchFamily="34" charset="-122"/>
+                <a:cs typeface="Calibri" pitchFamily="34" charset="-120"/>
+              </a:rPr>
+              <a:t>A</a:t>
+            </a:r>
+            <a:endParaRPr lang="en-US" sz="1400" dirty="0"/>
+          </a:p>
+        </p:txBody>
+      </p:sp>
+      <p:sp>
+        <p:nvSpPr>
+          <p:cNvPr id="5" name="Shape 3"/>
+          <p:cNvSpPr/>
+          <p:nvPr/>
+        </p:nvSpPr>
+        <p:spPr>
+          <a:xfrm>
+            <a:off x="9646920" y="274320"/>
+            <a:ext cx="402336" cy="402336"/>
+          </a:xfrm>
+          <a:prstGeom prst="ellipse">
+            <a:avLst/>
+          </a:prstGeom>
+          <a:solidFill>
+            <a:srgbClr val="EAF0FA"/>
+          </a:solidFill>
+          <a:ln/>
+        </p:spPr>
+      </p:sp>
+      <p:sp>
+        <p:nvSpPr>
+          <p:cNvPr id="6" name="Text 4"/>
+          <p:cNvSpPr txBox="1"/>
+          <p:nvPr/>
+        </p:nvSpPr>
+        <p:spPr>
+          <a:xfrm>
+            <a:off x="9646920" y="274320"/>
+            <a:ext cx="402336" cy="402336"/>
+          </a:xfrm>
+          <a:prstGeom prst="rect">
+            <a:avLst/>
+          </a:prstGeom>
+          <a:noFill/>
+          <a:ln/>
+        </p:spPr>
+        <p:txBody>
+          <a:bodyPr wrap="square" lIns="0" tIns="0" rIns="0" bIns="0" rtlCol="0" anchor="ctr"/>
+          <a:lstStyle/>
+          <a:p>
+            <a:pPr algn="ctr" indent="0" marL="0">
+              <a:buNone/>
+            </a:pPr>
+            <a:r>
+              <a:rPr lang="en-US" sz="1400" b="1" dirty="0">
+                <a:solidFill>
+                  <a:srgbClr val="5B6B8C"/>
+                </a:solidFill>
+                <a:latin typeface="Calibri" pitchFamily="34" charset="0"/>
+                <a:ea typeface="Calibri" pitchFamily="34" charset="-122"/>
+                <a:cs typeface="Calibri" pitchFamily="34" charset="-120"/>
+              </a:rPr>
+              <a:t>V</a:t>
+            </a:r>
+            <a:endParaRPr lang="en-US" sz="1400" dirty="0"/>
+          </a:p>
+        </p:txBody>
+      </p:sp>
+      <p:sp>
+        <p:nvSpPr>
+          <p:cNvPr id="7" name="Shape 5"/>
+          <p:cNvSpPr/>
+          <p:nvPr/>
+        </p:nvSpPr>
+        <p:spPr>
+          <a:xfrm>
+            <a:off x="10149840" y="274320"/>
+            <a:ext cx="402336" cy="402336"/>
+          </a:xfrm>
+          <a:prstGeom prst="ellipse">
+            <a:avLst/>
+          </a:prstGeom>
+          <a:solidFill>
+            <a:srgbClr val="EAF0FA"/>
+          </a:solidFill>
+          <a:ln/>
+        </p:spPr>
+      </p:sp>
+      <p:sp>
+        <p:nvSpPr>
+          <p:cNvPr id="8" name="Text 6"/>
+          <p:cNvSpPr txBox="1"/>
+          <p:nvPr/>
+        </p:nvSpPr>
+        <p:spPr>
+          <a:xfrm>
+            <a:off x="10149840" y="274320"/>
+            <a:ext cx="402336" cy="402336"/>
+          </a:xfrm>
+          <a:prstGeom prst="rect">
+            <a:avLst/>
+          </a:prstGeom>
+          <a:noFill/>
+          <a:ln/>
+        </p:spPr>
+        <p:txBody>
+          <a:bodyPr wrap="square" lIns="0" tIns="0" rIns="0" bIns="0" rtlCol="0" anchor="ctr"/>
+          <a:lstStyle/>
+          <a:p>
+            <a:pPr algn="ctr" indent="0" marL="0">
+              <a:buNone/>
+            </a:pPr>
+            <a:r>
+              <a:rPr lang="en-US" sz="1400" b="1" dirty="0">
+                <a:solidFill>
+                  <a:srgbClr val="5B6B8C"/>
+                </a:solidFill>
+                <a:latin typeface="Calibri" pitchFamily="34" charset="0"/>
+                <a:ea typeface="Calibri" pitchFamily="34" charset="-122"/>
+                <a:cs typeface="Calibri" pitchFamily="34" charset="-120"/>
+              </a:rPr>
+              <a:t>I</a:t>
+            </a:r>
+            <a:endParaRPr lang="en-US" sz="1400" dirty="0"/>
+          </a:p>
+        </p:txBody>
+      </p:sp>
+      <p:sp>
+        <p:nvSpPr>
+          <p:cNvPr id="9" name="Shape 7"/>
+          <p:cNvSpPr/>
+          <p:nvPr/>
+        </p:nvSpPr>
+        <p:spPr>
+          <a:xfrm>
+            <a:off x="10652760" y="274320"/>
+            <a:ext cx="402336" cy="402336"/>
+          </a:xfrm>
+          <a:prstGeom prst="ellipse">
+            <a:avLst/>
+          </a:prstGeom>
+          <a:solidFill>
+            <a:srgbClr val="EAF0FA"/>
+          </a:solidFill>
+          <a:ln/>
+        </p:spPr>
+      </p:sp>
+      <p:sp>
+        <p:nvSpPr>
+          <p:cNvPr id="10" name="Text 8"/>
+          <p:cNvSpPr txBox="1"/>
+          <p:nvPr/>
+        </p:nvSpPr>
+        <p:spPr>
+          <a:xfrm>
+            <a:off x="10652760" y="274320"/>
+            <a:ext cx="402336" cy="402336"/>
+          </a:xfrm>
+          <a:prstGeom prst="rect">
+            <a:avLst/>
+          </a:prstGeom>
+          <a:noFill/>
+          <a:ln/>
+        </p:spPr>
+        <p:txBody>
+          <a:bodyPr wrap="square" lIns="0" tIns="0" rIns="0" bIns="0" rtlCol="0" anchor="ctr"/>
+          <a:lstStyle/>
+          <a:p>
+            <a:pPr algn="ctr" indent="0" marL="0">
+              <a:buNone/>
+            </a:pPr>
+            <a:r>
+              <a:rPr lang="en-US" sz="1400" b="1" dirty="0">
+                <a:solidFill>
+                  <a:srgbClr val="5B6B8C"/>
+                </a:solidFill>
+                <a:latin typeface="Calibri" pitchFamily="34" charset="0"/>
+                <a:ea typeface="Calibri" pitchFamily="34" charset="-122"/>
+                <a:cs typeface="Calibri" pitchFamily="34" charset="-120"/>
+              </a:rPr>
+              <a:t>V</a:t>
+            </a:r>
+            <a:endParaRPr lang="en-US" sz="1400" dirty="0"/>
+          </a:p>
+        </p:txBody>
+      </p:sp>
+      <p:sp>
+        <p:nvSpPr>
+          <p:cNvPr id="11" name="Shape 9"/>
+          <p:cNvSpPr/>
+          <p:nvPr/>
+        </p:nvSpPr>
+        <p:spPr>
+          <a:xfrm>
+            <a:off x="11155680" y="274320"/>
+            <a:ext cx="402336" cy="402336"/>
+          </a:xfrm>
+          <a:prstGeom prst="ellipse">
+            <a:avLst/>
+          </a:prstGeom>
+          <a:solidFill>
+            <a:srgbClr val="D9534F"/>
+          </a:solidFill>
+          <a:ln/>
+        </p:spPr>
+      </p:sp>
+      <p:sp>
+        <p:nvSpPr>
+          <p:cNvPr id="12" name="Text 10"/>
+          <p:cNvSpPr txBox="1"/>
+          <p:nvPr/>
+        </p:nvSpPr>
+        <p:spPr>
+          <a:xfrm>
+            <a:off x="11155680" y="274320"/>
+            <a:ext cx="402336" cy="402336"/>
+          </a:xfrm>
+          <a:prstGeom prst="rect">
+            <a:avLst/>
+          </a:prstGeom>
+          <a:noFill/>
+          <a:ln/>
+        </p:spPr>
+        <p:txBody>
+          <a:bodyPr wrap="square" lIns="0" tIns="0" rIns="0" bIns="0" rtlCol="0" anchor="ctr"/>
+          <a:lstStyle/>
+          <a:p>
+            <a:pPr algn="ctr" indent="0" marL="0">
+              <a:buNone/>
+            </a:pPr>
+            <a:r>
+              <a:rPr lang="en-US" sz="1400" b="1" dirty="0">
+                <a:solidFill>
+                  <a:srgbClr val="FFFFFF"/>
+                </a:solidFill>
+                <a:latin typeface="Calibri" pitchFamily="34" charset="0"/>
+                <a:ea typeface="Calibri" pitchFamily="34" charset="-122"/>
+                <a:cs typeface="Calibri" pitchFamily="34" charset="-120"/>
+              </a:rPr>
+              <a:t>A</a:t>
+            </a:r>
+            <a:endParaRPr lang="en-US" sz="1400" dirty="0"/>
+          </a:p>
+        </p:txBody>
+      </p:sp>
+      <p:sp>
+        <p:nvSpPr>
+          <p:cNvPr id="13" name="Text 11"/>
           <p:cNvSpPr txBox="1"/>
           <p:nvPr/>
         </p:nvSpPr>
@@ -10226,7 +10824,7 @@
                 <a:ea typeface="Cambria" pitchFamily="34" charset="-122"/>
                 <a:cs typeface="Cambria" pitchFamily="34" charset="-120"/>
               </a:rPr>
-              <a:t>Ein Sportverein stimmt ab</a:t>
+              <a:t>Wie geht es weiter?</a:t>
             </a:r>
             <a:endParaRPr lang="en-US" sz="3400" dirty="0"/>
           </a:p>
@@ -10234,7 +10832,7 @@
       </p:sp>
       <p:sp>
         <p:nvSpPr>
-          <p:cNvPr id="4" name="Text 2"/>
+          <p:cNvPr id="14" name="Text 12"/>
           <p:cNvSpPr txBox="1"/>
           <p:nvPr/>
         </p:nvSpPr>
@@ -10273,7 +10871,7 @@
       </p:sp>
       <p:sp>
         <p:nvSpPr>
-          <p:cNvPr id="5" name="Text 3"/>
+          <p:cNvPr id="15" name="Text 13"/>
           <p:cNvSpPr txBox="1"/>
           <p:nvPr/>
         </p:nvSpPr>
@@ -10305,6 +10903,408 @@
                 <a:cs typeface="Calibri" pitchFamily="34" charset="-120"/>
               </a:rPr>
               <a:t>17</a:t>
+            </a:r>
+            <a:endParaRPr lang="en-US" sz="1000" dirty="0"/>
+          </a:p>
+        </p:txBody>
+      </p:sp>
+      <p:sp>
+        <p:nvSpPr>
+          <p:cNvPr id="17" name="Shape 14"/>
+          <p:cNvSpPr/>
+          <p:nvPr/>
+        </p:nvSpPr>
+        <p:spPr>
+          <a:xfrm>
+            <a:off x="548640" y="1645920"/>
+            <a:ext cx="11109960" cy="1828800"/>
+          </a:xfrm>
+          <a:prstGeom prst="roundRect">
+            <a:avLst>
+              <a:gd name="adj" fmla="val 4000"/>
+            </a:avLst>
+          </a:prstGeom>
+          <a:solidFill>
+            <a:srgbClr val="1E2761"/>
+          </a:solidFill>
+          <a:ln/>
+        </p:spPr>
+      </p:sp>
+      <p:sp>
+        <p:nvSpPr>
+          <p:cNvPr id="18" name="Text 15"/>
+          <p:cNvSpPr txBox="1"/>
+          <p:nvPr/>
+        </p:nvSpPr>
+        <p:spPr>
+          <a:xfrm>
+            <a:off x="868680" y="1645920"/>
+            <a:ext cx="10469880" cy="1828800"/>
+          </a:xfrm>
+          <a:prstGeom prst="rect">
+            <a:avLst/>
+          </a:prstGeom>
+          <a:noFill/>
+          <a:ln/>
+        </p:spPr>
+        <p:txBody>
+          <a:bodyPr wrap="square" lIns="0" tIns="0" rIns="0" bIns="0" rtlCol="0" anchor="ctr"/>
+          <a:lstStyle/>
+          <a:p>
+            <a:pPr indent="0" marL="0">
+              <a:buNone/>
+            </a:pPr>
+            <a:r>
+              <a:rPr lang="en-US" sz="3200" b="1" dirty="0">
+                <a:solidFill>
+                  <a:srgbClr val="FFFFFF"/>
+                </a:solidFill>
+                <a:latin typeface="Cambria" pitchFamily="34" charset="0"/>
+                <a:ea typeface="Cambria" pitchFamily="34" charset="-122"/>
+                <a:cs typeface="Cambria" pitchFamily="34" charset="-120"/>
+              </a:rPr>
+              <a:t>Der Dritte Stand fordert:</a:t>
+            </a:r>
+            <a:endParaRPr lang="en-US" sz="3200" dirty="0"/>
+          </a:p>
+          <a:p>
+            <a:pPr indent="0" marL="0">
+              <a:buNone/>
+            </a:pPr>
+            <a:r>
+              <a:rPr lang="en-US" sz="3200" b="1" dirty="0">
+                <a:solidFill>
+                  <a:srgbClr val="FFFFFF"/>
+                </a:solidFill>
+                <a:latin typeface="Cambria" pitchFamily="34" charset="0"/>
+                <a:ea typeface="Cambria" pitchFamily="34" charset="-122"/>
+                <a:cs typeface="Cambria" pitchFamily="34" charset="-120"/>
+              </a:rPr>
+              <a:t>„Wir stimmen nach Köpfen ab!“</a:t>
+            </a:r>
+            <a:endParaRPr lang="en-US" sz="3200" dirty="0"/>
+          </a:p>
+        </p:txBody>
+      </p:sp>
+      <p:sp>
+        <p:nvSpPr>
+          <p:cNvPr id="19" name="Shape 16"/>
+          <p:cNvSpPr/>
+          <p:nvPr/>
+        </p:nvSpPr>
+        <p:spPr>
+          <a:xfrm>
+            <a:off x="548640" y="3749040"/>
+            <a:ext cx="11109960" cy="1463040"/>
+          </a:xfrm>
+          <a:prstGeom prst="roundRect">
+            <a:avLst>
+              <a:gd name="adj" fmla="val 5000"/>
+            </a:avLst>
+          </a:prstGeom>
+          <a:solidFill>
+            <a:srgbClr val="EAF0FA"/>
+          </a:solidFill>
+          <a:ln/>
+        </p:spPr>
+      </p:sp>
+      <p:sp>
+        <p:nvSpPr>
+          <p:cNvPr id="20" name="Text 17"/>
+          <p:cNvSpPr txBox="1"/>
+          <p:nvPr/>
+        </p:nvSpPr>
+        <p:spPr>
+          <a:xfrm>
+            <a:off x="868680" y="3749040"/>
+            <a:ext cx="10469880" cy="1463040"/>
+          </a:xfrm>
+          <a:prstGeom prst="rect">
+            <a:avLst/>
+          </a:prstGeom>
+          <a:noFill/>
+          <a:ln/>
+        </p:spPr>
+        <p:txBody>
+          <a:bodyPr wrap="square" lIns="0" tIns="0" rIns="0" bIns="0" rtlCol="0" anchor="ctr"/>
+          <a:lstStyle/>
+          <a:p>
+            <a:pPr indent="0" marL="0">
+              <a:buNone/>
+            </a:pPr>
+            <a:r>
+              <a:rPr lang="en-US" sz="2800" dirty="0">
+                <a:solidFill>
+                  <a:srgbClr val="1E2761"/>
+                </a:solidFill>
+                <a:latin typeface="Cambria" pitchFamily="34" charset="0"/>
+                <a:ea typeface="Cambria" pitchFamily="34" charset="-122"/>
+                <a:cs typeface="Cambria" pitchFamily="34" charset="-120"/>
+              </a:rPr>
+              <a:t>Wie reagieren Klerus, Adel und der König? Das sehen wir in der nächsten Stunde.</a:t>
+            </a:r>
+            <a:endParaRPr lang="en-US" sz="2800" dirty="0"/>
+          </a:p>
+        </p:txBody>
+      </p:sp>
+      <p:sp>
+        <p:nvSpPr>
+          <p:cNvPr id="21" name="Shape 18"/>
+          <p:cNvSpPr/>
+          <p:nvPr/>
+        </p:nvSpPr>
+        <p:spPr>
+          <a:xfrm>
+            <a:off x="548640" y="5669280"/>
+            <a:ext cx="11109960" cy="777240"/>
+          </a:xfrm>
+          <a:prstGeom prst="roundRect">
+            <a:avLst>
+              <a:gd name="adj" fmla="val 9412"/>
+            </a:avLst>
+          </a:prstGeom>
+          <a:solidFill>
+            <a:srgbClr val="1E2761"/>
+          </a:solidFill>
+          <a:ln/>
+        </p:spPr>
+      </p:sp>
+      <p:sp>
+        <p:nvSpPr>
+          <p:cNvPr id="22" name="Text 19"/>
+          <p:cNvSpPr txBox="1"/>
+          <p:nvPr/>
+        </p:nvSpPr>
+        <p:spPr>
+          <a:xfrm>
+            <a:off x="822960" y="5669280"/>
+            <a:ext cx="10607040" cy="777240"/>
+          </a:xfrm>
+          <a:prstGeom prst="rect">
+            <a:avLst/>
+          </a:prstGeom>
+          <a:noFill/>
+          <a:ln/>
+        </p:spPr>
+        <p:txBody>
+          <a:bodyPr wrap="square" lIns="0" tIns="0" rIns="0" bIns="0" rtlCol="0" anchor="ctr"/>
+          <a:lstStyle/>
+          <a:p>
+            <a:pPr indent="0" marL="0">
+              <a:buNone/>
+            </a:pPr>
+            <a:r>
+              <a:rPr lang="en-US" sz="2400" b="1" dirty="0">
+                <a:solidFill>
+                  <a:srgbClr val="FFFFFF"/>
+                </a:solidFill>
+                <a:latin typeface="Calibri" pitchFamily="34" charset="0"/>
+                <a:ea typeface="Calibri" pitchFamily="34" charset="-122"/>
+                <a:cs typeface="Calibri" pitchFamily="34" charset="-120"/>
+              </a:rPr>
+              <a:t>Hausaufgabe: </a:t>
+            </a:r>
+            <a:pPr indent="0" marL="0">
+              <a:buNone/>
+            </a:pPr>
+            <a:r>
+              <a:rPr lang="en-US" sz="2400" dirty="0">
+                <a:solidFill>
+                  <a:srgbClr val="FFFFFF"/>
+                </a:solidFill>
+                <a:latin typeface="Calibri" pitchFamily="34" charset="0"/>
+                <a:ea typeface="Calibri" pitchFamily="34" charset="-122"/>
+                <a:cs typeface="Calibri" pitchFamily="34" charset="-120"/>
+              </a:rPr>
+              <a:t>Testaufgaben mit Grün berichtigen.</a:t>
+            </a:r>
+            <a:endParaRPr lang="en-US" sz="2400" dirty="0"/>
+          </a:p>
+        </p:txBody>
+      </p:sp>
+    </p:spTree>
+  </p:cSld>
+  <p:clrMapOvr>
+    <a:masterClrMapping/>
+  </p:clrMapOvr>
+</p:sld>
+</file>
+
+<file path=ppt/slides/slide18.xml><?xml version="1.0" encoding="utf-8"?>
+<p:sld xmlns:a="http://schemas.openxmlformats.org/drawingml/2006/main" xmlns:r="http://schemas.openxmlformats.org/officeDocument/2006/relationships" xmlns:p="http://schemas.openxmlformats.org/presentationml/2006/main">
+  <p:cSld name="Slide 18">
+    <p:bg>
+      <p:bgPr>
+        <a:solidFill>
+          <a:srgbClr val="FFFFFF"/>
+        </a:solidFill>
+      </p:bgPr>
+    </p:bg>
+    <p:spTree>
+      <p:nvGrpSpPr>
+        <p:cNvPr id="1" name=""/>
+        <p:cNvGrpSpPr/>
+        <p:nvPr/>
+      </p:nvGrpSpPr>
+      <p:grpSpPr>
+        <a:xfrm>
+          <a:off x="0" y="0"/>
+          <a:ext cx="0" cy="0"/>
+          <a:chOff x="0" y="0"/>
+          <a:chExt cx="0" cy="0"/>
+        </a:xfrm>
+      </p:grpSpPr>
+      <p:sp>
+        <p:nvSpPr>
+          <p:cNvPr id="2" name="Text 0"/>
+          <p:cNvSpPr txBox="1"/>
+          <p:nvPr/>
+        </p:nvSpPr>
+        <p:spPr>
+          <a:xfrm>
+            <a:off x="548640" y="320040"/>
+            <a:ext cx="8229600" cy="274320"/>
+          </a:xfrm>
+          <a:prstGeom prst="rect">
+            <a:avLst/>
+          </a:prstGeom>
+          <a:noFill/>
+          <a:ln/>
+        </p:spPr>
+        <p:txBody>
+          <a:bodyPr wrap="square" lIns="0" tIns="0" rIns="0" bIns="0" rtlCol="0" anchor="t"/>
+          <a:lstStyle/>
+          <a:p>
+            <a:pPr indent="0" marL="0">
+              <a:buNone/>
+            </a:pPr>
+            <a:r>
+              <a:rPr lang="en-US" sz="1300" b="1" spc="200" kern="0" dirty="0">
+                <a:solidFill>
+                  <a:srgbClr val="5B6B8C"/>
+                </a:solidFill>
+                <a:latin typeface="Calibri" pitchFamily="34" charset="0"/>
+                <a:ea typeface="Calibri" pitchFamily="34" charset="-122"/>
+                <a:cs typeface="Calibri" pitchFamily="34" charset="-120"/>
+              </a:rPr>
+              <a:t>ZUSATZ · NUR BEI ZEIT*</a:t>
+            </a:r>
+            <a:endParaRPr lang="en-US" sz="1300" dirty="0"/>
+          </a:p>
+        </p:txBody>
+      </p:sp>
+      <p:sp>
+        <p:nvSpPr>
+          <p:cNvPr id="3" name="Text 1"/>
+          <p:cNvSpPr txBox="1"/>
+          <p:nvPr/>
+        </p:nvSpPr>
+        <p:spPr>
+          <a:xfrm>
+            <a:off x="548640" y="640080"/>
+            <a:ext cx="11064240" cy="685800"/>
+          </a:xfrm>
+          <a:prstGeom prst="rect">
+            <a:avLst/>
+          </a:prstGeom>
+          <a:noFill/>
+          <a:ln/>
+        </p:spPr>
+        <p:txBody>
+          <a:bodyPr wrap="square" lIns="0" tIns="0" rIns="0" bIns="0" rtlCol="0" anchor="t"/>
+          <a:lstStyle/>
+          <a:p>
+            <a:pPr indent="0" marL="0">
+              <a:buNone/>
+            </a:pPr>
+            <a:r>
+              <a:rPr lang="en-US" sz="3400" b="1" dirty="0">
+                <a:solidFill>
+                  <a:srgbClr val="1E2761"/>
+                </a:solidFill>
+                <a:latin typeface="Cambria" pitchFamily="34" charset="0"/>
+                <a:ea typeface="Cambria" pitchFamily="34" charset="-122"/>
+                <a:cs typeface="Cambria" pitchFamily="34" charset="-120"/>
+              </a:rPr>
+              <a:t>Ein Sportverein stimmt ab</a:t>
+            </a:r>
+            <a:endParaRPr lang="en-US" sz="3400" dirty="0"/>
+          </a:p>
+        </p:txBody>
+      </p:sp>
+      <p:sp>
+        <p:nvSpPr>
+          <p:cNvPr id="4" name="Text 2"/>
+          <p:cNvSpPr txBox="1"/>
+          <p:nvPr/>
+        </p:nvSpPr>
+        <p:spPr>
+          <a:xfrm>
+            <a:off x="548640" y="6510528"/>
+            <a:ext cx="5486400" cy="228600"/>
+          </a:xfrm>
+          <a:prstGeom prst="rect">
+            <a:avLst/>
+          </a:prstGeom>
+          <a:noFill/>
+          <a:ln/>
+        </p:spPr>
+        <p:txBody>
+          <a:bodyPr wrap="square" lIns="0" tIns="0" rIns="0" bIns="0" rtlCol="0" anchor="t"/>
+          <a:lstStyle/>
+          <a:p>
+            <a:pPr indent="0" marL="0">
+              <a:buNone/>
+            </a:pPr>
+            <a:r>
+              <a:rPr lang="en-US" sz="1000" dirty="0">
+                <a:solidFill>
+                  <a:srgbClr val="5B6B8C"/>
+                </a:solidFill>
+                <a:latin typeface="Calibri" pitchFamily="34" charset="0"/>
+                <a:ea typeface="Calibri" pitchFamily="34" charset="-122"/>
+                <a:cs typeface="Calibri" pitchFamily="34" charset="-120"/>
+              </a:rPr>
+              <a:t>Generalstände · Geschichte 8D</a:t>
+            </a:r>
+            <a:endParaRPr lang="en-US" sz="1000" dirty="0"/>
+          </a:p>
+        </p:txBody>
+      </p:sp>
+      <p:sp>
+        <p:nvSpPr>
+          <p:cNvPr id="5" name="Text 3"/>
+          <p:cNvSpPr txBox="1"/>
+          <p:nvPr/>
+        </p:nvSpPr>
+        <p:spPr>
+          <a:xfrm>
+            <a:off x="11155680" y="6510528"/>
+            <a:ext cx="457200" cy="228600"/>
+          </a:xfrm>
+          <a:prstGeom prst="rect">
+            <a:avLst/>
+          </a:prstGeom>
+          <a:noFill/>
+          <a:ln/>
+        </p:spPr>
+        <p:txBody>
+          <a:bodyPr wrap="square" lIns="0" tIns="0" rIns="0" bIns="0" rtlCol="0" anchor="t"/>
+          <a:lstStyle/>
+          <a:p>
+            <a:pPr algn="r" indent="0" marL="0">
+              <a:buNone/>
+            </a:pPr>
+            <a:r>
+              <a:rPr lang="en-US" sz="1000" dirty="0">
+                <a:solidFill>
+                  <a:srgbClr val="5B6B8C"/>
+                </a:solidFill>
+                <a:latin typeface="Calibri" pitchFamily="34" charset="0"/>
+                <a:ea typeface="Calibri" pitchFamily="34" charset="-122"/>
+                <a:cs typeface="Calibri" pitchFamily="34" charset="-120"/>
+              </a:rPr>
+              <a:t>18</a:t>
             </a:r>
             <a:endParaRPr lang="en-US" sz="1000" dirty="0"/>
           </a:p>

</xml_diff>

<commit_message>
Generalstände 8D: Ü1 als Fehlertext (Vorwissen), Orientierung in CLAUDE.md und Sequenz
Co-Authored-By: Claude Sonnet 5.5 <noreply@anthropic.com>
Claude-Session: https://claude.ai/code/session_01GXwmzpsaCraifErTDddPwN
</commit_message>
<xml_diff>
--- a/Geschichte_8D/Generalstaende/Praesentation_Generalstaende_8D.pptx
+++ b/Geschichte_8D/Generalstaende/Praesentation_Generalstaende_8D.pptx
@@ -1575,7 +1575,7 @@
           <a:p>
             <a:r>
               <a:rPr lang="en-US" dirty="0"/>
-              <a:t>Ansage: „Jetzt arbeitet ihr allein. Die Aufgabe steht rechts.“ Kein Plenumsgespräch. Nach 4 Minuten Folie 5 zeigen. Wiederholung der letzten Stunde (Test): Zahlen und Vorrechte braucht die Klasse gleich im Spiel.</a:t>
+              <a:t>Ansage: „Jetzt arbeitet ihr allein. Die Aufgabe steht rechts.“ Kein Plenumsgespräch. Vier Sätze enthalten je einen Fehler, ein Satz ist richtig. Fehler: 1 (der König regiert allein, nicht mit den Ständen), 2 (die Macht kommt von Gott, Gottesgnadentum), 3 (der Klerus hat etwa 150 000 Mitglieder, nicht 20 Millionen), 4 (Klerus und Adel zahlen keine Steuern). Satz 5 ist richtig. Die Zahlen stammen aus dem Gruppenpuzzle (150 000 / 500 000 / 20 000 000). Wiederholung der letzten Stunde (Test). Die Generalstände kennt die Klasse noch nicht, sie kommen deshalb nicht vor. Nach 4 Minuten Folie 5 zeigen.</a:t>
             </a:r>
             <a:endParaRPr lang="en-US" dirty="0"/>
           </a:p>
@@ -1663,7 +1663,7 @@
           <a:p>
             <a:r>
               <a:rPr lang="en-US" dirty="0"/>
-              <a:t>Ansage: „Vergleicht und verbessert mit Grün.“ 2 Minuten, nicht besprechen. Kontrolle: Klerus ca. 150 000, Adel ca. 500 000, Dritter Stand (Bauern und Bürger) ca. 20 000 000. Klerus und Adel zahlen keine Steuern, die Steuern zahlt der Dritte Stand.</a:t>
+              <a:t>Ansage: „Vergleicht und verbessert mit Grün.“ 2 Minuten, nicht besprechen. Die korrigierten Stellen stehen grün. Satz 5 war richtig. Kurz zum Mitnehmen für die nächste Phase: Klerus und Adel zahlen keine Steuern, der Dritte Stand (Bauern und Bürger) zahlt sie. Bei Unklarheit eine gezielte Abfrage (2 bis 3 Personen), kein Gespräch.</a:t>
             </a:r>
             <a:endParaRPr lang="en-US" dirty="0"/>
           </a:p>
@@ -13573,7 +13573,7 @@
         <p:spPr>
           <a:xfrm>
             <a:off x="548640" y="320040"/>
-            <a:ext cx="7315200" cy="274320"/>
+            <a:ext cx="8229600" cy="274320"/>
           </a:xfrm>
           <a:prstGeom prst="rect">
             <a:avLst/>
@@ -13605,13 +13605,308 @@
       </p:sp>
       <p:sp>
         <p:nvSpPr>
-          <p:cNvPr id="3" name="Text 1"/>
-          <p:cNvSpPr txBox="1"/>
-          <p:nvPr/>
-        </p:nvSpPr>
-        <p:spPr>
-          <a:xfrm>
-            <a:off x="548640" y="594360"/>
+          <p:cNvPr id="3" name="Shape 1"/>
+          <p:cNvSpPr/>
+          <p:nvPr/>
+        </p:nvSpPr>
+        <p:spPr>
+          <a:xfrm>
+            <a:off x="9144000" y="274320"/>
+            <a:ext cx="402336" cy="402336"/>
+          </a:xfrm>
+          <a:prstGeom prst="ellipse">
+            <a:avLst/>
+          </a:prstGeom>
+          <a:solidFill>
+            <a:srgbClr val="EAF0FA"/>
+          </a:solidFill>
+          <a:ln/>
+        </p:spPr>
+      </p:sp>
+      <p:sp>
+        <p:nvSpPr>
+          <p:cNvPr id="4" name="Text 2"/>
+          <p:cNvSpPr txBox="1"/>
+          <p:nvPr/>
+        </p:nvSpPr>
+        <p:spPr>
+          <a:xfrm>
+            <a:off x="9144000" y="274320"/>
+            <a:ext cx="402336" cy="402336"/>
+          </a:xfrm>
+          <a:prstGeom prst="rect">
+            <a:avLst/>
+          </a:prstGeom>
+          <a:noFill/>
+          <a:ln/>
+        </p:spPr>
+        <p:txBody>
+          <a:bodyPr wrap="square" lIns="0" tIns="0" rIns="0" bIns="0" rtlCol="0" anchor="ctr"/>
+          <a:lstStyle/>
+          <a:p>
+            <a:pPr algn="ctr" indent="0" marL="0">
+              <a:buNone/>
+            </a:pPr>
+            <a:r>
+              <a:rPr lang="en-US" sz="1400" b="1" dirty="0">
+                <a:solidFill>
+                  <a:srgbClr val="5B6B8C"/>
+                </a:solidFill>
+                <a:latin typeface="Calibri" pitchFamily="34" charset="0"/>
+                <a:ea typeface="Calibri" pitchFamily="34" charset="-122"/>
+                <a:cs typeface="Calibri" pitchFamily="34" charset="-120"/>
+              </a:rPr>
+              <a:t>A</a:t>
+            </a:r>
+            <a:endParaRPr lang="en-US" sz="1400" dirty="0"/>
+          </a:p>
+        </p:txBody>
+      </p:sp>
+      <p:sp>
+        <p:nvSpPr>
+          <p:cNvPr id="5" name="Shape 3"/>
+          <p:cNvSpPr/>
+          <p:nvPr/>
+        </p:nvSpPr>
+        <p:spPr>
+          <a:xfrm>
+            <a:off x="9646920" y="274320"/>
+            <a:ext cx="402336" cy="402336"/>
+          </a:xfrm>
+          <a:prstGeom prst="ellipse">
+            <a:avLst/>
+          </a:prstGeom>
+          <a:solidFill>
+            <a:srgbClr val="D9534F"/>
+          </a:solidFill>
+          <a:ln/>
+        </p:spPr>
+      </p:sp>
+      <p:sp>
+        <p:nvSpPr>
+          <p:cNvPr id="6" name="Text 4"/>
+          <p:cNvSpPr txBox="1"/>
+          <p:nvPr/>
+        </p:nvSpPr>
+        <p:spPr>
+          <a:xfrm>
+            <a:off x="9646920" y="274320"/>
+            <a:ext cx="402336" cy="402336"/>
+          </a:xfrm>
+          <a:prstGeom prst="rect">
+            <a:avLst/>
+          </a:prstGeom>
+          <a:noFill/>
+          <a:ln/>
+        </p:spPr>
+        <p:txBody>
+          <a:bodyPr wrap="square" lIns="0" tIns="0" rIns="0" bIns="0" rtlCol="0" anchor="ctr"/>
+          <a:lstStyle/>
+          <a:p>
+            <a:pPr algn="ctr" indent="0" marL="0">
+              <a:buNone/>
+            </a:pPr>
+            <a:r>
+              <a:rPr lang="en-US" sz="1400" b="1" dirty="0">
+                <a:solidFill>
+                  <a:srgbClr val="FFFFFF"/>
+                </a:solidFill>
+                <a:latin typeface="Calibri" pitchFamily="34" charset="0"/>
+                <a:ea typeface="Calibri" pitchFamily="34" charset="-122"/>
+                <a:cs typeface="Calibri" pitchFamily="34" charset="-120"/>
+              </a:rPr>
+              <a:t>V</a:t>
+            </a:r>
+            <a:endParaRPr lang="en-US" sz="1400" dirty="0"/>
+          </a:p>
+        </p:txBody>
+      </p:sp>
+      <p:sp>
+        <p:nvSpPr>
+          <p:cNvPr id="7" name="Shape 5"/>
+          <p:cNvSpPr/>
+          <p:nvPr/>
+        </p:nvSpPr>
+        <p:spPr>
+          <a:xfrm>
+            <a:off x="10149840" y="274320"/>
+            <a:ext cx="402336" cy="402336"/>
+          </a:xfrm>
+          <a:prstGeom prst="ellipse">
+            <a:avLst/>
+          </a:prstGeom>
+          <a:solidFill>
+            <a:srgbClr val="EAF0FA"/>
+          </a:solidFill>
+          <a:ln/>
+        </p:spPr>
+      </p:sp>
+      <p:sp>
+        <p:nvSpPr>
+          <p:cNvPr id="8" name="Text 6"/>
+          <p:cNvSpPr txBox="1"/>
+          <p:nvPr/>
+        </p:nvSpPr>
+        <p:spPr>
+          <a:xfrm>
+            <a:off x="10149840" y="274320"/>
+            <a:ext cx="402336" cy="402336"/>
+          </a:xfrm>
+          <a:prstGeom prst="rect">
+            <a:avLst/>
+          </a:prstGeom>
+          <a:noFill/>
+          <a:ln/>
+        </p:spPr>
+        <p:txBody>
+          <a:bodyPr wrap="square" lIns="0" tIns="0" rIns="0" bIns="0" rtlCol="0" anchor="ctr"/>
+          <a:lstStyle/>
+          <a:p>
+            <a:pPr algn="ctr" indent="0" marL="0">
+              <a:buNone/>
+            </a:pPr>
+            <a:r>
+              <a:rPr lang="en-US" sz="1400" b="1" dirty="0">
+                <a:solidFill>
+                  <a:srgbClr val="5B6B8C"/>
+                </a:solidFill>
+                <a:latin typeface="Calibri" pitchFamily="34" charset="0"/>
+                <a:ea typeface="Calibri" pitchFamily="34" charset="-122"/>
+                <a:cs typeface="Calibri" pitchFamily="34" charset="-120"/>
+              </a:rPr>
+              <a:t>I</a:t>
+            </a:r>
+            <a:endParaRPr lang="en-US" sz="1400" dirty="0"/>
+          </a:p>
+        </p:txBody>
+      </p:sp>
+      <p:sp>
+        <p:nvSpPr>
+          <p:cNvPr id="9" name="Shape 7"/>
+          <p:cNvSpPr/>
+          <p:nvPr/>
+        </p:nvSpPr>
+        <p:spPr>
+          <a:xfrm>
+            <a:off x="10652760" y="274320"/>
+            <a:ext cx="402336" cy="402336"/>
+          </a:xfrm>
+          <a:prstGeom prst="ellipse">
+            <a:avLst/>
+          </a:prstGeom>
+          <a:solidFill>
+            <a:srgbClr val="EAF0FA"/>
+          </a:solidFill>
+          <a:ln/>
+        </p:spPr>
+      </p:sp>
+      <p:sp>
+        <p:nvSpPr>
+          <p:cNvPr id="10" name="Text 8"/>
+          <p:cNvSpPr txBox="1"/>
+          <p:nvPr/>
+        </p:nvSpPr>
+        <p:spPr>
+          <a:xfrm>
+            <a:off x="10652760" y="274320"/>
+            <a:ext cx="402336" cy="402336"/>
+          </a:xfrm>
+          <a:prstGeom prst="rect">
+            <a:avLst/>
+          </a:prstGeom>
+          <a:noFill/>
+          <a:ln/>
+        </p:spPr>
+        <p:txBody>
+          <a:bodyPr wrap="square" lIns="0" tIns="0" rIns="0" bIns="0" rtlCol="0" anchor="ctr"/>
+          <a:lstStyle/>
+          <a:p>
+            <a:pPr algn="ctr" indent="0" marL="0">
+              <a:buNone/>
+            </a:pPr>
+            <a:r>
+              <a:rPr lang="en-US" sz="1400" b="1" dirty="0">
+                <a:solidFill>
+                  <a:srgbClr val="5B6B8C"/>
+                </a:solidFill>
+                <a:latin typeface="Calibri" pitchFamily="34" charset="0"/>
+                <a:ea typeface="Calibri" pitchFamily="34" charset="-122"/>
+                <a:cs typeface="Calibri" pitchFamily="34" charset="-120"/>
+              </a:rPr>
+              <a:t>V</a:t>
+            </a:r>
+            <a:endParaRPr lang="en-US" sz="1400" dirty="0"/>
+          </a:p>
+        </p:txBody>
+      </p:sp>
+      <p:sp>
+        <p:nvSpPr>
+          <p:cNvPr id="11" name="Shape 9"/>
+          <p:cNvSpPr/>
+          <p:nvPr/>
+        </p:nvSpPr>
+        <p:spPr>
+          <a:xfrm>
+            <a:off x="11155680" y="274320"/>
+            <a:ext cx="402336" cy="402336"/>
+          </a:xfrm>
+          <a:prstGeom prst="ellipse">
+            <a:avLst/>
+          </a:prstGeom>
+          <a:solidFill>
+            <a:srgbClr val="EAF0FA"/>
+          </a:solidFill>
+          <a:ln/>
+        </p:spPr>
+      </p:sp>
+      <p:sp>
+        <p:nvSpPr>
+          <p:cNvPr id="12" name="Text 10"/>
+          <p:cNvSpPr txBox="1"/>
+          <p:nvPr/>
+        </p:nvSpPr>
+        <p:spPr>
+          <a:xfrm>
+            <a:off x="11155680" y="274320"/>
+            <a:ext cx="402336" cy="402336"/>
+          </a:xfrm>
+          <a:prstGeom prst="rect">
+            <a:avLst/>
+          </a:prstGeom>
+          <a:noFill/>
+          <a:ln/>
+        </p:spPr>
+        <p:txBody>
+          <a:bodyPr wrap="square" lIns="0" tIns="0" rIns="0" bIns="0" rtlCol="0" anchor="ctr"/>
+          <a:lstStyle/>
+          <a:p>
+            <a:pPr algn="ctr" indent="0" marL="0">
+              <a:buNone/>
+            </a:pPr>
+            <a:r>
+              <a:rPr lang="en-US" sz="1400" b="1" dirty="0">
+                <a:solidFill>
+                  <a:srgbClr val="5B6B8C"/>
+                </a:solidFill>
+                <a:latin typeface="Calibri" pitchFamily="34" charset="0"/>
+                <a:ea typeface="Calibri" pitchFamily="34" charset="-122"/>
+                <a:cs typeface="Calibri" pitchFamily="34" charset="-120"/>
+              </a:rPr>
+              <a:t>A</a:t>
+            </a:r>
+            <a:endParaRPr lang="en-US" sz="1400" dirty="0"/>
+          </a:p>
+        </p:txBody>
+      </p:sp>
+      <p:sp>
+        <p:nvSpPr>
+          <p:cNvPr id="13" name="Text 11"/>
+          <p:cNvSpPr txBox="1"/>
+          <p:nvPr/>
+        </p:nvSpPr>
+        <p:spPr>
+          <a:xfrm>
+            <a:off x="548640" y="640080"/>
             <a:ext cx="11064240" cy="685800"/>
           </a:xfrm>
           <a:prstGeom prst="rect">
@@ -13636,7 +13931,7 @@
                 <a:ea typeface="Cambria" pitchFamily="34" charset="-122"/>
                 <a:cs typeface="Cambria" pitchFamily="34" charset="-120"/>
               </a:rPr>
-              <a:t>Die drei Stände</a:t>
+              <a:t>Fehlertext: Absolutismus und Stände</a:t>
             </a:r>
             <a:endParaRPr lang="en-US" sz="3400" dirty="0"/>
           </a:p>
@@ -13644,18 +13939,96 @@
       </p:sp>
       <p:sp>
         <p:nvSpPr>
-          <p:cNvPr id="4" name="Shape 2"/>
+          <p:cNvPr id="14" name="Text 12"/>
+          <p:cNvSpPr txBox="1"/>
+          <p:nvPr/>
+        </p:nvSpPr>
+        <p:spPr>
+          <a:xfrm>
+            <a:off x="548640" y="6510528"/>
+            <a:ext cx="5486400" cy="228600"/>
+          </a:xfrm>
+          <a:prstGeom prst="rect">
+            <a:avLst/>
+          </a:prstGeom>
+          <a:noFill/>
+          <a:ln/>
+        </p:spPr>
+        <p:txBody>
+          <a:bodyPr wrap="square" lIns="0" tIns="0" rIns="0" bIns="0" rtlCol="0" anchor="t"/>
+          <a:lstStyle/>
+          <a:p>
+            <a:pPr indent="0" marL="0">
+              <a:buNone/>
+            </a:pPr>
+            <a:r>
+              <a:rPr lang="en-US" sz="1000" dirty="0">
+                <a:solidFill>
+                  <a:srgbClr val="5B6B8C"/>
+                </a:solidFill>
+                <a:latin typeface="Calibri" pitchFamily="34" charset="0"/>
+                <a:ea typeface="Calibri" pitchFamily="34" charset="-122"/>
+                <a:cs typeface="Calibri" pitchFamily="34" charset="-120"/>
+              </a:rPr>
+              <a:t>Generalstände · Geschichte 8D</a:t>
+            </a:r>
+            <a:endParaRPr lang="en-US" sz="1000" dirty="0"/>
+          </a:p>
+        </p:txBody>
+      </p:sp>
+      <p:sp>
+        <p:nvSpPr>
+          <p:cNvPr id="15" name="Text 13"/>
+          <p:cNvSpPr txBox="1"/>
+          <p:nvPr/>
+        </p:nvSpPr>
+        <p:spPr>
+          <a:xfrm>
+            <a:off x="11155680" y="6510528"/>
+            <a:ext cx="457200" cy="228600"/>
+          </a:xfrm>
+          <a:prstGeom prst="rect">
+            <a:avLst/>
+          </a:prstGeom>
+          <a:noFill/>
+          <a:ln/>
+        </p:spPr>
+        <p:txBody>
+          <a:bodyPr wrap="square" lIns="0" tIns="0" rIns="0" bIns="0" rtlCol="0" anchor="t"/>
+          <a:lstStyle/>
+          <a:p>
+            <a:pPr algn="r" indent="0" marL="0">
+              <a:buNone/>
+            </a:pPr>
+            <a:r>
+              <a:rPr lang="en-US" sz="1000" dirty="0">
+                <a:solidFill>
+                  <a:srgbClr val="5B6B8C"/>
+                </a:solidFill>
+                <a:latin typeface="Calibri" pitchFamily="34" charset="0"/>
+                <a:ea typeface="Calibri" pitchFamily="34" charset="-122"/>
+                <a:cs typeface="Calibri" pitchFamily="34" charset="-120"/>
+              </a:rPr>
+              <a:t>4</a:t>
+            </a:r>
+            <a:endParaRPr lang="en-US" sz="1000" dirty="0"/>
+          </a:p>
+        </p:txBody>
+      </p:sp>
+      <p:sp>
+        <p:nvSpPr>
+          <p:cNvPr id="17" name="Shape 14"/>
           <p:cNvSpPr/>
           <p:nvPr/>
         </p:nvSpPr>
         <p:spPr>
           <a:xfrm>
             <a:off x="548640" y="1371600"/>
-            <a:ext cx="11109960" cy="3090672"/>
+            <a:ext cx="11109960" cy="3246120"/>
           </a:xfrm>
           <a:prstGeom prst="roundRect">
             <a:avLst>
-              <a:gd name="adj" fmla="val 2367"/>
+              <a:gd name="adj" fmla="val 2254"/>
             </a:avLst>
           </a:prstGeom>
           <a:solidFill>
@@ -13666,14 +14039,14 @@
       </p:sp>
       <p:sp>
         <p:nvSpPr>
-          <p:cNvPr id="5" name="Shape 3"/>
-          <p:cNvSpPr/>
-          <p:nvPr/>
-        </p:nvSpPr>
-        <p:spPr>
-          <a:xfrm>
-            <a:off x="731520" y="1517904"/>
-            <a:ext cx="384048" cy="384048"/>
+          <p:cNvPr id="18" name="Shape 15"/>
+          <p:cNvSpPr/>
+          <p:nvPr/>
+        </p:nvSpPr>
+        <p:spPr>
+          <a:xfrm>
+            <a:off x="777240" y="1554480"/>
+            <a:ext cx="365760" cy="365760"/>
           </a:xfrm>
           <a:prstGeom prst="ellipse">
             <a:avLst/>
@@ -13686,14 +14059,14 @@
       </p:sp>
       <p:sp>
         <p:nvSpPr>
-          <p:cNvPr id="6" name="Text 4"/>
-          <p:cNvSpPr txBox="1"/>
-          <p:nvPr/>
-        </p:nvSpPr>
-        <p:spPr>
-          <a:xfrm>
-            <a:off x="731520" y="1517904"/>
-            <a:ext cx="384048" cy="384048"/>
+          <p:cNvPr id="19" name="Text 16"/>
+          <p:cNvSpPr txBox="1"/>
+          <p:nvPr/>
+        </p:nvSpPr>
+        <p:spPr>
+          <a:xfrm>
+            <a:off x="777240" y="1554480"/>
+            <a:ext cx="365760" cy="365760"/>
           </a:xfrm>
           <a:prstGeom prst="rect">
             <a:avLst/>
@@ -13725,29 +14098,519 @@
       </p:sp>
       <p:sp>
         <p:nvSpPr>
-          <p:cNvPr id="7" name="Text 5"/>
-          <p:cNvSpPr txBox="1"/>
-          <p:nvPr/>
-        </p:nvSpPr>
-        <p:spPr>
-          <a:xfrm>
-            <a:off x="1280160" y="1481328"/>
-            <a:ext cx="10241280" cy="457200"/>
-          </a:xfrm>
-          <a:prstGeom prst="rect">
-            <a:avLst/>
-          </a:prstGeom>
-          <a:noFill/>
-          <a:ln/>
-        </p:spPr>
-        <p:txBody>
-          <a:bodyPr wrap="square" lIns="0" tIns="0" rIns="0" bIns="0" rtlCol="0" anchor="t"/>
+          <p:cNvPr id="20" name="Text 17"/>
+          <p:cNvSpPr txBox="1"/>
+          <p:nvPr/>
+        </p:nvSpPr>
+        <p:spPr>
+          <a:xfrm>
+            <a:off x="1371600" y="1481328"/>
+            <a:ext cx="10149840" cy="530352"/>
+          </a:xfrm>
+          <a:prstGeom prst="rect">
+            <a:avLst/>
+          </a:prstGeom>
+          <a:noFill/>
+          <a:ln/>
+        </p:spPr>
+        <p:txBody>
+          <a:bodyPr wrap="square" lIns="0" tIns="0" rIns="0" bIns="0" rtlCol="0" anchor="ctr"/>
           <a:lstStyle/>
           <a:p>
             <a:pPr indent="0" marL="0">
               <a:buNone/>
             </a:pPr>
             <a:r>
+              <a:rPr lang="en-US" sz="2400" dirty="0">
+                <a:solidFill>
+                  <a:srgbClr val="1E2761"/>
+                </a:solidFill>
+                <a:latin typeface="Cambria" pitchFamily="34" charset="0"/>
+                <a:ea typeface="Cambria" pitchFamily="34" charset="-122"/>
+                <a:cs typeface="Cambria" pitchFamily="34" charset="-120"/>
+              </a:rPr>
+              <a:t>Ludwig XIV. war der Sonnenkönig und regierte im Absolutismus gemeinsam mit den Ständen.</a:t>
+            </a:r>
+            <a:endParaRPr lang="en-US" sz="2400" dirty="0"/>
+          </a:p>
+        </p:txBody>
+      </p:sp>
+      <p:sp>
+        <p:nvSpPr>
+          <p:cNvPr id="21" name="Shape 18"/>
+          <p:cNvSpPr/>
+          <p:nvPr/>
+        </p:nvSpPr>
+        <p:spPr>
+          <a:xfrm>
+            <a:off x="777240" y="2157984"/>
+            <a:ext cx="365760" cy="365760"/>
+          </a:xfrm>
+          <a:prstGeom prst="ellipse">
+            <a:avLst/>
+          </a:prstGeom>
+          <a:solidFill>
+            <a:srgbClr val="1E2761"/>
+          </a:solidFill>
+          <a:ln/>
+        </p:spPr>
+      </p:sp>
+      <p:sp>
+        <p:nvSpPr>
+          <p:cNvPr id="22" name="Text 19"/>
+          <p:cNvSpPr txBox="1"/>
+          <p:nvPr/>
+        </p:nvSpPr>
+        <p:spPr>
+          <a:xfrm>
+            <a:off x="777240" y="2157984"/>
+            <a:ext cx="365760" cy="365760"/>
+          </a:xfrm>
+          <a:prstGeom prst="rect">
+            <a:avLst/>
+          </a:prstGeom>
+          <a:noFill/>
+          <a:ln/>
+        </p:spPr>
+        <p:txBody>
+          <a:bodyPr wrap="square" lIns="0" tIns="0" rIns="0" bIns="0" rtlCol="0" anchor="ctr"/>
+          <a:lstStyle/>
+          <a:p>
+            <a:pPr algn="ctr" indent="0" marL="0">
+              <a:buNone/>
+            </a:pPr>
+            <a:r>
+              <a:rPr lang="en-US" sz="1800" b="1" dirty="0">
+                <a:solidFill>
+                  <a:srgbClr val="FFFFFF"/>
+                </a:solidFill>
+                <a:latin typeface="Calibri" pitchFamily="34" charset="0"/>
+                <a:ea typeface="Calibri" pitchFamily="34" charset="-122"/>
+                <a:cs typeface="Calibri" pitchFamily="34" charset="-120"/>
+              </a:rPr>
+              <a:t>2</a:t>
+            </a:r>
+            <a:endParaRPr lang="en-US" sz="1800" dirty="0"/>
+          </a:p>
+        </p:txBody>
+      </p:sp>
+      <p:sp>
+        <p:nvSpPr>
+          <p:cNvPr id="23" name="Text 20"/>
+          <p:cNvSpPr txBox="1"/>
+          <p:nvPr/>
+        </p:nvSpPr>
+        <p:spPr>
+          <a:xfrm>
+            <a:off x="1371600" y="2084832"/>
+            <a:ext cx="10149840" cy="530352"/>
+          </a:xfrm>
+          <a:prstGeom prst="rect">
+            <a:avLst/>
+          </a:prstGeom>
+          <a:noFill/>
+          <a:ln/>
+        </p:spPr>
+        <p:txBody>
+          <a:bodyPr wrap="square" lIns="0" tIns="0" rIns="0" bIns="0" rtlCol="0" anchor="ctr"/>
+          <a:lstStyle/>
+          <a:p>
+            <a:pPr indent="0" marL="0">
+              <a:buNone/>
+            </a:pPr>
+            <a:r>
+              <a:rPr lang="en-US" sz="2400" dirty="0">
+                <a:solidFill>
+                  <a:srgbClr val="1E2761"/>
+                </a:solidFill>
+                <a:latin typeface="Cambria" pitchFamily="34" charset="0"/>
+                <a:ea typeface="Cambria" pitchFamily="34" charset="-122"/>
+                <a:cs typeface="Cambria" pitchFamily="34" charset="-120"/>
+              </a:rPr>
+              <a:t>Seine Macht komme vom Volk, sagte er (Gottesgnadentum).</a:t>
+            </a:r>
+            <a:endParaRPr lang="en-US" sz="2400" dirty="0"/>
+          </a:p>
+        </p:txBody>
+      </p:sp>
+      <p:sp>
+        <p:nvSpPr>
+          <p:cNvPr id="24" name="Shape 21"/>
+          <p:cNvSpPr/>
+          <p:nvPr/>
+        </p:nvSpPr>
+        <p:spPr>
+          <a:xfrm>
+            <a:off x="777240" y="2761488"/>
+            <a:ext cx="365760" cy="365760"/>
+          </a:xfrm>
+          <a:prstGeom prst="ellipse">
+            <a:avLst/>
+          </a:prstGeom>
+          <a:solidFill>
+            <a:srgbClr val="1E2761"/>
+          </a:solidFill>
+          <a:ln/>
+        </p:spPr>
+      </p:sp>
+      <p:sp>
+        <p:nvSpPr>
+          <p:cNvPr id="25" name="Text 22"/>
+          <p:cNvSpPr txBox="1"/>
+          <p:nvPr/>
+        </p:nvSpPr>
+        <p:spPr>
+          <a:xfrm>
+            <a:off x="777240" y="2761488"/>
+            <a:ext cx="365760" cy="365760"/>
+          </a:xfrm>
+          <a:prstGeom prst="rect">
+            <a:avLst/>
+          </a:prstGeom>
+          <a:noFill/>
+          <a:ln/>
+        </p:spPr>
+        <p:txBody>
+          <a:bodyPr wrap="square" lIns="0" tIns="0" rIns="0" bIns="0" rtlCol="0" anchor="ctr"/>
+          <a:lstStyle/>
+          <a:p>
+            <a:pPr algn="ctr" indent="0" marL="0">
+              <a:buNone/>
+            </a:pPr>
+            <a:r>
+              <a:rPr lang="en-US" sz="1800" b="1" dirty="0">
+                <a:solidFill>
+                  <a:srgbClr val="FFFFFF"/>
+                </a:solidFill>
+                <a:latin typeface="Calibri" pitchFamily="34" charset="0"/>
+                <a:ea typeface="Calibri" pitchFamily="34" charset="-122"/>
+                <a:cs typeface="Calibri" pitchFamily="34" charset="-120"/>
+              </a:rPr>
+              <a:t>3</a:t>
+            </a:r>
+            <a:endParaRPr lang="en-US" sz="1800" dirty="0"/>
+          </a:p>
+        </p:txBody>
+      </p:sp>
+      <p:sp>
+        <p:nvSpPr>
+          <p:cNvPr id="26" name="Text 23"/>
+          <p:cNvSpPr txBox="1"/>
+          <p:nvPr/>
+        </p:nvSpPr>
+        <p:spPr>
+          <a:xfrm>
+            <a:off x="1371600" y="2688336"/>
+            <a:ext cx="10149840" cy="530352"/>
+          </a:xfrm>
+          <a:prstGeom prst="rect">
+            <a:avLst/>
+          </a:prstGeom>
+          <a:noFill/>
+          <a:ln/>
+        </p:spPr>
+        <p:txBody>
+          <a:bodyPr wrap="square" lIns="0" tIns="0" rIns="0" bIns="0" rtlCol="0" anchor="ctr"/>
+          <a:lstStyle/>
+          <a:p>
+            <a:pPr indent="0" marL="0">
+              <a:buNone/>
+            </a:pPr>
+            <a:r>
+              <a:rPr lang="en-US" sz="2400" dirty="0">
+                <a:solidFill>
+                  <a:srgbClr val="1E2761"/>
+                </a:solidFill>
+                <a:latin typeface="Cambria" pitchFamily="34" charset="0"/>
+                <a:ea typeface="Cambria" pitchFamily="34" charset="-122"/>
+                <a:cs typeface="Cambria" pitchFamily="34" charset="-120"/>
+              </a:rPr>
+              <a:t>Zum Klerus gehörten etwa 20 Millionen Menschen, zum Adel etwa 500 000.</a:t>
+            </a:r>
+            <a:endParaRPr lang="en-US" sz="2400" dirty="0"/>
+          </a:p>
+        </p:txBody>
+      </p:sp>
+      <p:sp>
+        <p:nvSpPr>
+          <p:cNvPr id="27" name="Shape 24"/>
+          <p:cNvSpPr/>
+          <p:nvPr/>
+        </p:nvSpPr>
+        <p:spPr>
+          <a:xfrm>
+            <a:off x="777240" y="3364992"/>
+            <a:ext cx="365760" cy="365760"/>
+          </a:xfrm>
+          <a:prstGeom prst="ellipse">
+            <a:avLst/>
+          </a:prstGeom>
+          <a:solidFill>
+            <a:srgbClr val="1E2761"/>
+          </a:solidFill>
+          <a:ln/>
+        </p:spPr>
+      </p:sp>
+      <p:sp>
+        <p:nvSpPr>
+          <p:cNvPr id="28" name="Text 25"/>
+          <p:cNvSpPr txBox="1"/>
+          <p:nvPr/>
+        </p:nvSpPr>
+        <p:spPr>
+          <a:xfrm>
+            <a:off x="777240" y="3364992"/>
+            <a:ext cx="365760" cy="365760"/>
+          </a:xfrm>
+          <a:prstGeom prst="rect">
+            <a:avLst/>
+          </a:prstGeom>
+          <a:noFill/>
+          <a:ln/>
+        </p:spPr>
+        <p:txBody>
+          <a:bodyPr wrap="square" lIns="0" tIns="0" rIns="0" bIns="0" rtlCol="0" anchor="ctr"/>
+          <a:lstStyle/>
+          <a:p>
+            <a:pPr algn="ctr" indent="0" marL="0">
+              <a:buNone/>
+            </a:pPr>
+            <a:r>
+              <a:rPr lang="en-US" sz="1800" b="1" dirty="0">
+                <a:solidFill>
+                  <a:srgbClr val="FFFFFF"/>
+                </a:solidFill>
+                <a:latin typeface="Calibri" pitchFamily="34" charset="0"/>
+                <a:ea typeface="Calibri" pitchFamily="34" charset="-122"/>
+                <a:cs typeface="Calibri" pitchFamily="34" charset="-120"/>
+              </a:rPr>
+              <a:t>4</a:t>
+            </a:r>
+            <a:endParaRPr lang="en-US" sz="1800" dirty="0"/>
+          </a:p>
+        </p:txBody>
+      </p:sp>
+      <p:sp>
+        <p:nvSpPr>
+          <p:cNvPr id="29" name="Text 26"/>
+          <p:cNvSpPr txBox="1"/>
+          <p:nvPr/>
+        </p:nvSpPr>
+        <p:spPr>
+          <a:xfrm>
+            <a:off x="1371600" y="3291840"/>
+            <a:ext cx="10149840" cy="530352"/>
+          </a:xfrm>
+          <a:prstGeom prst="rect">
+            <a:avLst/>
+          </a:prstGeom>
+          <a:noFill/>
+          <a:ln/>
+        </p:spPr>
+        <p:txBody>
+          <a:bodyPr wrap="square" lIns="0" tIns="0" rIns="0" bIns="0" rtlCol="0" anchor="ctr"/>
+          <a:lstStyle/>
+          <a:p>
+            <a:pPr indent="0" marL="0">
+              <a:buNone/>
+            </a:pPr>
+            <a:r>
+              <a:rPr lang="en-US" sz="2400" dirty="0">
+                <a:solidFill>
+                  <a:srgbClr val="1E2761"/>
+                </a:solidFill>
+                <a:latin typeface="Cambria" pitchFamily="34" charset="0"/>
+                <a:ea typeface="Cambria" pitchFamily="34" charset="-122"/>
+                <a:cs typeface="Cambria" pitchFamily="34" charset="-120"/>
+              </a:rPr>
+              <a:t>Klerus und Adel zahlten die meisten Steuern.</a:t>
+            </a:r>
+            <a:endParaRPr lang="en-US" sz="2400" dirty="0"/>
+          </a:p>
+        </p:txBody>
+      </p:sp>
+      <p:sp>
+        <p:nvSpPr>
+          <p:cNvPr id="30" name="Shape 27"/>
+          <p:cNvSpPr/>
+          <p:nvPr/>
+        </p:nvSpPr>
+        <p:spPr>
+          <a:xfrm>
+            <a:off x="777240" y="3968496"/>
+            <a:ext cx="365760" cy="365760"/>
+          </a:xfrm>
+          <a:prstGeom prst="ellipse">
+            <a:avLst/>
+          </a:prstGeom>
+          <a:solidFill>
+            <a:srgbClr val="1E2761"/>
+          </a:solidFill>
+          <a:ln/>
+        </p:spPr>
+      </p:sp>
+      <p:sp>
+        <p:nvSpPr>
+          <p:cNvPr id="31" name="Text 28"/>
+          <p:cNvSpPr txBox="1"/>
+          <p:nvPr/>
+        </p:nvSpPr>
+        <p:spPr>
+          <a:xfrm>
+            <a:off x="777240" y="3968496"/>
+            <a:ext cx="365760" cy="365760"/>
+          </a:xfrm>
+          <a:prstGeom prst="rect">
+            <a:avLst/>
+          </a:prstGeom>
+          <a:noFill/>
+          <a:ln/>
+        </p:spPr>
+        <p:txBody>
+          <a:bodyPr wrap="square" lIns="0" tIns="0" rIns="0" bIns="0" rtlCol="0" anchor="ctr"/>
+          <a:lstStyle/>
+          <a:p>
+            <a:pPr algn="ctr" indent="0" marL="0">
+              <a:buNone/>
+            </a:pPr>
+            <a:r>
+              <a:rPr lang="en-US" sz="1800" b="1" dirty="0">
+                <a:solidFill>
+                  <a:srgbClr val="FFFFFF"/>
+                </a:solidFill>
+                <a:latin typeface="Calibri" pitchFamily="34" charset="0"/>
+                <a:ea typeface="Calibri" pitchFamily="34" charset="-122"/>
+                <a:cs typeface="Calibri" pitchFamily="34" charset="-120"/>
+              </a:rPr>
+              <a:t>5</a:t>
+            </a:r>
+            <a:endParaRPr lang="en-US" sz="1800" dirty="0"/>
+          </a:p>
+        </p:txBody>
+      </p:sp>
+      <p:sp>
+        <p:nvSpPr>
+          <p:cNvPr id="32" name="Text 29"/>
+          <p:cNvSpPr txBox="1"/>
+          <p:nvPr/>
+        </p:nvSpPr>
+        <p:spPr>
+          <a:xfrm>
+            <a:off x="1371600" y="3895344"/>
+            <a:ext cx="10149840" cy="530352"/>
+          </a:xfrm>
+          <a:prstGeom prst="rect">
+            <a:avLst/>
+          </a:prstGeom>
+          <a:noFill/>
+          <a:ln/>
+        </p:spPr>
+        <p:txBody>
+          <a:bodyPr wrap="square" lIns="0" tIns="0" rIns="0" bIns="0" rtlCol="0" anchor="ctr"/>
+          <a:lstStyle/>
+          <a:p>
+            <a:pPr indent="0" marL="0">
+              <a:buNone/>
+            </a:pPr>
+            <a:r>
+              <a:rPr lang="en-US" sz="2400" dirty="0">
+                <a:solidFill>
+                  <a:srgbClr val="1E2761"/>
+                </a:solidFill>
+                <a:latin typeface="Cambria" pitchFamily="34" charset="0"/>
+                <a:ea typeface="Cambria" pitchFamily="34" charset="-122"/>
+                <a:cs typeface="Cambria" pitchFamily="34" charset="-120"/>
+              </a:rPr>
+              <a:t>Der Dritte Stand (Bauern und Bürger) hatte kaum Vorrechte.</a:t>
+            </a:r>
+            <a:endParaRPr lang="en-US" sz="2400" dirty="0"/>
+          </a:p>
+        </p:txBody>
+      </p:sp>
+      <p:sp>
+        <p:nvSpPr>
+          <p:cNvPr id="33" name="Shape 30"/>
+          <p:cNvSpPr/>
+          <p:nvPr/>
+        </p:nvSpPr>
+        <p:spPr>
+          <a:xfrm>
+            <a:off x="777240" y="4846320"/>
+            <a:ext cx="347472" cy="347472"/>
+          </a:xfrm>
+          <a:prstGeom prst="ellipse">
+            <a:avLst/>
+          </a:prstGeom>
+          <a:solidFill>
+            <a:srgbClr val="D9534F"/>
+          </a:solidFill>
+          <a:ln/>
+        </p:spPr>
+      </p:sp>
+      <p:sp>
+        <p:nvSpPr>
+          <p:cNvPr id="34" name="Text 31"/>
+          <p:cNvSpPr txBox="1"/>
+          <p:nvPr/>
+        </p:nvSpPr>
+        <p:spPr>
+          <a:xfrm>
+            <a:off x="777240" y="4846320"/>
+            <a:ext cx="347472" cy="347472"/>
+          </a:xfrm>
+          <a:prstGeom prst="rect">
+            <a:avLst/>
+          </a:prstGeom>
+          <a:noFill/>
+          <a:ln/>
+        </p:spPr>
+        <p:txBody>
+          <a:bodyPr wrap="square" lIns="0" tIns="0" rIns="0" bIns="0" rtlCol="0" anchor="ctr"/>
+          <a:lstStyle/>
+          <a:p>
+            <a:pPr algn="ctr" indent="0" marL="0">
+              <a:buNone/>
+            </a:pPr>
+            <a:r>
+              <a:rPr lang="en-US" sz="1800" b="1" dirty="0">
+                <a:solidFill>
+                  <a:srgbClr val="FFFFFF"/>
+                </a:solidFill>
+                <a:latin typeface="Calibri" pitchFamily="34" charset="0"/>
+                <a:ea typeface="Calibri" pitchFamily="34" charset="-122"/>
+                <a:cs typeface="Calibri" pitchFamily="34" charset="-120"/>
+              </a:rPr>
+              <a:t>1</a:t>
+            </a:r>
+            <a:endParaRPr lang="en-US" sz="1800" dirty="0"/>
+          </a:p>
+        </p:txBody>
+      </p:sp>
+      <p:sp>
+        <p:nvSpPr>
+          <p:cNvPr id="35" name="Text 32"/>
+          <p:cNvSpPr txBox="1"/>
+          <p:nvPr/>
+        </p:nvSpPr>
+        <p:spPr>
+          <a:xfrm>
+            <a:off x="1371600" y="4800600"/>
+            <a:ext cx="10149840" cy="411480"/>
+          </a:xfrm>
+          <a:prstGeom prst="rect">
+            <a:avLst/>
+          </a:prstGeom>
+          <a:noFill/>
+          <a:ln/>
+        </p:spPr>
+        <p:txBody>
+          <a:bodyPr wrap="square" lIns="0" tIns="0" rIns="0" bIns="0" rtlCol="0" anchor="ctr"/>
+          <a:lstStyle/>
+          <a:p>
+            <a:pPr indent="0" marL="0">
+              <a:buNone/>
+            </a:pPr>
+            <a:r>
               <a:rPr lang="en-US" sz="2400" b="1" dirty="0">
                 <a:solidFill>
                   <a:srgbClr val="1E2761"/>
@@ -13756,7 +14619,7 @@
                 <a:ea typeface="Calibri" pitchFamily="34" charset="-122"/>
                 <a:cs typeface="Calibri" pitchFamily="34" charset="-120"/>
               </a:rPr>
-              <a:t>Schreibe die drei Stände untereinander ins Heft.</a:t>
+              <a:t>Vier Sätze enthalten einen Fehler. Unterstreiche die Fehler.</a:t>
             </a:r>
             <a:endParaRPr lang="en-US" sz="2400" dirty="0"/>
           </a:p>
@@ -13764,34 +14627,34 @@
       </p:sp>
       <p:sp>
         <p:nvSpPr>
-          <p:cNvPr id="8" name="Shape 6"/>
-          <p:cNvSpPr/>
-          <p:nvPr/>
-        </p:nvSpPr>
-        <p:spPr>
-          <a:xfrm>
-            <a:off x="731520" y="2048256"/>
-            <a:ext cx="384048" cy="384048"/>
+          <p:cNvPr id="36" name="Shape 33"/>
+          <p:cNvSpPr/>
+          <p:nvPr/>
+        </p:nvSpPr>
+        <p:spPr>
+          <a:xfrm>
+            <a:off x="777240" y="5257800"/>
+            <a:ext cx="347472" cy="347472"/>
           </a:xfrm>
           <a:prstGeom prst="ellipse">
             <a:avLst/>
           </a:prstGeom>
           <a:solidFill>
-            <a:srgbClr val="1E2761"/>
-          </a:solidFill>
-          <a:ln/>
-        </p:spPr>
-      </p:sp>
-      <p:sp>
-        <p:nvSpPr>
-          <p:cNvPr id="9" name="Text 7"/>
-          <p:cNvSpPr txBox="1"/>
-          <p:nvPr/>
-        </p:nvSpPr>
-        <p:spPr>
-          <a:xfrm>
-            <a:off x="731520" y="2048256"/>
-            <a:ext cx="384048" cy="384048"/>
+            <a:srgbClr val="D9534F"/>
+          </a:solidFill>
+          <a:ln/>
+        </p:spPr>
+      </p:sp>
+      <p:sp>
+        <p:nvSpPr>
+          <p:cNvPr id="37" name="Text 34"/>
+          <p:cNvSpPr txBox="1"/>
+          <p:nvPr/>
+        </p:nvSpPr>
+        <p:spPr>
+          <a:xfrm>
+            <a:off x="777240" y="5257800"/>
+            <a:ext cx="347472" cy="347472"/>
           </a:xfrm>
           <a:prstGeom prst="rect">
             <a:avLst/>
@@ -13823,23 +14686,23 @@
       </p:sp>
       <p:sp>
         <p:nvSpPr>
-          <p:cNvPr id="10" name="Text 8"/>
-          <p:cNvSpPr txBox="1"/>
-          <p:nvPr/>
-        </p:nvSpPr>
-        <p:spPr>
-          <a:xfrm>
-            <a:off x="1280160" y="2011680"/>
-            <a:ext cx="10241280" cy="868680"/>
-          </a:xfrm>
-          <a:prstGeom prst="rect">
-            <a:avLst/>
-          </a:prstGeom>
-          <a:noFill/>
-          <a:ln/>
-        </p:spPr>
-        <p:txBody>
-          <a:bodyPr wrap="square" lIns="0" tIns="0" rIns="0" bIns="0" rtlCol="0" anchor="t"/>
+          <p:cNvPr id="38" name="Text 35"/>
+          <p:cNvSpPr txBox="1"/>
+          <p:nvPr/>
+        </p:nvSpPr>
+        <p:spPr>
+          <a:xfrm>
+            <a:off x="1371600" y="5212080"/>
+            <a:ext cx="10149840" cy="411480"/>
+          </a:xfrm>
+          <a:prstGeom prst="rect">
+            <a:avLst/>
+          </a:prstGeom>
+          <a:noFill/>
+          <a:ln/>
+        </p:spPr>
+        <p:txBody>
+          <a:bodyPr wrap="square" lIns="0" tIns="0" rIns="0" bIns="0" rtlCol="0" anchor="ctr"/>
           <a:lstStyle/>
           <a:p>
             <a:pPr indent="0" marL="0">
@@ -13854,7 +14717,7 @@
                 <a:ea typeface="Calibri" pitchFamily="34" charset="-122"/>
                 <a:cs typeface="Calibri" pitchFamily="34" charset="-120"/>
               </a:rPr>
-              <a:t>Schreibe dazu die Zahl der Menschen: 150 000 · 500 000 · 20 000 000.</a:t>
+              <a:t>Schreibe diese Sätze richtig ins Heft.</a:t>
             </a:r>
             <a:endParaRPr lang="en-US" sz="2400" dirty="0"/>
           </a:p>
@@ -13862,203 +14725,7 @@
       </p:sp>
       <p:sp>
         <p:nvSpPr>
-          <p:cNvPr id="11" name="Shape 9"/>
-          <p:cNvSpPr/>
-          <p:nvPr/>
-        </p:nvSpPr>
-        <p:spPr>
-          <a:xfrm>
-            <a:off x="731520" y="2990088"/>
-            <a:ext cx="384048" cy="384048"/>
-          </a:xfrm>
-          <a:prstGeom prst="ellipse">
-            <a:avLst/>
-          </a:prstGeom>
-          <a:solidFill>
-            <a:srgbClr val="1E2761"/>
-          </a:solidFill>
-          <a:ln/>
-        </p:spPr>
-      </p:sp>
-      <p:sp>
-        <p:nvSpPr>
-          <p:cNvPr id="12" name="Text 10"/>
-          <p:cNvSpPr txBox="1"/>
-          <p:nvPr/>
-        </p:nvSpPr>
-        <p:spPr>
-          <a:xfrm>
-            <a:off x="731520" y="2990088"/>
-            <a:ext cx="384048" cy="384048"/>
-          </a:xfrm>
-          <a:prstGeom prst="rect">
-            <a:avLst/>
-          </a:prstGeom>
-          <a:noFill/>
-          <a:ln/>
-        </p:spPr>
-        <p:txBody>
-          <a:bodyPr wrap="square" lIns="0" tIns="0" rIns="0" bIns="0" rtlCol="0" anchor="ctr"/>
-          <a:lstStyle/>
-          <a:p>
-            <a:pPr algn="ctr" indent="0" marL="0">
-              <a:buNone/>
-            </a:pPr>
-            <a:r>
-              <a:rPr lang="en-US" sz="1800" b="1" dirty="0">
-                <a:solidFill>
-                  <a:srgbClr val="FFFFFF"/>
-                </a:solidFill>
-                <a:latin typeface="Calibri" pitchFamily="34" charset="0"/>
-                <a:ea typeface="Calibri" pitchFamily="34" charset="-122"/>
-                <a:cs typeface="Calibri" pitchFamily="34" charset="-120"/>
-              </a:rPr>
-              <a:t>3</a:t>
-            </a:r>
-            <a:endParaRPr lang="en-US" sz="1800" dirty="0"/>
-          </a:p>
-        </p:txBody>
-      </p:sp>
-      <p:sp>
-        <p:nvSpPr>
-          <p:cNvPr id="13" name="Text 11"/>
-          <p:cNvSpPr txBox="1"/>
-          <p:nvPr/>
-        </p:nvSpPr>
-        <p:spPr>
-          <a:xfrm>
-            <a:off x="1280160" y="2953512"/>
-            <a:ext cx="10241280" cy="868680"/>
-          </a:xfrm>
-          <a:prstGeom prst="rect">
-            <a:avLst/>
-          </a:prstGeom>
-          <a:noFill/>
-          <a:ln/>
-        </p:spPr>
-        <p:txBody>
-          <a:bodyPr wrap="square" lIns="0" tIns="0" rIns="0" bIns="0" rtlCol="0" anchor="t"/>
-          <a:lstStyle/>
-          <a:p>
-            <a:pPr indent="0" marL="0">
-              <a:buNone/>
-            </a:pPr>
-            <a:r>
-              <a:rPr lang="en-US" sz="2400" b="1" dirty="0">
-                <a:solidFill>
-                  <a:srgbClr val="1E2761"/>
-                </a:solidFill>
-                <a:latin typeface="Calibri" pitchFamily="34" charset="0"/>
-                <a:ea typeface="Calibri" pitchFamily="34" charset="-122"/>
-                <a:cs typeface="Calibri" pitchFamily="34" charset="-120"/>
-              </a:rPr>
-              <a:t>Schreibe hinter die beiden Stände mit Vorrechten: „zahlt keine Steuern“.</a:t>
-            </a:r>
-            <a:endParaRPr lang="en-US" sz="2400" dirty="0"/>
-          </a:p>
-        </p:txBody>
-      </p:sp>
-      <p:sp>
-        <p:nvSpPr>
-          <p:cNvPr id="14" name="Shape 12"/>
-          <p:cNvSpPr/>
-          <p:nvPr/>
-        </p:nvSpPr>
-        <p:spPr>
-          <a:xfrm>
-            <a:off x="731520" y="3931920"/>
-            <a:ext cx="384048" cy="384048"/>
-          </a:xfrm>
-          <a:prstGeom prst="ellipse">
-            <a:avLst/>
-          </a:prstGeom>
-          <a:solidFill>
-            <a:srgbClr val="1E2761"/>
-          </a:solidFill>
-          <a:ln/>
-        </p:spPr>
-      </p:sp>
-      <p:sp>
-        <p:nvSpPr>
-          <p:cNvPr id="15" name="Text 13"/>
-          <p:cNvSpPr txBox="1"/>
-          <p:nvPr/>
-        </p:nvSpPr>
-        <p:spPr>
-          <a:xfrm>
-            <a:off x="731520" y="3931920"/>
-            <a:ext cx="384048" cy="384048"/>
-          </a:xfrm>
-          <a:prstGeom prst="rect">
-            <a:avLst/>
-          </a:prstGeom>
-          <a:noFill/>
-          <a:ln/>
-        </p:spPr>
-        <p:txBody>
-          <a:bodyPr wrap="square" lIns="0" tIns="0" rIns="0" bIns="0" rtlCol="0" anchor="ctr"/>
-          <a:lstStyle/>
-          <a:p>
-            <a:pPr algn="ctr" indent="0" marL="0">
-              <a:buNone/>
-            </a:pPr>
-            <a:r>
-              <a:rPr lang="en-US" sz="1800" b="1" dirty="0">
-                <a:solidFill>
-                  <a:srgbClr val="FFFFFF"/>
-                </a:solidFill>
-                <a:latin typeface="Calibri" pitchFamily="34" charset="0"/>
-                <a:ea typeface="Calibri" pitchFamily="34" charset="-122"/>
-                <a:cs typeface="Calibri" pitchFamily="34" charset="-120"/>
-              </a:rPr>
-              <a:t>4</a:t>
-            </a:r>
-            <a:endParaRPr lang="en-US" sz="1800" dirty="0"/>
-          </a:p>
-        </p:txBody>
-      </p:sp>
-      <p:sp>
-        <p:nvSpPr>
-          <p:cNvPr id="16" name="Text 14"/>
-          <p:cNvSpPr txBox="1"/>
-          <p:nvPr/>
-        </p:nvSpPr>
-        <p:spPr>
-          <a:xfrm>
-            <a:off x="1280160" y="3895344"/>
-            <a:ext cx="10241280" cy="457200"/>
-          </a:xfrm>
-          <a:prstGeom prst="rect">
-            <a:avLst/>
-          </a:prstGeom>
-          <a:noFill/>
-          <a:ln/>
-        </p:spPr>
-        <p:txBody>
-          <a:bodyPr wrap="square" lIns="0" tIns="0" rIns="0" bIns="0" rtlCol="0" anchor="t"/>
-          <a:lstStyle/>
-          <a:p>
-            <a:pPr indent="0" marL="0">
-              <a:buNone/>
-            </a:pPr>
-            <a:r>
-              <a:rPr lang="en-US" sz="2400" b="1" dirty="0">
-                <a:solidFill>
-                  <a:srgbClr val="1E2761"/>
-                </a:solidFill>
-                <a:latin typeface="Calibri" pitchFamily="34" charset="0"/>
-                <a:ea typeface="Calibri" pitchFamily="34" charset="-122"/>
-                <a:cs typeface="Calibri" pitchFamily="34" charset="-120"/>
-              </a:rPr>
-              <a:t>Beende: „Die Steuern zahlt der …“</a:t>
-            </a:r>
-            <a:endParaRPr lang="en-US" sz="2400" dirty="0"/>
-          </a:p>
-        </p:txBody>
-      </p:sp>
-      <p:sp>
-        <p:nvSpPr>
-          <p:cNvPr id="17" name="Shape 15"/>
+          <p:cNvPr id="39" name="Shape 36"/>
           <p:cNvSpPr/>
           <p:nvPr/>
         </p:nvSpPr>
@@ -14080,7 +14747,7 @@
       </p:sp>
       <p:sp>
         <p:nvSpPr>
-          <p:cNvPr id="18" name="Text 16"/>
+          <p:cNvPr id="40" name="Text 37"/>
           <p:cNvSpPr txBox="1"/>
           <p:nvPr/>
         </p:nvSpPr>
@@ -14139,382 +14806,9 @@
                 <a:ea typeface="Calibri" pitchFamily="34" charset="-122"/>
                 <a:cs typeface="Calibri" pitchFamily="34" charset="-120"/>
               </a:rPr>
-              <a:t>Fertig? Stift hinlegen und noch einmal durchlesen.</a:t>
+              <a:t>Fertig? Stift hinlegen.</a:t>
             </a:r>
             <a:endParaRPr lang="en-US" sz="2400" dirty="0"/>
-          </a:p>
-        </p:txBody>
-      </p:sp>
-      <p:sp>
-        <p:nvSpPr>
-          <p:cNvPr id="19" name="Text 17"/>
-          <p:cNvSpPr txBox="1"/>
-          <p:nvPr/>
-        </p:nvSpPr>
-        <p:spPr>
-          <a:xfrm>
-            <a:off x="548640" y="6510528"/>
-            <a:ext cx="5486400" cy="228600"/>
-          </a:xfrm>
-          <a:prstGeom prst="rect">
-            <a:avLst/>
-          </a:prstGeom>
-          <a:noFill/>
-          <a:ln/>
-        </p:spPr>
-        <p:txBody>
-          <a:bodyPr wrap="square" lIns="0" tIns="0" rIns="0" bIns="0" rtlCol="0" anchor="t"/>
-          <a:lstStyle/>
-          <a:p>
-            <a:pPr indent="0" marL="0">
-              <a:buNone/>
-            </a:pPr>
-            <a:r>
-              <a:rPr lang="en-US" sz="1000" dirty="0">
-                <a:solidFill>
-                  <a:srgbClr val="5B6B8C"/>
-                </a:solidFill>
-                <a:latin typeface="Calibri" pitchFamily="34" charset="0"/>
-                <a:ea typeface="Calibri" pitchFamily="34" charset="-122"/>
-                <a:cs typeface="Calibri" pitchFamily="34" charset="-120"/>
-              </a:rPr>
-              <a:t>Generalstände · Geschichte 8D</a:t>
-            </a:r>
-            <a:endParaRPr lang="en-US" sz="1000" dirty="0"/>
-          </a:p>
-        </p:txBody>
-      </p:sp>
-      <p:sp>
-        <p:nvSpPr>
-          <p:cNvPr id="20" name="Text 18"/>
-          <p:cNvSpPr txBox="1"/>
-          <p:nvPr/>
-        </p:nvSpPr>
-        <p:spPr>
-          <a:xfrm>
-            <a:off x="11155680" y="6510528"/>
-            <a:ext cx="457200" cy="228600"/>
-          </a:xfrm>
-          <a:prstGeom prst="rect">
-            <a:avLst/>
-          </a:prstGeom>
-          <a:noFill/>
-          <a:ln/>
-        </p:spPr>
-        <p:txBody>
-          <a:bodyPr wrap="square" lIns="0" tIns="0" rIns="0" bIns="0" rtlCol="0" anchor="t"/>
-          <a:lstStyle/>
-          <a:p>
-            <a:pPr algn="r" indent="0" marL="0">
-              <a:buNone/>
-            </a:pPr>
-            <a:r>
-              <a:rPr lang="en-US" sz="1000" dirty="0">
-                <a:solidFill>
-                  <a:srgbClr val="5B6B8C"/>
-                </a:solidFill>
-                <a:latin typeface="Calibri" pitchFamily="34" charset="0"/>
-                <a:ea typeface="Calibri" pitchFamily="34" charset="-122"/>
-                <a:cs typeface="Calibri" pitchFamily="34" charset="-120"/>
-              </a:rPr>
-              <a:t>4</a:t>
-            </a:r>
-            <a:endParaRPr lang="en-US" sz="1000" dirty="0"/>
-          </a:p>
-        </p:txBody>
-      </p:sp>
-      <p:sp>
-        <p:nvSpPr>
-          <p:cNvPr id="22" name="Shape 19"/>
-          <p:cNvSpPr/>
-          <p:nvPr/>
-        </p:nvSpPr>
-        <p:spPr>
-          <a:xfrm>
-            <a:off x="9144000" y="274320"/>
-            <a:ext cx="402336" cy="402336"/>
-          </a:xfrm>
-          <a:prstGeom prst="ellipse">
-            <a:avLst/>
-          </a:prstGeom>
-          <a:solidFill>
-            <a:srgbClr val="EAF0FA"/>
-          </a:solidFill>
-          <a:ln/>
-        </p:spPr>
-      </p:sp>
-      <p:sp>
-        <p:nvSpPr>
-          <p:cNvPr id="23" name="Text 20"/>
-          <p:cNvSpPr txBox="1"/>
-          <p:nvPr/>
-        </p:nvSpPr>
-        <p:spPr>
-          <a:xfrm>
-            <a:off x="9144000" y="274320"/>
-            <a:ext cx="402336" cy="402336"/>
-          </a:xfrm>
-          <a:prstGeom prst="rect">
-            <a:avLst/>
-          </a:prstGeom>
-          <a:noFill/>
-          <a:ln/>
-        </p:spPr>
-        <p:txBody>
-          <a:bodyPr wrap="square" lIns="0" tIns="0" rIns="0" bIns="0" rtlCol="0" anchor="ctr"/>
-          <a:lstStyle/>
-          <a:p>
-            <a:pPr algn="ctr" indent="0" marL="0">
-              <a:buNone/>
-            </a:pPr>
-            <a:r>
-              <a:rPr lang="en-US" sz="1400" b="1" dirty="0">
-                <a:solidFill>
-                  <a:srgbClr val="5B6B8C"/>
-                </a:solidFill>
-                <a:latin typeface="Calibri" pitchFamily="34" charset="0"/>
-                <a:ea typeface="Calibri" pitchFamily="34" charset="-122"/>
-                <a:cs typeface="Calibri" pitchFamily="34" charset="-120"/>
-              </a:rPr>
-              <a:t>A</a:t>
-            </a:r>
-            <a:endParaRPr lang="en-US" sz="1400" dirty="0"/>
-          </a:p>
-        </p:txBody>
-      </p:sp>
-      <p:sp>
-        <p:nvSpPr>
-          <p:cNvPr id="24" name="Shape 21"/>
-          <p:cNvSpPr/>
-          <p:nvPr/>
-        </p:nvSpPr>
-        <p:spPr>
-          <a:xfrm>
-            <a:off x="9646920" y="274320"/>
-            <a:ext cx="402336" cy="402336"/>
-          </a:xfrm>
-          <a:prstGeom prst="ellipse">
-            <a:avLst/>
-          </a:prstGeom>
-          <a:solidFill>
-            <a:srgbClr val="D9534F"/>
-          </a:solidFill>
-          <a:ln/>
-        </p:spPr>
-      </p:sp>
-      <p:sp>
-        <p:nvSpPr>
-          <p:cNvPr id="25" name="Text 22"/>
-          <p:cNvSpPr txBox="1"/>
-          <p:nvPr/>
-        </p:nvSpPr>
-        <p:spPr>
-          <a:xfrm>
-            <a:off x="9646920" y="274320"/>
-            <a:ext cx="402336" cy="402336"/>
-          </a:xfrm>
-          <a:prstGeom prst="rect">
-            <a:avLst/>
-          </a:prstGeom>
-          <a:noFill/>
-          <a:ln/>
-        </p:spPr>
-        <p:txBody>
-          <a:bodyPr wrap="square" lIns="0" tIns="0" rIns="0" bIns="0" rtlCol="0" anchor="ctr"/>
-          <a:lstStyle/>
-          <a:p>
-            <a:pPr algn="ctr" indent="0" marL="0">
-              <a:buNone/>
-            </a:pPr>
-            <a:r>
-              <a:rPr lang="en-US" sz="1400" b="1" dirty="0">
-                <a:solidFill>
-                  <a:srgbClr val="FFFFFF"/>
-                </a:solidFill>
-                <a:latin typeface="Calibri" pitchFamily="34" charset="0"/>
-                <a:ea typeface="Calibri" pitchFamily="34" charset="-122"/>
-                <a:cs typeface="Calibri" pitchFamily="34" charset="-120"/>
-              </a:rPr>
-              <a:t>V</a:t>
-            </a:r>
-            <a:endParaRPr lang="en-US" sz="1400" dirty="0"/>
-          </a:p>
-        </p:txBody>
-      </p:sp>
-      <p:sp>
-        <p:nvSpPr>
-          <p:cNvPr id="26" name="Shape 23"/>
-          <p:cNvSpPr/>
-          <p:nvPr/>
-        </p:nvSpPr>
-        <p:spPr>
-          <a:xfrm>
-            <a:off x="10149840" y="274320"/>
-            <a:ext cx="402336" cy="402336"/>
-          </a:xfrm>
-          <a:prstGeom prst="ellipse">
-            <a:avLst/>
-          </a:prstGeom>
-          <a:solidFill>
-            <a:srgbClr val="EAF0FA"/>
-          </a:solidFill>
-          <a:ln/>
-        </p:spPr>
-      </p:sp>
-      <p:sp>
-        <p:nvSpPr>
-          <p:cNvPr id="27" name="Text 24"/>
-          <p:cNvSpPr txBox="1"/>
-          <p:nvPr/>
-        </p:nvSpPr>
-        <p:spPr>
-          <a:xfrm>
-            <a:off x="10149840" y="274320"/>
-            <a:ext cx="402336" cy="402336"/>
-          </a:xfrm>
-          <a:prstGeom prst="rect">
-            <a:avLst/>
-          </a:prstGeom>
-          <a:noFill/>
-          <a:ln/>
-        </p:spPr>
-        <p:txBody>
-          <a:bodyPr wrap="square" lIns="0" tIns="0" rIns="0" bIns="0" rtlCol="0" anchor="ctr"/>
-          <a:lstStyle/>
-          <a:p>
-            <a:pPr algn="ctr" indent="0" marL="0">
-              <a:buNone/>
-            </a:pPr>
-            <a:r>
-              <a:rPr lang="en-US" sz="1400" b="1" dirty="0">
-                <a:solidFill>
-                  <a:srgbClr val="5B6B8C"/>
-                </a:solidFill>
-                <a:latin typeface="Calibri" pitchFamily="34" charset="0"/>
-                <a:ea typeface="Calibri" pitchFamily="34" charset="-122"/>
-                <a:cs typeface="Calibri" pitchFamily="34" charset="-120"/>
-              </a:rPr>
-              <a:t>I</a:t>
-            </a:r>
-            <a:endParaRPr lang="en-US" sz="1400" dirty="0"/>
-          </a:p>
-        </p:txBody>
-      </p:sp>
-      <p:sp>
-        <p:nvSpPr>
-          <p:cNvPr id="28" name="Shape 25"/>
-          <p:cNvSpPr/>
-          <p:nvPr/>
-        </p:nvSpPr>
-        <p:spPr>
-          <a:xfrm>
-            <a:off x="10652760" y="274320"/>
-            <a:ext cx="402336" cy="402336"/>
-          </a:xfrm>
-          <a:prstGeom prst="ellipse">
-            <a:avLst/>
-          </a:prstGeom>
-          <a:solidFill>
-            <a:srgbClr val="EAF0FA"/>
-          </a:solidFill>
-          <a:ln/>
-        </p:spPr>
-      </p:sp>
-      <p:sp>
-        <p:nvSpPr>
-          <p:cNvPr id="29" name="Text 26"/>
-          <p:cNvSpPr txBox="1"/>
-          <p:nvPr/>
-        </p:nvSpPr>
-        <p:spPr>
-          <a:xfrm>
-            <a:off x="10652760" y="274320"/>
-            <a:ext cx="402336" cy="402336"/>
-          </a:xfrm>
-          <a:prstGeom prst="rect">
-            <a:avLst/>
-          </a:prstGeom>
-          <a:noFill/>
-          <a:ln/>
-        </p:spPr>
-        <p:txBody>
-          <a:bodyPr wrap="square" lIns="0" tIns="0" rIns="0" bIns="0" rtlCol="0" anchor="ctr"/>
-          <a:lstStyle/>
-          <a:p>
-            <a:pPr algn="ctr" indent="0" marL="0">
-              <a:buNone/>
-            </a:pPr>
-            <a:r>
-              <a:rPr lang="en-US" sz="1400" b="1" dirty="0">
-                <a:solidFill>
-                  <a:srgbClr val="5B6B8C"/>
-                </a:solidFill>
-                <a:latin typeface="Calibri" pitchFamily="34" charset="0"/>
-                <a:ea typeface="Calibri" pitchFamily="34" charset="-122"/>
-                <a:cs typeface="Calibri" pitchFamily="34" charset="-120"/>
-              </a:rPr>
-              <a:t>V</a:t>
-            </a:r>
-            <a:endParaRPr lang="en-US" sz="1400" dirty="0"/>
-          </a:p>
-        </p:txBody>
-      </p:sp>
-      <p:sp>
-        <p:nvSpPr>
-          <p:cNvPr id="30" name="Shape 27"/>
-          <p:cNvSpPr/>
-          <p:nvPr/>
-        </p:nvSpPr>
-        <p:spPr>
-          <a:xfrm>
-            <a:off x="11155680" y="274320"/>
-            <a:ext cx="402336" cy="402336"/>
-          </a:xfrm>
-          <a:prstGeom prst="ellipse">
-            <a:avLst/>
-          </a:prstGeom>
-          <a:solidFill>
-            <a:srgbClr val="EAF0FA"/>
-          </a:solidFill>
-          <a:ln/>
-        </p:spPr>
-      </p:sp>
-      <p:sp>
-        <p:nvSpPr>
-          <p:cNvPr id="31" name="Text 28"/>
-          <p:cNvSpPr txBox="1"/>
-          <p:nvPr/>
-        </p:nvSpPr>
-        <p:spPr>
-          <a:xfrm>
-            <a:off x="11155680" y="274320"/>
-            <a:ext cx="402336" cy="402336"/>
-          </a:xfrm>
-          <a:prstGeom prst="rect">
-            <a:avLst/>
-          </a:prstGeom>
-          <a:noFill/>
-          <a:ln/>
-        </p:spPr>
-        <p:txBody>
-          <a:bodyPr wrap="square" lIns="0" tIns="0" rIns="0" bIns="0" rtlCol="0" anchor="ctr"/>
-          <a:lstStyle/>
-          <a:p>
-            <a:pPr algn="ctr" indent="0" marL="0">
-              <a:buNone/>
-            </a:pPr>
-            <a:r>
-              <a:rPr lang="en-US" sz="1400" b="1" dirty="0">
-                <a:solidFill>
-                  <a:srgbClr val="5B6B8C"/>
-                </a:solidFill>
-                <a:latin typeface="Calibri" pitchFamily="34" charset="0"/>
-                <a:ea typeface="Calibri" pitchFamily="34" charset="-122"/>
-                <a:cs typeface="Calibri" pitchFamily="34" charset="-120"/>
-              </a:rPr>
-              <a:t>A</a:t>
-            </a:r>
-            <a:endParaRPr lang="en-US" sz="1400" dirty="0"/>
           </a:p>
         </p:txBody>
       </p:sp>
@@ -14917,7 +15211,7 @@
                 <a:ea typeface="Cambria" pitchFamily="34" charset="-122"/>
                 <a:cs typeface="Cambria" pitchFamily="34" charset="-120"/>
               </a:rPr>
-              <a:t>Die drei Stände</a:t>
+              <a:t>Fehlertext: Lösung</a:t>
             </a:r>
             <a:endParaRPr lang="en-US" sz="3400" dirty="0"/>
           </a:p>
@@ -15009,16 +15303,16 @@
         </p:nvSpPr>
         <p:spPr>
           <a:xfrm>
-            <a:off x="548640" y="1554480"/>
-            <a:ext cx="11109960" cy="1097280"/>
+            <a:off x="548640" y="1371600"/>
+            <a:ext cx="11109960" cy="4069080"/>
           </a:xfrm>
           <a:prstGeom prst="roundRect">
             <a:avLst>
-              <a:gd name="adj" fmla="val 6667"/>
+              <a:gd name="adj" fmla="val 1798"/>
             </a:avLst>
           </a:prstGeom>
           <a:solidFill>
-            <a:srgbClr val="F4F7FD"/>
+            <a:srgbClr val="EAF0FA"/>
           </a:solidFill>
           <a:ln/>
         </p:spPr>
@@ -15031,14 +15325,14 @@
         </p:nvSpPr>
         <p:spPr>
           <a:xfrm>
-            <a:off x="548640" y="1554480"/>
-            <a:ext cx="128016" cy="1097280"/>
-          </a:xfrm>
-          <a:prstGeom prst="rect">
-            <a:avLst/>
-          </a:prstGeom>
-          <a:solidFill>
-            <a:srgbClr val="8E6BBE"/>
+            <a:off x="777240" y="1600200"/>
+            <a:ext cx="365760" cy="365760"/>
+          </a:xfrm>
+          <a:prstGeom prst="ellipse">
+            <a:avLst/>
+          </a:prstGeom>
+          <a:solidFill>
+            <a:srgbClr val="1E2761"/>
           </a:solidFill>
           <a:ln/>
         </p:spPr>
@@ -15051,8 +15345,8 @@
         </p:nvSpPr>
         <p:spPr>
           <a:xfrm>
-            <a:off x="914400" y="1554480"/>
-            <a:ext cx="5120640" cy="1097280"/>
+            <a:off x="777240" y="1600200"/>
+            <a:ext cx="365760" cy="365760"/>
           </a:xfrm>
           <a:prstGeom prst="rect">
             <a:avLst/>
@@ -15064,11 +15358,50 @@
           <a:bodyPr wrap="square" lIns="0" tIns="0" rIns="0" bIns="0" rtlCol="0" anchor="ctr"/>
           <a:lstStyle/>
           <a:p>
+            <a:pPr algn="ctr" indent="0" marL="0">
+              <a:buNone/>
+            </a:pPr>
+            <a:r>
+              <a:rPr lang="en-US" sz="1800" b="1" dirty="0">
+                <a:solidFill>
+                  <a:srgbClr val="FFFFFF"/>
+                </a:solidFill>
+                <a:latin typeface="Calibri" pitchFamily="34" charset="0"/>
+                <a:ea typeface="Calibri" pitchFamily="34" charset="-122"/>
+                <a:cs typeface="Calibri" pitchFamily="34" charset="-120"/>
+              </a:rPr>
+              <a:t>1</a:t>
+            </a:r>
+            <a:endParaRPr lang="en-US" sz="1800" dirty="0"/>
+          </a:p>
+        </p:txBody>
+      </p:sp>
+      <p:sp>
+        <p:nvSpPr>
+          <p:cNvPr id="20" name="Text 17"/>
+          <p:cNvSpPr txBox="1"/>
+          <p:nvPr/>
+        </p:nvSpPr>
+        <p:spPr>
+          <a:xfrm>
+            <a:off x="1371600" y="1508760"/>
+            <a:ext cx="10058400" cy="731520"/>
+          </a:xfrm>
+          <a:prstGeom prst="rect">
+            <a:avLst/>
+          </a:prstGeom>
+          <a:noFill/>
+          <a:ln/>
+        </p:spPr>
+        <p:txBody>
+          <a:bodyPr wrap="square" lIns="0" tIns="0" rIns="0" bIns="0" rtlCol="0" anchor="ctr"/>
+          <a:lstStyle/>
+          <a:p>
             <a:pPr indent="0" marL="0">
               <a:buNone/>
             </a:pPr>
             <a:r>
-              <a:rPr lang="en-US" sz="2400" b="1" dirty="0">
+              <a:rPr lang="en-US" sz="2400" dirty="0">
                 <a:solidFill>
                   <a:srgbClr val="1E2761"/>
                 </a:solidFill>
@@ -15076,239 +15409,27 @@
                 <a:ea typeface="Cambria" pitchFamily="34" charset="-122"/>
                 <a:cs typeface="Cambria" pitchFamily="34" charset="-120"/>
               </a:rPr>
-              <a:t>Erster Stand · Klerus</a:t>
-            </a:r>
-            <a:endParaRPr lang="en-US" sz="2400" dirty="0"/>
-          </a:p>
-        </p:txBody>
-      </p:sp>
-      <p:sp>
-        <p:nvSpPr>
-          <p:cNvPr id="20" name="Text 17"/>
-          <p:cNvSpPr txBox="1"/>
-          <p:nvPr/>
-        </p:nvSpPr>
-        <p:spPr>
-          <a:xfrm>
-            <a:off x="6126480" y="1554480"/>
-            <a:ext cx="5394960" cy="1097280"/>
-          </a:xfrm>
-          <a:prstGeom prst="rect">
-            <a:avLst/>
-          </a:prstGeom>
-          <a:noFill/>
-          <a:ln/>
-        </p:spPr>
-        <p:txBody>
-          <a:bodyPr wrap="square" lIns="0" tIns="0" rIns="0" bIns="0" rtlCol="0" anchor="ctr"/>
-          <a:lstStyle/>
-          <a:p>
+              <a:t>Ludwig XIV. war der Sonnenkönig und regierte im Absolutismus </a:t>
+            </a:r>
             <a:pPr indent="0" marL="0">
               <a:buNone/>
             </a:pPr>
             <a:r>
-              <a:rPr lang="en-US" sz="2400" dirty="0">
-                <a:solidFill>
-                  <a:srgbClr val="1E2761"/>
-                </a:solidFill>
-                <a:latin typeface="Calibri" pitchFamily="34" charset="0"/>
-                <a:ea typeface="Calibri" pitchFamily="34" charset="-122"/>
-                <a:cs typeface="Calibri" pitchFamily="34" charset="-120"/>
-              </a:rPr>
-              <a:t>ca. 150 000 · zahlt keine Steuern</a:t>
-            </a:r>
-            <a:endParaRPr lang="en-US" sz="2400" dirty="0"/>
-          </a:p>
-        </p:txBody>
-      </p:sp>
-      <p:sp>
-        <p:nvSpPr>
-          <p:cNvPr id="21" name="Shape 18"/>
-          <p:cNvSpPr/>
-          <p:nvPr/>
-        </p:nvSpPr>
-        <p:spPr>
-          <a:xfrm>
-            <a:off x="548640" y="2834640"/>
-            <a:ext cx="11109960" cy="1097280"/>
-          </a:xfrm>
-          <a:prstGeom prst="roundRect">
-            <a:avLst>
-              <a:gd name="adj" fmla="val 6667"/>
-            </a:avLst>
-          </a:prstGeom>
-          <a:solidFill>
-            <a:srgbClr val="F4F7FD"/>
-          </a:solidFill>
-          <a:ln/>
-        </p:spPr>
-      </p:sp>
-      <p:sp>
-        <p:nvSpPr>
-          <p:cNvPr id="22" name="Shape 19"/>
-          <p:cNvSpPr/>
-          <p:nvPr/>
-        </p:nvSpPr>
-        <p:spPr>
-          <a:xfrm>
-            <a:off x="548640" y="2834640"/>
-            <a:ext cx="128016" cy="1097280"/>
-          </a:xfrm>
-          <a:prstGeom prst="rect">
-            <a:avLst/>
-          </a:prstGeom>
-          <a:solidFill>
-            <a:srgbClr val="E8A33D"/>
-          </a:solidFill>
-          <a:ln/>
-        </p:spPr>
-      </p:sp>
-      <p:sp>
-        <p:nvSpPr>
-          <p:cNvPr id="23" name="Text 20"/>
-          <p:cNvSpPr txBox="1"/>
-          <p:nvPr/>
-        </p:nvSpPr>
-        <p:spPr>
-          <a:xfrm>
-            <a:off x="914400" y="2834640"/>
-            <a:ext cx="5120640" cy="1097280"/>
-          </a:xfrm>
-          <a:prstGeom prst="rect">
-            <a:avLst/>
-          </a:prstGeom>
-          <a:noFill/>
-          <a:ln/>
-        </p:spPr>
-        <p:txBody>
-          <a:bodyPr wrap="square" lIns="0" tIns="0" rIns="0" bIns="0" rtlCol="0" anchor="ctr"/>
-          <a:lstStyle/>
-          <a:p>
-            <a:pPr indent="0" marL="0">
-              <a:buNone/>
-            </a:pPr>
-            <a:r>
               <a:rPr lang="en-US" sz="2400" b="1" dirty="0">
                 <a:solidFill>
-                  <a:srgbClr val="1E2761"/>
+                  <a:srgbClr val="2E9E6B"/>
                 </a:solidFill>
                 <a:latin typeface="Cambria" pitchFamily="34" charset="0"/>
                 <a:ea typeface="Cambria" pitchFamily="34" charset="-122"/>
                 <a:cs typeface="Cambria" pitchFamily="34" charset="-120"/>
               </a:rPr>
-              <a:t>Zweiter Stand · Adel</a:t>
-            </a:r>
-            <a:endParaRPr lang="en-US" sz="2400" dirty="0"/>
-          </a:p>
-        </p:txBody>
-      </p:sp>
-      <p:sp>
-        <p:nvSpPr>
-          <p:cNvPr id="24" name="Text 21"/>
-          <p:cNvSpPr txBox="1"/>
-          <p:nvPr/>
-        </p:nvSpPr>
-        <p:spPr>
-          <a:xfrm>
-            <a:off x="6126480" y="2834640"/>
-            <a:ext cx="5394960" cy="1097280"/>
-          </a:xfrm>
-          <a:prstGeom prst="rect">
-            <a:avLst/>
-          </a:prstGeom>
-          <a:noFill/>
-          <a:ln/>
-        </p:spPr>
-        <p:txBody>
-          <a:bodyPr wrap="square" lIns="0" tIns="0" rIns="0" bIns="0" rtlCol="0" anchor="ctr"/>
-          <a:lstStyle/>
-          <a:p>
+              <a:t>allein, ohne die Stände</a:t>
+            </a:r>
             <a:pPr indent="0" marL="0">
               <a:buNone/>
             </a:pPr>
             <a:r>
               <a:rPr lang="en-US" sz="2400" dirty="0">
-                <a:solidFill>
-                  <a:srgbClr val="1E2761"/>
-                </a:solidFill>
-                <a:latin typeface="Calibri" pitchFamily="34" charset="0"/>
-                <a:ea typeface="Calibri" pitchFamily="34" charset="-122"/>
-                <a:cs typeface="Calibri" pitchFamily="34" charset="-120"/>
-              </a:rPr>
-              <a:t>ca. 500 000 · zahlt keine Steuern</a:t>
-            </a:r>
-            <a:endParaRPr lang="en-US" sz="2400" dirty="0"/>
-          </a:p>
-        </p:txBody>
-      </p:sp>
-      <p:sp>
-        <p:nvSpPr>
-          <p:cNvPr id="25" name="Shape 22"/>
-          <p:cNvSpPr/>
-          <p:nvPr/>
-        </p:nvSpPr>
-        <p:spPr>
-          <a:xfrm>
-            <a:off x="548640" y="4114800"/>
-            <a:ext cx="11109960" cy="1097280"/>
-          </a:xfrm>
-          <a:prstGeom prst="roundRect">
-            <a:avLst>
-              <a:gd name="adj" fmla="val 6667"/>
-            </a:avLst>
-          </a:prstGeom>
-          <a:solidFill>
-            <a:srgbClr val="F4F7FD"/>
-          </a:solidFill>
-          <a:ln/>
-        </p:spPr>
-      </p:sp>
-      <p:sp>
-        <p:nvSpPr>
-          <p:cNvPr id="26" name="Shape 23"/>
-          <p:cNvSpPr/>
-          <p:nvPr/>
-        </p:nvSpPr>
-        <p:spPr>
-          <a:xfrm>
-            <a:off x="548640" y="4114800"/>
-            <a:ext cx="128016" cy="1097280"/>
-          </a:xfrm>
-          <a:prstGeom prst="rect">
-            <a:avLst/>
-          </a:prstGeom>
-          <a:solidFill>
-            <a:srgbClr val="3F7CC4"/>
-          </a:solidFill>
-          <a:ln/>
-        </p:spPr>
-      </p:sp>
-      <p:sp>
-        <p:nvSpPr>
-          <p:cNvPr id="27" name="Text 24"/>
-          <p:cNvSpPr txBox="1"/>
-          <p:nvPr/>
-        </p:nvSpPr>
-        <p:spPr>
-          <a:xfrm>
-            <a:off x="914400" y="4114800"/>
-            <a:ext cx="5120640" cy="1097280"/>
-          </a:xfrm>
-          <a:prstGeom prst="rect">
-            <a:avLst/>
-          </a:prstGeom>
-          <a:noFill/>
-          <a:ln/>
-        </p:spPr>
-        <p:txBody>
-          <a:bodyPr wrap="square" lIns="0" tIns="0" rIns="0" bIns="0" rtlCol="0" anchor="ctr"/>
-          <a:lstStyle/>
-          <a:p>
-            <a:pPr indent="0" marL="0">
-              <a:buNone/>
-            </a:pPr>
-            <a:r>
-              <a:rPr lang="en-US" sz="2400" b="1" dirty="0">
                 <a:solidFill>
                   <a:srgbClr val="1E2761"/>
                 </a:solidFill>
@@ -15316,7 +15437,7 @@
                 <a:ea typeface="Cambria" pitchFamily="34" charset="-122"/>
                 <a:cs typeface="Cambria" pitchFamily="34" charset="-120"/>
               </a:rPr>
-              <a:t>Dritter Stand (Bauern und Bürger)</a:t>
+              <a:t>.</a:t>
             </a:r>
             <a:endParaRPr lang="en-US" sz="2400" dirty="0"/>
           </a:p>
@@ -15324,14 +15445,286 @@
       </p:sp>
       <p:sp>
         <p:nvSpPr>
+          <p:cNvPr id="21" name="Shape 18"/>
+          <p:cNvSpPr/>
+          <p:nvPr/>
+        </p:nvSpPr>
+        <p:spPr>
+          <a:xfrm>
+            <a:off x="777240" y="2377440"/>
+            <a:ext cx="365760" cy="365760"/>
+          </a:xfrm>
+          <a:prstGeom prst="ellipse">
+            <a:avLst/>
+          </a:prstGeom>
+          <a:solidFill>
+            <a:srgbClr val="1E2761"/>
+          </a:solidFill>
+          <a:ln/>
+        </p:spPr>
+      </p:sp>
+      <p:sp>
+        <p:nvSpPr>
+          <p:cNvPr id="22" name="Text 19"/>
+          <p:cNvSpPr txBox="1"/>
+          <p:nvPr/>
+        </p:nvSpPr>
+        <p:spPr>
+          <a:xfrm>
+            <a:off x="777240" y="2377440"/>
+            <a:ext cx="365760" cy="365760"/>
+          </a:xfrm>
+          <a:prstGeom prst="rect">
+            <a:avLst/>
+          </a:prstGeom>
+          <a:noFill/>
+          <a:ln/>
+        </p:spPr>
+        <p:txBody>
+          <a:bodyPr wrap="square" lIns="0" tIns="0" rIns="0" bIns="0" rtlCol="0" anchor="ctr"/>
+          <a:lstStyle/>
+          <a:p>
+            <a:pPr algn="ctr" indent="0" marL="0">
+              <a:buNone/>
+            </a:pPr>
+            <a:r>
+              <a:rPr lang="en-US" sz="1800" b="1" dirty="0">
+                <a:solidFill>
+                  <a:srgbClr val="FFFFFF"/>
+                </a:solidFill>
+                <a:latin typeface="Calibri" pitchFamily="34" charset="0"/>
+                <a:ea typeface="Calibri" pitchFamily="34" charset="-122"/>
+                <a:cs typeface="Calibri" pitchFamily="34" charset="-120"/>
+              </a:rPr>
+              <a:t>2</a:t>
+            </a:r>
+            <a:endParaRPr lang="en-US" sz="1800" dirty="0"/>
+          </a:p>
+        </p:txBody>
+      </p:sp>
+      <p:sp>
+        <p:nvSpPr>
+          <p:cNvPr id="23" name="Text 20"/>
+          <p:cNvSpPr txBox="1"/>
+          <p:nvPr/>
+        </p:nvSpPr>
+        <p:spPr>
+          <a:xfrm>
+            <a:off x="1371600" y="2286000"/>
+            <a:ext cx="10058400" cy="731520"/>
+          </a:xfrm>
+          <a:prstGeom prst="rect">
+            <a:avLst/>
+          </a:prstGeom>
+          <a:noFill/>
+          <a:ln/>
+        </p:spPr>
+        <p:txBody>
+          <a:bodyPr wrap="square" lIns="0" tIns="0" rIns="0" bIns="0" rtlCol="0" anchor="ctr"/>
+          <a:lstStyle/>
+          <a:p>
+            <a:pPr indent="0" marL="0">
+              <a:buNone/>
+            </a:pPr>
+            <a:r>
+              <a:rPr lang="en-US" sz="2400" dirty="0">
+                <a:solidFill>
+                  <a:srgbClr val="1E2761"/>
+                </a:solidFill>
+                <a:latin typeface="Cambria" pitchFamily="34" charset="0"/>
+                <a:ea typeface="Cambria" pitchFamily="34" charset="-122"/>
+                <a:cs typeface="Cambria" pitchFamily="34" charset="-120"/>
+              </a:rPr>
+              <a:t>Seine Macht komme </a:t>
+            </a:r>
+            <a:pPr indent="0" marL="0">
+              <a:buNone/>
+            </a:pPr>
+            <a:r>
+              <a:rPr lang="en-US" sz="2400" b="1" dirty="0">
+                <a:solidFill>
+                  <a:srgbClr val="2E9E6B"/>
+                </a:solidFill>
+                <a:latin typeface="Cambria" pitchFamily="34" charset="0"/>
+                <a:ea typeface="Cambria" pitchFamily="34" charset="-122"/>
+                <a:cs typeface="Cambria" pitchFamily="34" charset="-120"/>
+              </a:rPr>
+              <a:t>von Gott</a:t>
+            </a:r>
+            <a:pPr indent="0" marL="0">
+              <a:buNone/>
+            </a:pPr>
+            <a:r>
+              <a:rPr lang="en-US" sz="2400" dirty="0">
+                <a:solidFill>
+                  <a:srgbClr val="1E2761"/>
+                </a:solidFill>
+                <a:latin typeface="Cambria" pitchFamily="34" charset="0"/>
+                <a:ea typeface="Cambria" pitchFamily="34" charset="-122"/>
+                <a:cs typeface="Cambria" pitchFamily="34" charset="-120"/>
+              </a:rPr>
+              <a:t>, sagte er (Gottesgnadentum).</a:t>
+            </a:r>
+            <a:endParaRPr lang="en-US" sz="2400" dirty="0"/>
+          </a:p>
+        </p:txBody>
+      </p:sp>
+      <p:sp>
+        <p:nvSpPr>
+          <p:cNvPr id="24" name="Shape 21"/>
+          <p:cNvSpPr/>
+          <p:nvPr/>
+        </p:nvSpPr>
+        <p:spPr>
+          <a:xfrm>
+            <a:off x="777240" y="3154680"/>
+            <a:ext cx="365760" cy="365760"/>
+          </a:xfrm>
+          <a:prstGeom prst="ellipse">
+            <a:avLst/>
+          </a:prstGeom>
+          <a:solidFill>
+            <a:srgbClr val="1E2761"/>
+          </a:solidFill>
+          <a:ln/>
+        </p:spPr>
+      </p:sp>
+      <p:sp>
+        <p:nvSpPr>
+          <p:cNvPr id="25" name="Text 22"/>
+          <p:cNvSpPr txBox="1"/>
+          <p:nvPr/>
+        </p:nvSpPr>
+        <p:spPr>
+          <a:xfrm>
+            <a:off x="777240" y="3154680"/>
+            <a:ext cx="365760" cy="365760"/>
+          </a:xfrm>
+          <a:prstGeom prst="rect">
+            <a:avLst/>
+          </a:prstGeom>
+          <a:noFill/>
+          <a:ln/>
+        </p:spPr>
+        <p:txBody>
+          <a:bodyPr wrap="square" lIns="0" tIns="0" rIns="0" bIns="0" rtlCol="0" anchor="ctr"/>
+          <a:lstStyle/>
+          <a:p>
+            <a:pPr algn="ctr" indent="0" marL="0">
+              <a:buNone/>
+            </a:pPr>
+            <a:r>
+              <a:rPr lang="en-US" sz="1800" b="1" dirty="0">
+                <a:solidFill>
+                  <a:srgbClr val="FFFFFF"/>
+                </a:solidFill>
+                <a:latin typeface="Calibri" pitchFamily="34" charset="0"/>
+                <a:ea typeface="Calibri" pitchFamily="34" charset="-122"/>
+                <a:cs typeface="Calibri" pitchFamily="34" charset="-120"/>
+              </a:rPr>
+              <a:t>3</a:t>
+            </a:r>
+            <a:endParaRPr lang="en-US" sz="1800" dirty="0"/>
+          </a:p>
+        </p:txBody>
+      </p:sp>
+      <p:sp>
+        <p:nvSpPr>
+          <p:cNvPr id="26" name="Text 23"/>
+          <p:cNvSpPr txBox="1"/>
+          <p:nvPr/>
+        </p:nvSpPr>
+        <p:spPr>
+          <a:xfrm>
+            <a:off x="1371600" y="3063240"/>
+            <a:ext cx="10058400" cy="731520"/>
+          </a:xfrm>
+          <a:prstGeom prst="rect">
+            <a:avLst/>
+          </a:prstGeom>
+          <a:noFill/>
+          <a:ln/>
+        </p:spPr>
+        <p:txBody>
+          <a:bodyPr wrap="square" lIns="0" tIns="0" rIns="0" bIns="0" rtlCol="0" anchor="ctr"/>
+          <a:lstStyle/>
+          <a:p>
+            <a:pPr indent="0" marL="0">
+              <a:buNone/>
+            </a:pPr>
+            <a:r>
+              <a:rPr lang="en-US" sz="2400" dirty="0">
+                <a:solidFill>
+                  <a:srgbClr val="1E2761"/>
+                </a:solidFill>
+                <a:latin typeface="Cambria" pitchFamily="34" charset="0"/>
+                <a:ea typeface="Cambria" pitchFamily="34" charset="-122"/>
+                <a:cs typeface="Cambria" pitchFamily="34" charset="-120"/>
+              </a:rPr>
+              <a:t>Zum Klerus gehörten etwa </a:t>
+            </a:r>
+            <a:pPr indent="0" marL="0">
+              <a:buNone/>
+            </a:pPr>
+            <a:r>
+              <a:rPr lang="en-US" sz="2400" b="1" dirty="0">
+                <a:solidFill>
+                  <a:srgbClr val="2E9E6B"/>
+                </a:solidFill>
+                <a:latin typeface="Cambria" pitchFamily="34" charset="0"/>
+                <a:ea typeface="Cambria" pitchFamily="34" charset="-122"/>
+                <a:cs typeface="Cambria" pitchFamily="34" charset="-120"/>
+              </a:rPr>
+              <a:t>150 000</a:t>
+            </a:r>
+            <a:pPr indent="0" marL="0">
+              <a:buNone/>
+            </a:pPr>
+            <a:r>
+              <a:rPr lang="en-US" sz="2400" dirty="0">
+                <a:solidFill>
+                  <a:srgbClr val="1E2761"/>
+                </a:solidFill>
+                <a:latin typeface="Cambria" pitchFamily="34" charset="0"/>
+                <a:ea typeface="Cambria" pitchFamily="34" charset="-122"/>
+                <a:cs typeface="Cambria" pitchFamily="34" charset="-120"/>
+              </a:rPr>
+              <a:t> Menschen, zum Adel etwa 500 000.</a:t>
+            </a:r>
+            <a:endParaRPr lang="en-US" sz="2400" dirty="0"/>
+          </a:p>
+        </p:txBody>
+      </p:sp>
+      <p:sp>
+        <p:nvSpPr>
+          <p:cNvPr id="27" name="Shape 24"/>
+          <p:cNvSpPr/>
+          <p:nvPr/>
+        </p:nvSpPr>
+        <p:spPr>
+          <a:xfrm>
+            <a:off x="777240" y="3931920"/>
+            <a:ext cx="365760" cy="365760"/>
+          </a:xfrm>
+          <a:prstGeom prst="ellipse">
+            <a:avLst/>
+          </a:prstGeom>
+          <a:solidFill>
+            <a:srgbClr val="1E2761"/>
+          </a:solidFill>
+          <a:ln/>
+        </p:spPr>
+      </p:sp>
+      <p:sp>
+        <p:nvSpPr>
           <p:cNvPr id="28" name="Text 25"/>
           <p:cNvSpPr txBox="1"/>
           <p:nvPr/>
         </p:nvSpPr>
         <p:spPr>
           <a:xfrm>
-            <a:off x="6126480" y="4114800"/>
-            <a:ext cx="5394960" cy="1097280"/>
+            <a:off x="777240" y="3931920"/>
+            <a:ext cx="365760" cy="365760"/>
           </a:xfrm>
           <a:prstGeom prst="rect">
             <a:avLst/>
@@ -15343,6 +15736,45 @@
           <a:bodyPr wrap="square" lIns="0" tIns="0" rIns="0" bIns="0" rtlCol="0" anchor="ctr"/>
           <a:lstStyle/>
           <a:p>
+            <a:pPr algn="ctr" indent="0" marL="0">
+              <a:buNone/>
+            </a:pPr>
+            <a:r>
+              <a:rPr lang="en-US" sz="1800" b="1" dirty="0">
+                <a:solidFill>
+                  <a:srgbClr val="FFFFFF"/>
+                </a:solidFill>
+                <a:latin typeface="Calibri" pitchFamily="34" charset="0"/>
+                <a:ea typeface="Calibri" pitchFamily="34" charset="-122"/>
+                <a:cs typeface="Calibri" pitchFamily="34" charset="-120"/>
+              </a:rPr>
+              <a:t>4</a:t>
+            </a:r>
+            <a:endParaRPr lang="en-US" sz="1800" dirty="0"/>
+          </a:p>
+        </p:txBody>
+      </p:sp>
+      <p:sp>
+        <p:nvSpPr>
+          <p:cNvPr id="29" name="Text 26"/>
+          <p:cNvSpPr txBox="1"/>
+          <p:nvPr/>
+        </p:nvSpPr>
+        <p:spPr>
+          <a:xfrm>
+            <a:off x="1371600" y="3840480"/>
+            <a:ext cx="10058400" cy="731520"/>
+          </a:xfrm>
+          <a:prstGeom prst="rect">
+            <a:avLst/>
+          </a:prstGeom>
+          <a:noFill/>
+          <a:ln/>
+        </p:spPr>
+        <p:txBody>
+          <a:bodyPr wrap="square" lIns="0" tIns="0" rIns="0" bIns="0" rtlCol="0" anchor="ctr"/>
+          <a:lstStyle/>
+          <a:p>
             <a:pPr indent="0" marL="0">
               <a:buNone/>
             </a:pPr>
@@ -15351,11 +15783,39 @@
                 <a:solidFill>
                   <a:srgbClr val="1E2761"/>
                 </a:solidFill>
-                <a:latin typeface="Calibri" pitchFamily="34" charset="0"/>
-                <a:ea typeface="Calibri" pitchFamily="34" charset="-122"/>
-                <a:cs typeface="Calibri" pitchFamily="34" charset="-120"/>
-              </a:rPr>
-              <a:t>ca. 20 000 000 · zahlt die Steuern</a:t>
+                <a:latin typeface="Cambria" pitchFamily="34" charset="0"/>
+                <a:ea typeface="Cambria" pitchFamily="34" charset="-122"/>
+                <a:cs typeface="Cambria" pitchFamily="34" charset="-120"/>
+              </a:rPr>
+              <a:t>Klerus und Adel zahlten </a:t>
+            </a:r>
+            <a:pPr indent="0" marL="0">
+              <a:buNone/>
+            </a:pPr>
+            <a:r>
+              <a:rPr lang="en-US" sz="2400" b="1" dirty="0">
+                <a:solidFill>
+                  <a:srgbClr val="2E9E6B"/>
+                </a:solidFill>
+                <a:latin typeface="Cambria" pitchFamily="34" charset="0"/>
+                <a:ea typeface="Cambria" pitchFamily="34" charset="-122"/>
+                <a:cs typeface="Cambria" pitchFamily="34" charset="-120"/>
+              </a:rPr>
+              <a:t>keine Steuern</a:t>
+            </a:r>
+            <a:pPr indent="0" marL="0">
+              <a:buNone/>
+            </a:pPr>
+            <a:r>
+              <a:rPr lang="en-US" sz="2400" dirty="0">
+                <a:solidFill>
+                  <a:srgbClr val="1E2761"/>
+                </a:solidFill>
+                <a:latin typeface="Cambria" pitchFamily="34" charset="0"/>
+                <a:ea typeface="Cambria" pitchFamily="34" charset="-122"/>
+                <a:cs typeface="Cambria" pitchFamily="34" charset="-120"/>
+              </a:rPr>
+              <a:t>.</a:t>
             </a:r>
             <a:endParaRPr lang="en-US" sz="2400" dirty="0"/>
           </a:p>
@@ -15363,7 +15823,119 @@
       </p:sp>
       <p:sp>
         <p:nvSpPr>
-          <p:cNvPr id="29" name="Shape 26"/>
+          <p:cNvPr id="30" name="Shape 27"/>
+          <p:cNvSpPr/>
+          <p:nvPr/>
+        </p:nvSpPr>
+        <p:spPr>
+          <a:xfrm>
+            <a:off x="777240" y="4709160"/>
+            <a:ext cx="365760" cy="365760"/>
+          </a:xfrm>
+          <a:prstGeom prst="ellipse">
+            <a:avLst/>
+          </a:prstGeom>
+          <a:solidFill>
+            <a:srgbClr val="1E2761"/>
+          </a:solidFill>
+          <a:ln/>
+        </p:spPr>
+      </p:sp>
+      <p:sp>
+        <p:nvSpPr>
+          <p:cNvPr id="31" name="Text 28"/>
+          <p:cNvSpPr txBox="1"/>
+          <p:nvPr/>
+        </p:nvSpPr>
+        <p:spPr>
+          <a:xfrm>
+            <a:off x="777240" y="4709160"/>
+            <a:ext cx="365760" cy="365760"/>
+          </a:xfrm>
+          <a:prstGeom prst="rect">
+            <a:avLst/>
+          </a:prstGeom>
+          <a:noFill/>
+          <a:ln/>
+        </p:spPr>
+        <p:txBody>
+          <a:bodyPr wrap="square" lIns="0" tIns="0" rIns="0" bIns="0" rtlCol="0" anchor="ctr"/>
+          <a:lstStyle/>
+          <a:p>
+            <a:pPr algn="ctr" indent="0" marL="0">
+              <a:buNone/>
+            </a:pPr>
+            <a:r>
+              <a:rPr lang="en-US" sz="1800" b="1" dirty="0">
+                <a:solidFill>
+                  <a:srgbClr val="FFFFFF"/>
+                </a:solidFill>
+                <a:latin typeface="Calibri" pitchFamily="34" charset="0"/>
+                <a:ea typeface="Calibri" pitchFamily="34" charset="-122"/>
+                <a:cs typeface="Calibri" pitchFamily="34" charset="-120"/>
+              </a:rPr>
+              <a:t>5</a:t>
+            </a:r>
+            <a:endParaRPr lang="en-US" sz="1800" dirty="0"/>
+          </a:p>
+        </p:txBody>
+      </p:sp>
+      <p:sp>
+        <p:nvSpPr>
+          <p:cNvPr id="32" name="Text 29"/>
+          <p:cNvSpPr txBox="1"/>
+          <p:nvPr/>
+        </p:nvSpPr>
+        <p:spPr>
+          <a:xfrm>
+            <a:off x="1371600" y="4617720"/>
+            <a:ext cx="10058400" cy="731520"/>
+          </a:xfrm>
+          <a:prstGeom prst="rect">
+            <a:avLst/>
+          </a:prstGeom>
+          <a:noFill/>
+          <a:ln/>
+        </p:spPr>
+        <p:txBody>
+          <a:bodyPr wrap="square" lIns="0" tIns="0" rIns="0" bIns="0" rtlCol="0" anchor="ctr"/>
+          <a:lstStyle/>
+          <a:p>
+            <a:pPr indent="0" marL="0">
+              <a:buNone/>
+            </a:pPr>
+            <a:r>
+              <a:rPr lang="en-US" sz="2400" dirty="0">
+                <a:solidFill>
+                  <a:srgbClr val="1E2761"/>
+                </a:solidFill>
+                <a:latin typeface="Cambria" pitchFamily="34" charset="0"/>
+                <a:ea typeface="Cambria" pitchFamily="34" charset="-122"/>
+                <a:cs typeface="Cambria" pitchFamily="34" charset="-120"/>
+              </a:rPr>
+              <a:t>Der Dritte Stand (Bauern und Bürger) hatte kaum Vorrechte. </a:t>
+            </a:r>
+            <a:pPr indent="0" marL="0">
+              <a:buNone/>
+            </a:pPr>
+            <a:r>
+              <a:rPr lang="en-US" sz="2400" i="1" dirty="0">
+                <a:solidFill>
+                  <a:srgbClr val="5B6B8C"/>
+                </a:solidFill>
+                <a:latin typeface="Cambria" pitchFamily="34" charset="0"/>
+                <a:ea typeface="Cambria" pitchFamily="34" charset="-122"/>
+                <a:cs typeface="Cambria" pitchFamily="34" charset="-120"/>
+              </a:rPr>
+              <a:t>(war richtig)</a:t>
+            </a:r>
+            <a:endParaRPr lang="en-US" sz="2400" dirty="0"/>
+          </a:p>
+        </p:txBody>
+      </p:sp>
+      <p:sp>
+        <p:nvSpPr>
+          <p:cNvPr id="33" name="Shape 30"/>
           <p:cNvSpPr/>
           <p:nvPr/>
         </p:nvSpPr>
@@ -15385,7 +15957,7 @@
       </p:sp>
       <p:sp>
         <p:nvSpPr>
-          <p:cNvPr id="30" name="Text 27"/>
+          <p:cNvPr id="34" name="Text 31"/>
           <p:cNvSpPr txBox="1"/>
           <p:nvPr/>
         </p:nvSpPr>

</xml_diff>